<commit_message>
Deck review: full-width architecture slide, BA-18 trap and TC-03 mutations on slide 6, new 'How I used AI tools' slide (15 slides)
BA-18 claim verified first: read-only probe, deployed CitationValidator rejects computed margins 1.4% / 1.43% / 'about 1.4 percent' (recorded in the spec). AI_TOOLING_LOG: the unlogged 686646f incident (YAML validation not gating the commit) added, 21 entries. TC-02 clarification on admin/integration-profile log access in the CSV, TC-02.md and the Test Protocol; REQ-19 unchanged.
</commit_message>
<xml_diff>
--- a/docs/Panel_Overview.pptx
+++ b/docs/Panel_Overview.pptx
@@ -19,6 +19,7 @@
     <p:sldId id="267" r:id="rId19"/>
     <p:sldId id="268" r:id="rId20"/>
     <p:sldId id="269" r:id="rId21"/>
+    <p:sldId id="270" r:id="rId22"/>
   </p:sldIdLst>
   <p:sldSz cx="12191695" cy="6858000" type="screen4x3"/>
   <p:notesSz cx="6858000" cy="9144000"/>
@@ -725,7 +726,7 @@
           <a:lstStyle/>
           <a:p>
             <a:r>
-              <a:t>Measured from 39 log rows; nothing was load-tested, and the full register in SCALABILITY_RISKS.md has 13 risks. The binding limits are inside the banker's own transaction: the template's grounding Apex adds about 5 SOQL and half a second of CPU per call, so the service processes at most 3 records per call and makes every LLM call before any DML. Latency: 3.1 to 9.9 seconds for a summary, median 7.2, 14.6 with a retry. Consumption doubles on a retry, so only invalid output and transient errors are retried. The log needs a retention policy because it holds raw client data. And the cross-client check loads at most 2,000 other names, so in a large book it is incomplete: that is now logged, and the proposed fix is to look up only the names in the question and answer. Two more to mention: concurrent long-running requests need a load test, and model lifecycle means a model change forces a full re-test.</a:t>
+              <a:t>I used Claude Code throughout, and I logged it honestly in AI_TOOLING_LOG.md: 21 entries, most of them where it misled me and how it was caught. Division of work: Claude Code wrote the Apex, tests, scripts, logs and documents; I designed the approach, reviewed every change, and did every UI step myself: objects in Setup, both templates in Prompt Builder, the agent in Agent Builder, and every agent test in the Lightning panel. Mistakes it made that we caught: its Agent Script snippet told the agent to format the link as markdown, which likely contributed to BA-13, where the agent wrote a link with the wrong meeting's Id. It named Apex variables url and id, which shadow the URL and Id types because Apex is case-insensitive; deploys failed and it fixed them. It ran the YAML validation and the commit on separate lines of one command, so a spec with a broken quote was committed and pushed (686646f) and fixed in the next commit; since then, commits only run after validation passes. And it described the citation check as "the selected client's own name is exempt", implying other clients' names were checked; they weren't until I asked, and the other-client check was then built and proven end to end. The safeguards are what make AI-written code acceptable here: diff the deployed agent against the intended script, evidence that post-dates the change, criteria committed before any test, and replay plus mutation so a validator is shown to fire, not just assumed to.</a:t>
             </a:r>
           </a:p>
         </p:txBody>
@@ -795,7 +796,7 @@
           <a:lstStyle/>
           <a:p>
             <a:r>
-              <a:t>This is what the SI copies. Five stages, each with a contract: the context builder returns source-tagged text in user mode with a budget; the template returns strict JSON from a frozen version; the validator assigns every rule to block, repair or offline; the fallback is deterministic and labelled; and every request logs one row. The shared kit is real code: AiActionSupport was extracted when Option B was built, so the second capability reused error classification, link building and logging instead of copying them. MockLlmGateway means tests never call the model. assertBankerFacing checks that every message is written to the banker, not to the agent. Per agent: add the action to the domain's existing subagent, apply the guard, generate the whole script and diff the deployed bundle, and keep holdouts unseen until the end. REUSABLE_PATTERN.md has the checklist and the anti-patterns with BUILD_LOG references.</a:t>
+              <a:t>Measured from 39 log rows; nothing was load-tested, and the full register in SCALABILITY_RISKS.md has 13 risks. The binding limits are inside the banker's own transaction: the template's grounding Apex adds about 5 SOQL and half a second of CPU per call, so the service processes at most 3 records per call and makes every LLM call before any DML. Latency: 3.1 to 9.9 seconds for a summary, median 7.2, 14.6 with a retry. Consumption doubles on a retry, so only invalid output and transient errors are retried. The log needs a retention policy because it holds raw client data. And the cross-client check loads at most 2,000 other names, so in a large book it is incomplete: that is now logged, and the proposed fix is to look up only the names in the question and answer. Two more to mention: concurrent long-running requests need a load test, and model lifecycle means a model change forces a full re-test.</a:t>
             </a:r>
           </a:p>
         </p:txBody>
@@ -865,6 +866,76 @@
           <a:lstStyle/>
           <a:p>
             <a:r>
+              <a:t>This is what the SI copies. Five stages, each with a contract: the context builder returns source-tagged text in user mode with a budget; the template returns strict JSON from a frozen version; the validator assigns every rule to block, repair or offline; the fallback is deterministic and labelled; and every request logs one row. The shared kit is real code: AiActionSupport was extracted when Option B was built, so the second capability reused error classification, link building and logging instead of copying them. MockLlmGateway means tests never call the model. assertBankerFacing checks that every message is written to the banker, not to the agent. Per agent: add the action to the domain's existing subagent, apply the guard, generate the whole script and diff the deployed bundle, and keep holdouts unseen until the end. REUSABLE_PATTERN.md has the checklist and the anti-patterns with BUILD_LOG references.</a:t>
+            </a:r>
+          </a:p>
+        </p:txBody>
+      </p:sp>
+      <p:sp>
+        <p:nvSpPr>
+          <p:cNvPr id="4" name="Slide Number Placeholder 3"/>
+          <p:cNvSpPr>
+            <a:spLocks noGrp="1"/>
+          </p:cNvSpPr>
+          <p:nvPr>
+            <p:ph type="sldNum" idx="5" sz="quarter"/>
+          </p:nvPr>
+        </p:nvSpPr>
+        <p:spPr/>
+      </p:sp>
+    </p:spTree>
+  </p:cSld>
+  <p:clrMapOvr>
+    <a:masterClrMapping/>
+  </p:clrMapOvr>
+</p:notes>
+</file>
+
+<file path=ppt/notesSlides/notesSlide15.xml><?xml version="1.0" encoding="utf-8"?>
+<p:notes xmlns:a="http://schemas.openxmlformats.org/drawingml/2006/main" xmlns:p="http://schemas.openxmlformats.org/presentationml/2006/main" xmlns:r="http://schemas.openxmlformats.org/officeDocument/2006/relationships">
+  <p:cSld>
+    <p:spTree>
+      <p:nvGrpSpPr>
+        <p:cNvPr id="1" name=""/>
+        <p:cNvGrpSpPr/>
+        <p:nvPr/>
+      </p:nvGrpSpPr>
+      <p:grpSpPr>
+        <a:xfrm>
+          <a:off x="0" y="0"/>
+          <a:ext cx="0" cy="0"/>
+          <a:chOff x="0" y="0"/>
+          <a:chExt cx="0" cy="0"/>
+        </a:xfrm>
+      </p:grpSpPr>
+      <p:sp>
+        <p:nvSpPr>
+          <p:cNvPr id="2" name="Slide Image Placeholder 1"/>
+          <p:cNvSpPr>
+            <a:spLocks noGrp="1"/>
+          </p:cNvSpPr>
+          <p:nvPr>
+            <p:ph type="sldImg" idx="2"/>
+          </p:nvPr>
+        </p:nvSpPr>
+        <p:spPr/>
+      </p:sp>
+      <p:sp>
+        <p:nvSpPr>
+          <p:cNvPr id="3" name="Notes Placeholder 2"/>
+          <p:cNvSpPr>
+            <a:spLocks noGrp="1"/>
+          </p:cNvSpPr>
+          <p:nvPr>
+            <p:ph type="body" idx="3" sz="quarter"/>
+          </p:nvPr>
+        </p:nvSpPr>
+        <p:spPr/>
+        <p:txBody>
+          <a:bodyPr/>
+          <a:lstStyle/>
+          <a:p>
+            <a:r>
               <a:t>Honest limits. The agent's LLM is the display layer: it can shorten validated text or replay an earlier result; the system of record is the meeting record, the PDF and the log, and the production fix is a custom Lightning Type renderer so the text shown is the text returned. Confirmation before regenerating is an instruction, not code. Wording and attribution are measured offline, not guaranteed at runtime. Closed deals and older meetings are not in the context. User mode is unit-tested but not shown end to end, because the Developer Edition org has public sharing on these objects. Next: execute the remaining test cases, including the first holdout runs; then the renderer, structured log fields, the name lookup, a load test with an async path, and closed deals in the context, each followed by a re-run of the test set. Questions.</a:t>
             </a:r>
           </a:p>
@@ -1215,7 +1286,7 @@
           <a:lstStyle/>
           <a:p>
             <a:r>
-              <a:t>Every validator rule is assigned a tier up front. Block: the output is invalid, so one plain retry of the same template, then the fallback; examples are a source id that isn't in the context, or an amount that isn't. Repair: code fixes it and the status says Repaired. Offline only: wording and attribution, which can't be checked at runtime and are measured on the test set. Two real examples from the GPT 5.4 runs. The repair: the model truncated "send buyer list (TB)" to "send buyer list" and named Tom Brennan as owner. Code finds the full clause in the notes and applies the owner rule: a trailing bracket like (TB) could be the requester or the recipient, so the owner is Unassigned. The block: one run returned invalid JSON; the service retries once. Code also adds what the prompt misses: the v4 prompt was tuned for precision and missed the Keel conflict in MTG-0019, so a deterministic amount-conflict check now adds it.</a:t>
+              <a:t>Every validator rule is assigned a tier up front. Block: the output is invalid, so one plain retry of the same template, then the fallback; examples are a source id that isn't in the context, or an amount or number that isn't in a cited source. Repair: code fixes it and the status says Repaired. Offline only: wording and attribution, which can't be checked at runtime and are measured on the test set. Three real examples. The repair, from the GPT 5.4 runs: the model truncated "send buyer list (TB)" to "send buyer list" and named Tom Brennan as owner. Code finds the full clause in the notes and applies the owner rule: a trailing bracket like (TB) could be the requester or the recipient, so the owner is Unassigned. The block: one GPT 5.4 run returned invalid JSON at column 2190, and the service retries once. To prove the checks fire, TC-03 mutates saved outputs: a fabricated $5B in a summary, and "Northwind is also a bidder" added to a Halverson answer. Both come back INVALID. The Q&amp;A trap, BA-18: "What's Halverson's EBITDA margin?" The context has division EBITDA of about $120mm and revenue of USD 8,400,000,000, so a model could divide them. It didn't: it answered Not answerable and listed both figures as what is missing. And if it had, the validator blocks it: on 2026-10-14 I fed the deployed validator answers stating 1.4%, 1.43% and "about 1.4 percent", citing both sources, and all three were INVALID because the number is not in a cited source. The positive side, BA-21: Northwind's 2.7x pro forma leverage was cited to the pitch deck research note it came from. Code also adds what the prompt misses: the v4 prompt was tuned for precision and missed the Keel conflict in MTG-0019, so a deterministic amount-conflict check adds it.</a:t>
             </a:r>
           </a:p>
         </p:txBody>
@@ -5935,7 +6006,7 @@
                 </a:solidFill>
                 <a:latin typeface="Calibri"/>
               </a:rPr>
-              <a:t>Scalability: top risks</a:t>
+              <a:t>How I used AI tools</a:t>
             </a:r>
           </a:p>
         </p:txBody>
@@ -6041,6 +6112,386 @@
                 <a:latin typeface="Calibri"/>
               </a:rPr>
               <a:t>12</a:t>
+            </a:r>
+          </a:p>
+        </p:txBody>
+      </p:sp>
+      <p:sp>
+        <p:nvSpPr>
+          <p:cNvPr id="7" name="TextBox 6"/>
+          <p:cNvSpPr txBox="1"/>
+          <p:nvPr/>
+        </p:nvSpPr>
+        <p:spPr>
+          <a:xfrm>
+            <a:off x="548640" y="1371600"/>
+            <a:ext cx="11064240" cy="4754880"/>
+          </a:xfrm>
+          <a:prstGeom prst="rect">
+            <a:avLst/>
+          </a:prstGeom>
+          <a:noFill/>
+        </p:spPr>
+        <p:txBody>
+          <a:bodyPr wrap="square">
+            <a:spAutoFit/>
+          </a:bodyPr>
+          <a:lstStyle/>
+          <a:p>
+            <a:pPr marL="274320" indent="-228600">
+              <a:spcAft>
+                <a:spcPts val="1400"/>
+              </a:spcAft>
+              <a:buChar char="•"/>
+            </a:pPr>
+            <a:r>
+              <a:rPr sz="2100" b="1" i="0">
+                <a:solidFill>
+                  <a:srgbClr val="1A1A1A"/>
+                </a:solidFill>
+                <a:latin typeface="Calibri"/>
+              </a:rPr>
+              <a:t>Claude Code built</a:t>
+            </a:r>
+            <a:r>
+              <a:rPr sz="2100" b="0" i="0">
+                <a:solidFill>
+                  <a:srgbClr val="1A1A1A"/>
+                </a:solidFill>
+                <a:latin typeface="Calibri"/>
+              </a:rPr>
+              <a:t> the Apex, tests, scripts, logs and these documents</a:t>
+            </a:r>
+          </a:p>
+          <a:p>
+            <a:pPr marL="274320" indent="-228600">
+              <a:spcAft>
+                <a:spcPts val="1400"/>
+              </a:spcAft>
+              <a:buChar char="•"/>
+            </a:pPr>
+            <a:r>
+              <a:rPr sz="2100" b="1" i="0">
+                <a:solidFill>
+                  <a:srgbClr val="1A1A1A"/>
+                </a:solidFill>
+                <a:latin typeface="Calibri"/>
+              </a:rPr>
+              <a:t>I designed, reviewed and ran</a:t>
+            </a:r>
+            <a:r>
+              <a:rPr sz="2100" b="0" i="0">
+                <a:solidFill>
+                  <a:srgbClr val="1A1A1A"/>
+                </a:solidFill>
+                <a:latin typeface="Calibri"/>
+              </a:rPr>
+              <a:t> every UI step: Setup, Prompt Builder, Agent Builder, agent tests</a:t>
+            </a:r>
+          </a:p>
+          <a:p>
+            <a:pPr marL="274320" indent="-228600">
+              <a:spcAft>
+                <a:spcPts val="1400"/>
+              </a:spcAft>
+              <a:buChar char="•"/>
+            </a:pPr>
+            <a:r>
+              <a:rPr sz="2100" b="1" i="0">
+                <a:solidFill>
+                  <a:srgbClr val="1A1A1A"/>
+                </a:solidFill>
+                <a:latin typeface="Calibri"/>
+              </a:rPr>
+              <a:t>Caught:</a:t>
+            </a:r>
+            <a:r>
+              <a:rPr sz="2100" b="0" i="0">
+                <a:solidFill>
+                  <a:srgbClr val="1A1A1A"/>
+                </a:solidFill>
+                <a:latin typeface="Calibri"/>
+              </a:rPr>
+              <a:t> a markdown-link snippet that led to the wrong-record link (BA-13)</a:t>
+            </a:r>
+          </a:p>
+          <a:p>
+            <a:pPr marL="274320" indent="-228600">
+              <a:spcAft>
+                <a:spcPts val="1400"/>
+              </a:spcAft>
+              <a:buChar char="•"/>
+            </a:pPr>
+            <a:r>
+              <a:rPr sz="2100" b="1" i="0">
+                <a:solidFill>
+                  <a:srgbClr val="1A1A1A"/>
+                </a:solidFill>
+                <a:latin typeface="Calibri"/>
+              </a:rPr>
+              <a:t>Caught:</a:t>
+            </a:r>
+            <a:r>
+              <a:rPr sz="2100" b="0" i="0">
+                <a:solidFill>
+                  <a:srgbClr val="1A1A1A"/>
+                </a:solidFill>
+                <a:latin typeface="Calibri"/>
+              </a:rPr>
+              <a:t> variables shadowing Apex types; a spec committed before its YAML check passed</a:t>
+            </a:r>
+          </a:p>
+          <a:p>
+            <a:pPr marL="274320" indent="-228600">
+              <a:spcAft>
+                <a:spcPts val="1400"/>
+              </a:spcAft>
+              <a:buChar char="•"/>
+            </a:pPr>
+            <a:r>
+              <a:rPr sz="2100" b="1" i="0">
+                <a:solidFill>
+                  <a:srgbClr val="1A1A1A"/>
+                </a:solidFill>
+                <a:latin typeface="Calibri"/>
+              </a:rPr>
+              <a:t>Caught:</a:t>
+            </a:r>
+            <a:r>
+              <a:rPr sz="2100" b="0" i="0">
+                <a:solidFill>
+                  <a:srgbClr val="1A1A1A"/>
+                </a:solidFill>
+                <a:latin typeface="Calibri"/>
+              </a:rPr>
+              <a:t> a claim that the name check covered other clients when it didn't</a:t>
+            </a:r>
+          </a:p>
+          <a:p>
+            <a:pPr marL="274320" indent="-228600">
+              <a:spcAft>
+                <a:spcPts val="1400"/>
+              </a:spcAft>
+              <a:buChar char="•"/>
+            </a:pPr>
+            <a:r>
+              <a:rPr sz="2100" b="1" i="0">
+                <a:solidFill>
+                  <a:srgbClr val="1A1A1A"/>
+                </a:solidFill>
+                <a:latin typeface="Calibri"/>
+              </a:rPr>
+              <a:t>Safeguards:</a:t>
+            </a:r>
+            <a:r>
+              <a:rPr sz="2100" b="0" i="0">
+                <a:solidFill>
+                  <a:srgbClr val="1A1A1A"/>
+                </a:solidFill>
+                <a:latin typeface="Calibri"/>
+              </a:rPr>
+              <a:t> bundle diffs, evidence after the change, pre-registration, replay + mutation</a:t>
+            </a:r>
+          </a:p>
+        </p:txBody>
+      </p:sp>
+    </p:spTree>
+  </p:cSld>
+  <p:clrMapOvr>
+    <a:masterClrMapping/>
+  </p:clrMapOvr>
+</p:sld>
+</file>
+
+<file path=ppt/slides/slide13.xml><?xml version="1.0" encoding="utf-8"?>
+<p:sld xmlns:a="http://schemas.openxmlformats.org/drawingml/2006/main" xmlns:p="http://schemas.openxmlformats.org/presentationml/2006/main" xmlns:r="http://schemas.openxmlformats.org/officeDocument/2006/relationships">
+  <p:cSld>
+    <p:spTree>
+      <p:nvGrpSpPr>
+        <p:cNvPr id="1" name=""/>
+        <p:cNvGrpSpPr/>
+        <p:nvPr/>
+      </p:nvGrpSpPr>
+      <p:grpSpPr/>
+      <p:sp>
+        <p:nvSpPr>
+          <p:cNvPr id="2" name="Rectangle 1"/>
+          <p:cNvSpPr/>
+          <p:nvPr/>
+        </p:nvSpPr>
+        <p:spPr>
+          <a:xfrm>
+            <a:off x="0" y="0"/>
+            <a:ext cx="164592" cy="6858000"/>
+          </a:xfrm>
+          <a:prstGeom prst="rect">
+            <a:avLst/>
+          </a:prstGeom>
+          <a:solidFill>
+            <a:srgbClr val="1F4E79"/>
+          </a:solidFill>
+          <a:ln>
+            <a:noFill/>
+          </a:ln>
+        </p:spPr>
+        <p:style>
+          <a:lnRef idx="1">
+            <a:schemeClr val="accent1"/>
+          </a:lnRef>
+          <a:fillRef idx="3">
+            <a:schemeClr val="accent1"/>
+          </a:fillRef>
+          <a:effectRef idx="2">
+            <a:schemeClr val="accent1"/>
+          </a:effectRef>
+          <a:fontRef idx="minor">
+            <a:schemeClr val="lt1"/>
+          </a:fontRef>
+        </p:style>
+        <p:txBody>
+          <a:bodyPr rtlCol="0" anchor="ctr"/>
+          <a:lstStyle/>
+          <a:p>
+            <a:pPr algn="ctr"/>
+          </a:p>
+        </p:txBody>
+      </p:sp>
+      <p:sp>
+        <p:nvSpPr>
+          <p:cNvPr id="3" name="TextBox 2"/>
+          <p:cNvSpPr txBox="1"/>
+          <p:nvPr/>
+        </p:nvSpPr>
+        <p:spPr>
+          <a:xfrm>
+            <a:off x="502920" y="320040"/>
+            <a:ext cx="11155680" cy="731520"/>
+          </a:xfrm>
+          <a:prstGeom prst="rect">
+            <a:avLst/>
+          </a:prstGeom>
+          <a:noFill/>
+        </p:spPr>
+        <p:txBody>
+          <a:bodyPr wrap="square" anchor="t" lIns="45720" rIns="45720">
+            <a:spAutoFit/>
+          </a:bodyPr>
+          <a:lstStyle/>
+          <a:p>
+            <a:pPr algn="l"/>
+            <a:r>
+              <a:rPr sz="3000" b="1" i="0">
+                <a:solidFill>
+                  <a:srgbClr val="1F4E79"/>
+                </a:solidFill>
+                <a:latin typeface="Calibri"/>
+              </a:rPr>
+              <a:t>Scalability: top risks</a:t>
+            </a:r>
+          </a:p>
+        </p:txBody>
+      </p:sp>
+      <p:cxnSp>
+        <p:nvCxnSpPr>
+          <p:cNvPr id="4" name="Connector 3"/>
+          <p:cNvCxnSpPr/>
+          <p:nvPr/>
+        </p:nvCxnSpPr>
+        <p:spPr>
+          <a:xfrm>
+            <a:off x="548640" y="1051560"/>
+            <a:ext cx="11109960" cy="0"/>
+          </a:xfrm>
+          <a:prstGeom prst="line">
+            <a:avLst/>
+          </a:prstGeom>
+          <a:ln w="12700">
+            <a:solidFill>
+              <a:srgbClr val="BFBFBF"/>
+            </a:solidFill>
+          </a:ln>
+        </p:spPr>
+        <p:style>
+          <a:lnRef idx="2">
+            <a:schemeClr val="accent1"/>
+          </a:lnRef>
+          <a:fillRef idx="0">
+            <a:schemeClr val="accent1"/>
+          </a:fillRef>
+          <a:effectRef idx="1">
+            <a:schemeClr val="accent1"/>
+          </a:effectRef>
+          <a:fontRef idx="minor">
+            <a:schemeClr val="tx1"/>
+          </a:fontRef>
+        </p:style>
+      </p:cxnSp>
+      <p:sp>
+        <p:nvSpPr>
+          <p:cNvPr id="5" name="TextBox 4"/>
+          <p:cNvSpPr txBox="1"/>
+          <p:nvPr/>
+        </p:nvSpPr>
+        <p:spPr>
+          <a:xfrm>
+            <a:off x="502920" y="6400800"/>
+            <a:ext cx="7315200" cy="320040"/>
+          </a:xfrm>
+          <a:prstGeom prst="rect">
+            <a:avLst/>
+          </a:prstGeom>
+          <a:noFill/>
+        </p:spPr>
+        <p:txBody>
+          <a:bodyPr wrap="square" anchor="t" lIns="45720" rIns="45720">
+            <a:spAutoFit/>
+          </a:bodyPr>
+          <a:lstStyle/>
+          <a:p>
+            <a:pPr algn="l"/>
+            <a:r>
+              <a:rPr sz="1000" b="0" i="0">
+                <a:solidFill>
+                  <a:srgbClr val="595959"/>
+                </a:solidFill>
+                <a:latin typeface="Calibri"/>
+              </a:rPr>
+              <a:t>Agentforce Banking Reference Implementation</a:t>
+            </a:r>
+          </a:p>
+        </p:txBody>
+      </p:sp>
+      <p:sp>
+        <p:nvSpPr>
+          <p:cNvPr id="6" name="TextBox 5"/>
+          <p:cNvSpPr txBox="1"/>
+          <p:nvPr/>
+        </p:nvSpPr>
+        <p:spPr>
+          <a:xfrm>
+            <a:off x="10698480" y="6400800"/>
+            <a:ext cx="1005840" cy="320040"/>
+          </a:xfrm>
+          <a:prstGeom prst="rect">
+            <a:avLst/>
+          </a:prstGeom>
+          <a:noFill/>
+        </p:spPr>
+        <p:txBody>
+          <a:bodyPr wrap="square" anchor="t" lIns="45720" rIns="45720">
+            <a:spAutoFit/>
+          </a:bodyPr>
+          <a:lstStyle/>
+          <a:p>
+            <a:pPr algn="r"/>
+            <a:r>
+              <a:rPr sz="1000" b="0" i="0">
+                <a:solidFill>
+                  <a:srgbClr val="595959"/>
+                </a:solidFill>
+                <a:latin typeface="Calibri"/>
+              </a:rPr>
+              <a:t>13</a:t>
             </a:r>
           </a:p>
         </p:txBody>
@@ -6355,988 +6806,6 @@
 </p:sld>
 </file>
 
-<file path=ppt/slides/slide13.xml><?xml version="1.0" encoding="utf-8"?>
-<p:sld xmlns:a="http://schemas.openxmlformats.org/drawingml/2006/main" xmlns:p="http://schemas.openxmlformats.org/presentationml/2006/main" xmlns:r="http://schemas.openxmlformats.org/officeDocument/2006/relationships">
-  <p:cSld>
-    <p:spTree>
-      <p:nvGrpSpPr>
-        <p:cNvPr id="1" name=""/>
-        <p:cNvGrpSpPr/>
-        <p:nvPr/>
-      </p:nvGrpSpPr>
-      <p:grpSpPr/>
-      <p:sp>
-        <p:nvSpPr>
-          <p:cNvPr id="2" name="Rectangle 1"/>
-          <p:cNvSpPr/>
-          <p:nvPr/>
-        </p:nvSpPr>
-        <p:spPr>
-          <a:xfrm>
-            <a:off x="0" y="0"/>
-            <a:ext cx="164592" cy="6858000"/>
-          </a:xfrm>
-          <a:prstGeom prst="rect">
-            <a:avLst/>
-          </a:prstGeom>
-          <a:solidFill>
-            <a:srgbClr val="1F4E79"/>
-          </a:solidFill>
-          <a:ln>
-            <a:noFill/>
-          </a:ln>
-        </p:spPr>
-        <p:style>
-          <a:lnRef idx="1">
-            <a:schemeClr val="accent1"/>
-          </a:lnRef>
-          <a:fillRef idx="3">
-            <a:schemeClr val="accent1"/>
-          </a:fillRef>
-          <a:effectRef idx="2">
-            <a:schemeClr val="accent1"/>
-          </a:effectRef>
-          <a:fontRef idx="minor">
-            <a:schemeClr val="lt1"/>
-          </a:fontRef>
-        </p:style>
-        <p:txBody>
-          <a:bodyPr rtlCol="0" anchor="ctr"/>
-          <a:lstStyle/>
-          <a:p>
-            <a:pPr algn="ctr"/>
-          </a:p>
-        </p:txBody>
-      </p:sp>
-      <p:sp>
-        <p:nvSpPr>
-          <p:cNvPr id="3" name="TextBox 2"/>
-          <p:cNvSpPr txBox="1"/>
-          <p:nvPr/>
-        </p:nvSpPr>
-        <p:spPr>
-          <a:xfrm>
-            <a:off x="502920" y="320040"/>
-            <a:ext cx="11155680" cy="731520"/>
-          </a:xfrm>
-          <a:prstGeom prst="rect">
-            <a:avLst/>
-          </a:prstGeom>
-          <a:noFill/>
-        </p:spPr>
-        <p:txBody>
-          <a:bodyPr wrap="square" anchor="t" lIns="45720" rIns="45720">
-            <a:spAutoFit/>
-          </a:bodyPr>
-          <a:lstStyle/>
-          <a:p>
-            <a:pPr algn="l"/>
-            <a:r>
-              <a:rPr sz="3000" b="1" i="0">
-                <a:solidFill>
-                  <a:srgbClr val="1F4E79"/>
-                </a:solidFill>
-                <a:latin typeface="Calibri"/>
-              </a:rPr>
-              <a:t>Reusable pattern for the 30+ agent backlog</a:t>
-            </a:r>
-          </a:p>
-        </p:txBody>
-      </p:sp>
-      <p:cxnSp>
-        <p:nvCxnSpPr>
-          <p:cNvPr id="4" name="Connector 3"/>
-          <p:cNvCxnSpPr/>
-          <p:nvPr/>
-        </p:nvCxnSpPr>
-        <p:spPr>
-          <a:xfrm>
-            <a:off x="548640" y="1051560"/>
-            <a:ext cx="11109960" cy="0"/>
-          </a:xfrm>
-          <a:prstGeom prst="line">
-            <a:avLst/>
-          </a:prstGeom>
-          <a:ln w="12700">
-            <a:solidFill>
-              <a:srgbClr val="BFBFBF"/>
-            </a:solidFill>
-          </a:ln>
-        </p:spPr>
-        <p:style>
-          <a:lnRef idx="2">
-            <a:schemeClr val="accent1"/>
-          </a:lnRef>
-          <a:fillRef idx="0">
-            <a:schemeClr val="accent1"/>
-          </a:fillRef>
-          <a:effectRef idx="1">
-            <a:schemeClr val="accent1"/>
-          </a:effectRef>
-          <a:fontRef idx="minor">
-            <a:schemeClr val="tx1"/>
-          </a:fontRef>
-        </p:style>
-      </p:cxnSp>
-      <p:sp>
-        <p:nvSpPr>
-          <p:cNvPr id="5" name="TextBox 4"/>
-          <p:cNvSpPr txBox="1"/>
-          <p:nvPr/>
-        </p:nvSpPr>
-        <p:spPr>
-          <a:xfrm>
-            <a:off x="502920" y="6400800"/>
-            <a:ext cx="7315200" cy="320040"/>
-          </a:xfrm>
-          <a:prstGeom prst="rect">
-            <a:avLst/>
-          </a:prstGeom>
-          <a:noFill/>
-        </p:spPr>
-        <p:txBody>
-          <a:bodyPr wrap="square" anchor="t" lIns="45720" rIns="45720">
-            <a:spAutoFit/>
-          </a:bodyPr>
-          <a:lstStyle/>
-          <a:p>
-            <a:pPr algn="l"/>
-            <a:r>
-              <a:rPr sz="1000" b="0" i="0">
-                <a:solidFill>
-                  <a:srgbClr val="595959"/>
-                </a:solidFill>
-                <a:latin typeface="Calibri"/>
-              </a:rPr>
-              <a:t>Agentforce Banking Reference Implementation</a:t>
-            </a:r>
-          </a:p>
-        </p:txBody>
-      </p:sp>
-      <p:sp>
-        <p:nvSpPr>
-          <p:cNvPr id="6" name="TextBox 5"/>
-          <p:cNvSpPr txBox="1"/>
-          <p:nvPr/>
-        </p:nvSpPr>
-        <p:spPr>
-          <a:xfrm>
-            <a:off x="10698480" y="6400800"/>
-            <a:ext cx="1005840" cy="320040"/>
-          </a:xfrm>
-          <a:prstGeom prst="rect">
-            <a:avLst/>
-          </a:prstGeom>
-          <a:noFill/>
-        </p:spPr>
-        <p:txBody>
-          <a:bodyPr wrap="square" anchor="t" lIns="45720" rIns="45720">
-            <a:spAutoFit/>
-          </a:bodyPr>
-          <a:lstStyle/>
-          <a:p>
-            <a:pPr algn="r"/>
-            <a:r>
-              <a:rPr sz="1000" b="0" i="0">
-                <a:solidFill>
-                  <a:srgbClr val="595959"/>
-                </a:solidFill>
-                <a:latin typeface="Calibri"/>
-              </a:rPr>
-              <a:t>13</a:t>
-            </a:r>
-          </a:p>
-        </p:txBody>
-      </p:sp>
-      <p:sp>
-        <p:nvSpPr>
-          <p:cNvPr id="7" name="Pentagon 6"/>
-          <p:cNvSpPr/>
-          <p:nvPr/>
-        </p:nvSpPr>
-        <p:spPr>
-          <a:xfrm>
-            <a:off x="548640" y="1371600"/>
-            <a:ext cx="2148840" cy="731520"/>
-          </a:xfrm>
-          <a:prstGeom prst="homePlate">
-            <a:avLst/>
-          </a:prstGeom>
-          <a:solidFill>
-            <a:srgbClr val="1F4E79"/>
-          </a:solidFill>
-          <a:ln>
-            <a:noFill/>
-          </a:ln>
-        </p:spPr>
-        <p:style>
-          <a:lnRef idx="1">
-            <a:schemeClr val="accent1"/>
-          </a:lnRef>
-          <a:fillRef idx="3">
-            <a:schemeClr val="accent1"/>
-          </a:fillRef>
-          <a:effectRef idx="2">
-            <a:schemeClr val="accent1"/>
-          </a:effectRef>
-          <a:fontRef idx="minor">
-            <a:schemeClr val="lt1"/>
-          </a:fontRef>
-        </p:style>
-        <p:txBody>
-          <a:bodyPr rtlCol="0" anchor="ctr"/>
-          <a:lstStyle/>
-          <a:p>
-            <a:pPr algn="ctr"/>
-            <a:r>
-              <a:rPr sz="1600" b="1" i="0">
-                <a:solidFill>
-                  <a:srgbClr val="FFFFFF"/>
-                </a:solidFill>
-                <a:latin typeface="Calibri"/>
-              </a:rPr>
-              <a:t>Context</a:t>
-            </a:r>
-          </a:p>
-        </p:txBody>
-      </p:sp>
-      <p:sp>
-        <p:nvSpPr>
-          <p:cNvPr id="8" name="TextBox 7"/>
-          <p:cNvSpPr txBox="1"/>
-          <p:nvPr/>
-        </p:nvSpPr>
-        <p:spPr>
-          <a:xfrm>
-            <a:off x="640080" y="2194560"/>
-            <a:ext cx="2011680" cy="731520"/>
-          </a:xfrm>
-          <a:prstGeom prst="rect">
-            <a:avLst/>
-          </a:prstGeom>
-          <a:noFill/>
-        </p:spPr>
-        <p:txBody>
-          <a:bodyPr wrap="square" anchor="t" lIns="45720" rIns="45720">
-            <a:spAutoFit/>
-          </a:bodyPr>
-          <a:lstStyle/>
-          <a:p>
-            <a:pPr algn="l"/>
-            <a:r>
-              <a:rPr sz="1400" b="0" i="0">
-                <a:solidFill>
-                  <a:srgbClr val="1A1A1A"/>
-                </a:solidFill>
-                <a:latin typeface="Calibri"/>
-              </a:rPr>
-              <a:t>User mode, source ids, budget</a:t>
-            </a:r>
-          </a:p>
-        </p:txBody>
-      </p:sp>
-      <p:sp>
-        <p:nvSpPr>
-          <p:cNvPr id="9" name="Chevron 8"/>
-          <p:cNvSpPr/>
-          <p:nvPr/>
-        </p:nvSpPr>
-        <p:spPr>
-          <a:xfrm>
-            <a:off x="2788920" y="1371600"/>
-            <a:ext cx="2148840" cy="731520"/>
-          </a:xfrm>
-          <a:prstGeom prst="chevron">
-            <a:avLst/>
-          </a:prstGeom>
-          <a:solidFill>
-            <a:srgbClr val="1F4E79"/>
-          </a:solidFill>
-          <a:ln>
-            <a:noFill/>
-          </a:ln>
-        </p:spPr>
-        <p:style>
-          <a:lnRef idx="1">
-            <a:schemeClr val="accent1"/>
-          </a:lnRef>
-          <a:fillRef idx="3">
-            <a:schemeClr val="accent1"/>
-          </a:fillRef>
-          <a:effectRef idx="2">
-            <a:schemeClr val="accent1"/>
-          </a:effectRef>
-          <a:fontRef idx="minor">
-            <a:schemeClr val="lt1"/>
-          </a:fontRef>
-        </p:style>
-        <p:txBody>
-          <a:bodyPr rtlCol="0" anchor="ctr"/>
-          <a:lstStyle/>
-          <a:p>
-            <a:pPr algn="ctr"/>
-            <a:r>
-              <a:rPr sz="1600" b="1" i="0">
-                <a:solidFill>
-                  <a:srgbClr val="FFFFFF"/>
-                </a:solidFill>
-                <a:latin typeface="Calibri"/>
-              </a:rPr>
-              <a:t>Template</a:t>
-            </a:r>
-          </a:p>
-        </p:txBody>
-      </p:sp>
-      <p:sp>
-        <p:nvSpPr>
-          <p:cNvPr id="10" name="TextBox 9"/>
-          <p:cNvSpPr txBox="1"/>
-          <p:nvPr/>
-        </p:nvSpPr>
-        <p:spPr>
-          <a:xfrm>
-            <a:off x="2880360" y="2194560"/>
-            <a:ext cx="2011680" cy="731520"/>
-          </a:xfrm>
-          <a:prstGeom prst="rect">
-            <a:avLst/>
-          </a:prstGeom>
-          <a:noFill/>
-        </p:spPr>
-        <p:txBody>
-          <a:bodyPr wrap="square" anchor="t" lIns="45720" rIns="45720">
-            <a:spAutoFit/>
-          </a:bodyPr>
-          <a:lstStyle/>
-          <a:p>
-            <a:pPr algn="l"/>
-            <a:r>
-              <a:rPr sz="1400" b="0" i="0">
-                <a:solidFill>
-                  <a:srgbClr val="1A1A1A"/>
-                </a:solidFill>
-                <a:latin typeface="Calibri"/>
-              </a:rPr>
-              <a:t>Strict JSON, frozen version</a:t>
-            </a:r>
-          </a:p>
-        </p:txBody>
-      </p:sp>
-      <p:sp>
-        <p:nvSpPr>
-          <p:cNvPr id="11" name="Chevron 10"/>
-          <p:cNvSpPr/>
-          <p:nvPr/>
-        </p:nvSpPr>
-        <p:spPr>
-          <a:xfrm>
-            <a:off x="5029200" y="1371600"/>
-            <a:ext cx="2148840" cy="731520"/>
-          </a:xfrm>
-          <a:prstGeom prst="chevron">
-            <a:avLst/>
-          </a:prstGeom>
-          <a:solidFill>
-            <a:srgbClr val="1F4E79"/>
-          </a:solidFill>
-          <a:ln>
-            <a:noFill/>
-          </a:ln>
-        </p:spPr>
-        <p:style>
-          <a:lnRef idx="1">
-            <a:schemeClr val="accent1"/>
-          </a:lnRef>
-          <a:fillRef idx="3">
-            <a:schemeClr val="accent1"/>
-          </a:fillRef>
-          <a:effectRef idx="2">
-            <a:schemeClr val="accent1"/>
-          </a:effectRef>
-          <a:fontRef idx="minor">
-            <a:schemeClr val="lt1"/>
-          </a:fontRef>
-        </p:style>
-        <p:txBody>
-          <a:bodyPr rtlCol="0" anchor="ctr"/>
-          <a:lstStyle/>
-          <a:p>
-            <a:pPr algn="ctr"/>
-            <a:r>
-              <a:rPr sz="1600" b="1" i="0">
-                <a:solidFill>
-                  <a:srgbClr val="FFFFFF"/>
-                </a:solidFill>
-                <a:latin typeface="Calibri"/>
-              </a:rPr>
-              <a:t>Validate</a:t>
-            </a:r>
-          </a:p>
-        </p:txBody>
-      </p:sp>
-      <p:sp>
-        <p:nvSpPr>
-          <p:cNvPr id="12" name="TextBox 11"/>
-          <p:cNvSpPr txBox="1"/>
-          <p:nvPr/>
-        </p:nvSpPr>
-        <p:spPr>
-          <a:xfrm>
-            <a:off x="5120640" y="2194560"/>
-            <a:ext cx="2011680" cy="731520"/>
-          </a:xfrm>
-          <a:prstGeom prst="rect">
-            <a:avLst/>
-          </a:prstGeom>
-          <a:noFill/>
-        </p:spPr>
-        <p:txBody>
-          <a:bodyPr wrap="square" anchor="t" lIns="45720" rIns="45720">
-            <a:spAutoFit/>
-          </a:bodyPr>
-          <a:lstStyle/>
-          <a:p>
-            <a:pPr algn="l"/>
-            <a:r>
-              <a:rPr sz="1400" b="0" i="0">
-                <a:solidFill>
-                  <a:srgbClr val="1A1A1A"/>
-                </a:solidFill>
-                <a:latin typeface="Calibri"/>
-              </a:rPr>
-              <a:t>Block, repair, offline</a:t>
-            </a:r>
-          </a:p>
-        </p:txBody>
-      </p:sp>
-      <p:sp>
-        <p:nvSpPr>
-          <p:cNvPr id="13" name="Chevron 12"/>
-          <p:cNvSpPr/>
-          <p:nvPr/>
-        </p:nvSpPr>
-        <p:spPr>
-          <a:xfrm>
-            <a:off x="7269480" y="1371600"/>
-            <a:ext cx="2148840" cy="731520"/>
-          </a:xfrm>
-          <a:prstGeom prst="chevron">
-            <a:avLst/>
-          </a:prstGeom>
-          <a:solidFill>
-            <a:srgbClr val="1F4E79"/>
-          </a:solidFill>
-          <a:ln>
-            <a:noFill/>
-          </a:ln>
-        </p:spPr>
-        <p:style>
-          <a:lnRef idx="1">
-            <a:schemeClr val="accent1"/>
-          </a:lnRef>
-          <a:fillRef idx="3">
-            <a:schemeClr val="accent1"/>
-          </a:fillRef>
-          <a:effectRef idx="2">
-            <a:schemeClr val="accent1"/>
-          </a:effectRef>
-          <a:fontRef idx="minor">
-            <a:schemeClr val="lt1"/>
-          </a:fontRef>
-        </p:style>
-        <p:txBody>
-          <a:bodyPr rtlCol="0" anchor="ctr"/>
-          <a:lstStyle/>
-          <a:p>
-            <a:pPr algn="ctr"/>
-            <a:r>
-              <a:rPr sz="1600" b="1" i="0">
-                <a:solidFill>
-                  <a:srgbClr val="FFFFFF"/>
-                </a:solidFill>
-                <a:latin typeface="Calibri"/>
-              </a:rPr>
-              <a:t>Fallback</a:t>
-            </a:r>
-          </a:p>
-        </p:txBody>
-      </p:sp>
-      <p:sp>
-        <p:nvSpPr>
-          <p:cNvPr id="14" name="TextBox 13"/>
-          <p:cNvSpPr txBox="1"/>
-          <p:nvPr/>
-        </p:nvSpPr>
-        <p:spPr>
-          <a:xfrm>
-            <a:off x="7360920" y="2194560"/>
-            <a:ext cx="2011680" cy="731520"/>
-          </a:xfrm>
-          <a:prstGeom prst="rect">
-            <a:avLst/>
-          </a:prstGeom>
-          <a:noFill/>
-        </p:spPr>
-        <p:txBody>
-          <a:bodyPr wrap="square" anchor="t" lIns="45720" rIns="45720">
-            <a:spAutoFit/>
-          </a:bodyPr>
-          <a:lstStyle/>
-          <a:p>
-            <a:pPr algn="l"/>
-            <a:r>
-              <a:rPr sz="1400" b="0" i="0">
-                <a:solidFill>
-                  <a:srgbClr val="1A1A1A"/>
-                </a:solidFill>
-                <a:latin typeface="Calibri"/>
-              </a:rPr>
-              <a:t>Labelled, deterministic</a:t>
-            </a:r>
-          </a:p>
-        </p:txBody>
-      </p:sp>
-      <p:sp>
-        <p:nvSpPr>
-          <p:cNvPr id="15" name="Chevron 14"/>
-          <p:cNvSpPr/>
-          <p:nvPr/>
-        </p:nvSpPr>
-        <p:spPr>
-          <a:xfrm>
-            <a:off x="9509760" y="1371600"/>
-            <a:ext cx="2148840" cy="731520"/>
-          </a:xfrm>
-          <a:prstGeom prst="chevron">
-            <a:avLst/>
-          </a:prstGeom>
-          <a:solidFill>
-            <a:srgbClr val="1F4E79"/>
-          </a:solidFill>
-          <a:ln>
-            <a:noFill/>
-          </a:ln>
-        </p:spPr>
-        <p:style>
-          <a:lnRef idx="1">
-            <a:schemeClr val="accent1"/>
-          </a:lnRef>
-          <a:fillRef idx="3">
-            <a:schemeClr val="accent1"/>
-          </a:fillRef>
-          <a:effectRef idx="2">
-            <a:schemeClr val="accent1"/>
-          </a:effectRef>
-          <a:fontRef idx="minor">
-            <a:schemeClr val="lt1"/>
-          </a:fontRef>
-        </p:style>
-        <p:txBody>
-          <a:bodyPr rtlCol="0" anchor="ctr"/>
-          <a:lstStyle/>
-          <a:p>
-            <a:pPr algn="ctr"/>
-            <a:r>
-              <a:rPr sz="1600" b="1" i="0">
-                <a:solidFill>
-                  <a:srgbClr val="FFFFFF"/>
-                </a:solidFill>
-                <a:latin typeface="Calibri"/>
-              </a:rPr>
-              <a:t>Log</a:t>
-            </a:r>
-          </a:p>
-        </p:txBody>
-      </p:sp>
-      <p:sp>
-        <p:nvSpPr>
-          <p:cNvPr id="16" name="TextBox 15"/>
-          <p:cNvSpPr txBox="1"/>
-          <p:nvPr/>
-        </p:nvSpPr>
-        <p:spPr>
-          <a:xfrm>
-            <a:off x="9601200" y="2194560"/>
-            <a:ext cx="2011680" cy="731520"/>
-          </a:xfrm>
-          <a:prstGeom prst="rect">
-            <a:avLst/>
-          </a:prstGeom>
-          <a:noFill/>
-        </p:spPr>
-        <p:txBody>
-          <a:bodyPr wrap="square" anchor="t" lIns="45720" rIns="45720">
-            <a:spAutoFit/>
-          </a:bodyPr>
-          <a:lstStyle/>
-          <a:p>
-            <a:pPr algn="l"/>
-            <a:r>
-              <a:rPr sz="1400" b="0" i="0">
-                <a:solidFill>
-                  <a:srgbClr val="1A1A1A"/>
-                </a:solidFill>
-                <a:latin typeface="Calibri"/>
-              </a:rPr>
-              <a:t>One row per request</a:t>
-            </a:r>
-          </a:p>
-        </p:txBody>
-      </p:sp>
-      <p:sp>
-        <p:nvSpPr>
-          <p:cNvPr id="17" name="Rounded Rectangle 16"/>
-          <p:cNvSpPr/>
-          <p:nvPr/>
-        </p:nvSpPr>
-        <p:spPr>
-          <a:xfrm>
-            <a:off x="548640" y="3154680"/>
-            <a:ext cx="5440680" cy="2743200"/>
-          </a:xfrm>
-          <a:prstGeom prst="roundRect">
-            <a:avLst>
-              <a:gd name="adj" fmla="val 6000"/>
-            </a:avLst>
-          </a:prstGeom>
-          <a:solidFill>
-            <a:srgbClr val="EAF1F8"/>
-          </a:solidFill>
-          <a:ln w="15875">
-            <a:solidFill>
-              <a:srgbClr val="1F4E79"/>
-            </a:solidFill>
-          </a:ln>
-        </p:spPr>
-        <p:style>
-          <a:lnRef idx="1">
-            <a:schemeClr val="accent1"/>
-          </a:lnRef>
-          <a:fillRef idx="3">
-            <a:schemeClr val="accent1"/>
-          </a:fillRef>
-          <a:effectRef idx="2">
-            <a:schemeClr val="accent1"/>
-          </a:effectRef>
-          <a:fontRef idx="minor">
-            <a:schemeClr val="lt1"/>
-          </a:fontRef>
-        </p:style>
-        <p:txBody>
-          <a:bodyPr rtlCol="0" anchor="ctr"/>
-          <a:lstStyle/>
-          <a:p>
-            <a:pPr algn="ctr"/>
-          </a:p>
-        </p:txBody>
-      </p:sp>
-      <p:sp>
-        <p:nvSpPr>
-          <p:cNvPr id="18" name="TextBox 17"/>
-          <p:cNvSpPr txBox="1"/>
-          <p:nvPr/>
-        </p:nvSpPr>
-        <p:spPr>
-          <a:xfrm>
-            <a:off x="685800" y="3264408"/>
-            <a:ext cx="5166360" cy="457200"/>
-          </a:xfrm>
-          <a:prstGeom prst="rect">
-            <a:avLst/>
-          </a:prstGeom>
-          <a:noFill/>
-        </p:spPr>
-        <p:txBody>
-          <a:bodyPr wrap="square" anchor="t" lIns="45720" rIns="45720">
-            <a:spAutoFit/>
-          </a:bodyPr>
-          <a:lstStyle/>
-          <a:p>
-            <a:pPr algn="l"/>
-            <a:r>
-              <a:rPr sz="2100" b="1" i="0">
-                <a:solidFill>
-                  <a:srgbClr val="1F4E79"/>
-                </a:solidFill>
-                <a:latin typeface="Calibri"/>
-              </a:rPr>
-              <a:t>Shared kit</a:t>
-            </a:r>
-          </a:p>
-        </p:txBody>
-      </p:sp>
-      <p:sp>
-        <p:nvSpPr>
-          <p:cNvPr id="19" name="TextBox 18"/>
-          <p:cNvSpPr txBox="1"/>
-          <p:nvPr/>
-        </p:nvSpPr>
-        <p:spPr>
-          <a:xfrm>
-            <a:off x="640080" y="3749040"/>
-            <a:ext cx="5257800" cy="2057400"/>
-          </a:xfrm>
-          <a:prstGeom prst="rect">
-            <a:avLst/>
-          </a:prstGeom>
-          <a:noFill/>
-        </p:spPr>
-        <p:txBody>
-          <a:bodyPr wrap="square">
-            <a:spAutoFit/>
-          </a:bodyPr>
-          <a:lstStyle/>
-          <a:p>
-            <a:pPr marL="274320" indent="-228600">
-              <a:spcAft>
-                <a:spcPts val="600"/>
-              </a:spcAft>
-              <a:buChar char="•"/>
-            </a:pPr>
-            <a:r>
-              <a:rPr sz="1900" b="0" i="0">
-                <a:solidFill>
-                  <a:srgbClr val="1A1A1A"/>
-                </a:solidFill>
-                <a:latin typeface="Calibri"/>
-              </a:rPr>
-              <a:t>AiActionSupport: errors, links, logs</a:t>
-            </a:r>
-          </a:p>
-          <a:p>
-            <a:pPr marL="274320" indent="-228600">
-              <a:spcAft>
-                <a:spcPts val="600"/>
-              </a:spcAft>
-              <a:buChar char="•"/>
-            </a:pPr>
-            <a:r>
-              <a:rPr sz="1900" b="0" i="0">
-                <a:solidFill>
-                  <a:srgbClr val="1A1A1A"/>
-                </a:solidFill>
-                <a:latin typeface="Calibri"/>
-              </a:rPr>
-              <a:t>ILlmGateway + MockLlmGateway</a:t>
-            </a:r>
-          </a:p>
-          <a:p>
-            <a:pPr marL="274320" indent="-228600">
-              <a:spcAft>
-                <a:spcPts val="600"/>
-              </a:spcAft>
-              <a:buChar char="•"/>
-            </a:pPr>
-            <a:r>
-              <a:rPr sz="1900" b="0" i="0">
-                <a:solidFill>
-                  <a:srgbClr val="1A1A1A"/>
-                </a:solidFill>
-                <a:latin typeface="Calibri"/>
-              </a:rPr>
-              <a:t>assertBankerFacing on every path</a:t>
-            </a:r>
-          </a:p>
-          <a:p>
-            <a:pPr marL="274320" indent="-228600">
-              <a:spcAft>
-                <a:spcPts val="600"/>
-              </a:spcAft>
-              <a:buChar char="•"/>
-            </a:pPr>
-            <a:r>
-              <a:rPr sz="1900" b="0" i="0">
-                <a:solidFill>
-                  <a:srgbClr val="1A1A1A"/>
-                </a:solidFill>
-                <a:latin typeface="Calibri"/>
-              </a:rPr>
-              <a:t>Replay + mutation scripts</a:t>
-            </a:r>
-          </a:p>
-        </p:txBody>
-      </p:sp>
-      <p:sp>
-        <p:nvSpPr>
-          <p:cNvPr id="20" name="Rounded Rectangle 19"/>
-          <p:cNvSpPr/>
-          <p:nvPr/>
-        </p:nvSpPr>
-        <p:spPr>
-          <a:xfrm>
-            <a:off x="6217920" y="3154680"/>
-            <a:ext cx="5440680" cy="2743200"/>
-          </a:xfrm>
-          <a:prstGeom prst="roundRect">
-            <a:avLst>
-              <a:gd name="adj" fmla="val 6000"/>
-            </a:avLst>
-          </a:prstGeom>
-          <a:solidFill>
-            <a:srgbClr val="EAF1F8"/>
-          </a:solidFill>
-          <a:ln w="15875">
-            <a:solidFill>
-              <a:srgbClr val="1F4E79"/>
-            </a:solidFill>
-          </a:ln>
-        </p:spPr>
-        <p:style>
-          <a:lnRef idx="1">
-            <a:schemeClr val="accent1"/>
-          </a:lnRef>
-          <a:fillRef idx="3">
-            <a:schemeClr val="accent1"/>
-          </a:fillRef>
-          <a:effectRef idx="2">
-            <a:schemeClr val="accent1"/>
-          </a:effectRef>
-          <a:fontRef idx="minor">
-            <a:schemeClr val="lt1"/>
-          </a:fontRef>
-        </p:style>
-        <p:txBody>
-          <a:bodyPr rtlCol="0" anchor="ctr"/>
-          <a:lstStyle/>
-          <a:p>
-            <a:pPr algn="ctr"/>
-          </a:p>
-        </p:txBody>
-      </p:sp>
-      <p:sp>
-        <p:nvSpPr>
-          <p:cNvPr id="21" name="TextBox 20"/>
-          <p:cNvSpPr txBox="1"/>
-          <p:nvPr/>
-        </p:nvSpPr>
-        <p:spPr>
-          <a:xfrm>
-            <a:off x="6355080" y="3264408"/>
-            <a:ext cx="5166360" cy="457200"/>
-          </a:xfrm>
-          <a:prstGeom prst="rect">
-            <a:avLst/>
-          </a:prstGeom>
-          <a:noFill/>
-        </p:spPr>
-        <p:txBody>
-          <a:bodyPr wrap="square" anchor="t" lIns="45720" rIns="45720">
-            <a:spAutoFit/>
-          </a:bodyPr>
-          <a:lstStyle/>
-          <a:p>
-            <a:pPr algn="l"/>
-            <a:r>
-              <a:rPr sz="2100" b="1" i="0">
-                <a:solidFill>
-                  <a:srgbClr val="1F4E79"/>
-                </a:solidFill>
-                <a:latin typeface="Calibri"/>
-              </a:rPr>
-              <a:t>Per-agent rules</a:t>
-            </a:r>
-          </a:p>
-        </p:txBody>
-      </p:sp>
-      <p:sp>
-        <p:nvSpPr>
-          <p:cNvPr id="22" name="TextBox 21"/>
-          <p:cNvSpPr txBox="1"/>
-          <p:nvPr/>
-        </p:nvSpPr>
-        <p:spPr>
-          <a:xfrm>
-            <a:off x="6309360" y="3749040"/>
-            <a:ext cx="5257800" cy="2057400"/>
-          </a:xfrm>
-          <a:prstGeom prst="rect">
-            <a:avLst/>
-          </a:prstGeom>
-          <a:noFill/>
-        </p:spPr>
-        <p:txBody>
-          <a:bodyPr wrap="square">
-            <a:spAutoFit/>
-          </a:bodyPr>
-          <a:lstStyle/>
-          <a:p>
-            <a:pPr marL="274320" indent="-228600">
-              <a:spcAft>
-                <a:spcPts val="600"/>
-              </a:spcAft>
-              <a:buChar char="•"/>
-            </a:pPr>
-            <a:r>
-              <a:rPr sz="1900" b="0" i="0">
-                <a:solidFill>
-                  <a:srgbClr val="1A1A1A"/>
-                </a:solidFill>
-                <a:latin typeface="Calibri"/>
-              </a:rPr>
-              <a:t>Action in the domain's subagent</a:t>
-            </a:r>
-          </a:p>
-          <a:p>
-            <a:pPr marL="274320" indent="-228600">
-              <a:spcAft>
-                <a:spcPts val="600"/>
-              </a:spcAft>
-              <a:buChar char="•"/>
-            </a:pPr>
-            <a:r>
-              <a:rPr sz="1900" b="0" i="0">
-                <a:solidFill>
-                  <a:srgbClr val="1A1A1A"/>
-                </a:solidFill>
-                <a:latin typeface="Calibri"/>
-              </a:rPr>
-              <a:t>Guard: set, available, bound, cleared</a:t>
-            </a:r>
-          </a:p>
-          <a:p>
-            <a:pPr marL="274320" indent="-228600">
-              <a:spcAft>
-                <a:spcPts val="600"/>
-              </a:spcAft>
-              <a:buChar char="•"/>
-            </a:pPr>
-            <a:r>
-              <a:rPr sz="1900" b="0" i="0">
-                <a:solidFill>
-                  <a:srgbClr val="1A1A1A"/>
-                </a:solidFill>
-                <a:latin typeface="Calibri"/>
-              </a:rPr>
-              <a:t>Generate the full script; diff the bundle</a:t>
-            </a:r>
-          </a:p>
-          <a:p>
-            <a:pPr marL="274320" indent="-228600">
-              <a:spcAft>
-                <a:spcPts val="600"/>
-              </a:spcAft>
-              <a:buChar char="•"/>
-            </a:pPr>
-            <a:r>
-              <a:rPr sz="1900" b="0" i="0">
-                <a:solidFill>
-                  <a:srgbClr val="1A1A1A"/>
-                </a:solidFill>
-                <a:latin typeface="Calibri"/>
-              </a:rPr>
-              <a:t>Holdouts run once, at the end</a:t>
-            </a:r>
-          </a:p>
-        </p:txBody>
-      </p:sp>
-    </p:spTree>
-  </p:cSld>
-  <p:clrMapOvr>
-    <a:masterClrMapping/>
-  </p:clrMapOvr>
-</p:sld>
-</file>
-
 <file path=ppt/slides/slide14.xml><?xml version="1.0" encoding="utf-8"?>
 <p:sld xmlns:a="http://schemas.openxmlformats.org/drawingml/2006/main" xmlns:p="http://schemas.openxmlformats.org/presentationml/2006/main" xmlns:r="http://schemas.openxmlformats.org/officeDocument/2006/relationships">
   <p:cSld>
@@ -7420,7 +6889,7 @@
                 </a:solidFill>
                 <a:latin typeface="Calibri"/>
               </a:rPr>
-              <a:t>Known limitations and next steps</a:t>
+              <a:t>Reusable pattern for the 30+ agent backlog</a:t>
             </a:r>
           </a:p>
         </p:txBody>
@@ -7526,6 +6995,988 @@
                 <a:latin typeface="Calibri"/>
               </a:rPr>
               <a:t>14</a:t>
+            </a:r>
+          </a:p>
+        </p:txBody>
+      </p:sp>
+      <p:sp>
+        <p:nvSpPr>
+          <p:cNvPr id="7" name="Pentagon 6"/>
+          <p:cNvSpPr/>
+          <p:nvPr/>
+        </p:nvSpPr>
+        <p:spPr>
+          <a:xfrm>
+            <a:off x="548640" y="1371600"/>
+            <a:ext cx="2148840" cy="731520"/>
+          </a:xfrm>
+          <a:prstGeom prst="homePlate">
+            <a:avLst/>
+          </a:prstGeom>
+          <a:solidFill>
+            <a:srgbClr val="1F4E79"/>
+          </a:solidFill>
+          <a:ln>
+            <a:noFill/>
+          </a:ln>
+        </p:spPr>
+        <p:style>
+          <a:lnRef idx="1">
+            <a:schemeClr val="accent1"/>
+          </a:lnRef>
+          <a:fillRef idx="3">
+            <a:schemeClr val="accent1"/>
+          </a:fillRef>
+          <a:effectRef idx="2">
+            <a:schemeClr val="accent1"/>
+          </a:effectRef>
+          <a:fontRef idx="minor">
+            <a:schemeClr val="lt1"/>
+          </a:fontRef>
+        </p:style>
+        <p:txBody>
+          <a:bodyPr rtlCol="0" anchor="ctr"/>
+          <a:lstStyle/>
+          <a:p>
+            <a:pPr algn="ctr"/>
+            <a:r>
+              <a:rPr sz="1600" b="1" i="0">
+                <a:solidFill>
+                  <a:srgbClr val="FFFFFF"/>
+                </a:solidFill>
+                <a:latin typeface="Calibri"/>
+              </a:rPr>
+              <a:t>Context</a:t>
+            </a:r>
+          </a:p>
+        </p:txBody>
+      </p:sp>
+      <p:sp>
+        <p:nvSpPr>
+          <p:cNvPr id="8" name="TextBox 7"/>
+          <p:cNvSpPr txBox="1"/>
+          <p:nvPr/>
+        </p:nvSpPr>
+        <p:spPr>
+          <a:xfrm>
+            <a:off x="640080" y="2194560"/>
+            <a:ext cx="2011680" cy="731520"/>
+          </a:xfrm>
+          <a:prstGeom prst="rect">
+            <a:avLst/>
+          </a:prstGeom>
+          <a:noFill/>
+        </p:spPr>
+        <p:txBody>
+          <a:bodyPr wrap="square" anchor="t" lIns="45720" rIns="45720">
+            <a:spAutoFit/>
+          </a:bodyPr>
+          <a:lstStyle/>
+          <a:p>
+            <a:pPr algn="l"/>
+            <a:r>
+              <a:rPr sz="1400" b="0" i="0">
+                <a:solidFill>
+                  <a:srgbClr val="1A1A1A"/>
+                </a:solidFill>
+                <a:latin typeface="Calibri"/>
+              </a:rPr>
+              <a:t>User mode, source ids, budget</a:t>
+            </a:r>
+          </a:p>
+        </p:txBody>
+      </p:sp>
+      <p:sp>
+        <p:nvSpPr>
+          <p:cNvPr id="9" name="Chevron 8"/>
+          <p:cNvSpPr/>
+          <p:nvPr/>
+        </p:nvSpPr>
+        <p:spPr>
+          <a:xfrm>
+            <a:off x="2788920" y="1371600"/>
+            <a:ext cx="2148840" cy="731520"/>
+          </a:xfrm>
+          <a:prstGeom prst="chevron">
+            <a:avLst/>
+          </a:prstGeom>
+          <a:solidFill>
+            <a:srgbClr val="1F4E79"/>
+          </a:solidFill>
+          <a:ln>
+            <a:noFill/>
+          </a:ln>
+        </p:spPr>
+        <p:style>
+          <a:lnRef idx="1">
+            <a:schemeClr val="accent1"/>
+          </a:lnRef>
+          <a:fillRef idx="3">
+            <a:schemeClr val="accent1"/>
+          </a:fillRef>
+          <a:effectRef idx="2">
+            <a:schemeClr val="accent1"/>
+          </a:effectRef>
+          <a:fontRef idx="minor">
+            <a:schemeClr val="lt1"/>
+          </a:fontRef>
+        </p:style>
+        <p:txBody>
+          <a:bodyPr rtlCol="0" anchor="ctr"/>
+          <a:lstStyle/>
+          <a:p>
+            <a:pPr algn="ctr"/>
+            <a:r>
+              <a:rPr sz="1600" b="1" i="0">
+                <a:solidFill>
+                  <a:srgbClr val="FFFFFF"/>
+                </a:solidFill>
+                <a:latin typeface="Calibri"/>
+              </a:rPr>
+              <a:t>Template</a:t>
+            </a:r>
+          </a:p>
+        </p:txBody>
+      </p:sp>
+      <p:sp>
+        <p:nvSpPr>
+          <p:cNvPr id="10" name="TextBox 9"/>
+          <p:cNvSpPr txBox="1"/>
+          <p:nvPr/>
+        </p:nvSpPr>
+        <p:spPr>
+          <a:xfrm>
+            <a:off x="2880360" y="2194560"/>
+            <a:ext cx="2011680" cy="731520"/>
+          </a:xfrm>
+          <a:prstGeom prst="rect">
+            <a:avLst/>
+          </a:prstGeom>
+          <a:noFill/>
+        </p:spPr>
+        <p:txBody>
+          <a:bodyPr wrap="square" anchor="t" lIns="45720" rIns="45720">
+            <a:spAutoFit/>
+          </a:bodyPr>
+          <a:lstStyle/>
+          <a:p>
+            <a:pPr algn="l"/>
+            <a:r>
+              <a:rPr sz="1400" b="0" i="0">
+                <a:solidFill>
+                  <a:srgbClr val="1A1A1A"/>
+                </a:solidFill>
+                <a:latin typeface="Calibri"/>
+              </a:rPr>
+              <a:t>Strict JSON, frozen version</a:t>
+            </a:r>
+          </a:p>
+        </p:txBody>
+      </p:sp>
+      <p:sp>
+        <p:nvSpPr>
+          <p:cNvPr id="11" name="Chevron 10"/>
+          <p:cNvSpPr/>
+          <p:nvPr/>
+        </p:nvSpPr>
+        <p:spPr>
+          <a:xfrm>
+            <a:off x="5029200" y="1371600"/>
+            <a:ext cx="2148840" cy="731520"/>
+          </a:xfrm>
+          <a:prstGeom prst="chevron">
+            <a:avLst/>
+          </a:prstGeom>
+          <a:solidFill>
+            <a:srgbClr val="1F4E79"/>
+          </a:solidFill>
+          <a:ln>
+            <a:noFill/>
+          </a:ln>
+        </p:spPr>
+        <p:style>
+          <a:lnRef idx="1">
+            <a:schemeClr val="accent1"/>
+          </a:lnRef>
+          <a:fillRef idx="3">
+            <a:schemeClr val="accent1"/>
+          </a:fillRef>
+          <a:effectRef idx="2">
+            <a:schemeClr val="accent1"/>
+          </a:effectRef>
+          <a:fontRef idx="minor">
+            <a:schemeClr val="lt1"/>
+          </a:fontRef>
+        </p:style>
+        <p:txBody>
+          <a:bodyPr rtlCol="0" anchor="ctr"/>
+          <a:lstStyle/>
+          <a:p>
+            <a:pPr algn="ctr"/>
+            <a:r>
+              <a:rPr sz="1600" b="1" i="0">
+                <a:solidFill>
+                  <a:srgbClr val="FFFFFF"/>
+                </a:solidFill>
+                <a:latin typeface="Calibri"/>
+              </a:rPr>
+              <a:t>Validate</a:t>
+            </a:r>
+          </a:p>
+        </p:txBody>
+      </p:sp>
+      <p:sp>
+        <p:nvSpPr>
+          <p:cNvPr id="12" name="TextBox 11"/>
+          <p:cNvSpPr txBox="1"/>
+          <p:nvPr/>
+        </p:nvSpPr>
+        <p:spPr>
+          <a:xfrm>
+            <a:off x="5120640" y="2194560"/>
+            <a:ext cx="2011680" cy="731520"/>
+          </a:xfrm>
+          <a:prstGeom prst="rect">
+            <a:avLst/>
+          </a:prstGeom>
+          <a:noFill/>
+        </p:spPr>
+        <p:txBody>
+          <a:bodyPr wrap="square" anchor="t" lIns="45720" rIns="45720">
+            <a:spAutoFit/>
+          </a:bodyPr>
+          <a:lstStyle/>
+          <a:p>
+            <a:pPr algn="l"/>
+            <a:r>
+              <a:rPr sz="1400" b="0" i="0">
+                <a:solidFill>
+                  <a:srgbClr val="1A1A1A"/>
+                </a:solidFill>
+                <a:latin typeface="Calibri"/>
+              </a:rPr>
+              <a:t>Block, repair, offline</a:t>
+            </a:r>
+          </a:p>
+        </p:txBody>
+      </p:sp>
+      <p:sp>
+        <p:nvSpPr>
+          <p:cNvPr id="13" name="Chevron 12"/>
+          <p:cNvSpPr/>
+          <p:nvPr/>
+        </p:nvSpPr>
+        <p:spPr>
+          <a:xfrm>
+            <a:off x="7269480" y="1371600"/>
+            <a:ext cx="2148840" cy="731520"/>
+          </a:xfrm>
+          <a:prstGeom prst="chevron">
+            <a:avLst/>
+          </a:prstGeom>
+          <a:solidFill>
+            <a:srgbClr val="1F4E79"/>
+          </a:solidFill>
+          <a:ln>
+            <a:noFill/>
+          </a:ln>
+        </p:spPr>
+        <p:style>
+          <a:lnRef idx="1">
+            <a:schemeClr val="accent1"/>
+          </a:lnRef>
+          <a:fillRef idx="3">
+            <a:schemeClr val="accent1"/>
+          </a:fillRef>
+          <a:effectRef idx="2">
+            <a:schemeClr val="accent1"/>
+          </a:effectRef>
+          <a:fontRef idx="minor">
+            <a:schemeClr val="lt1"/>
+          </a:fontRef>
+        </p:style>
+        <p:txBody>
+          <a:bodyPr rtlCol="0" anchor="ctr"/>
+          <a:lstStyle/>
+          <a:p>
+            <a:pPr algn="ctr"/>
+            <a:r>
+              <a:rPr sz="1600" b="1" i="0">
+                <a:solidFill>
+                  <a:srgbClr val="FFFFFF"/>
+                </a:solidFill>
+                <a:latin typeface="Calibri"/>
+              </a:rPr>
+              <a:t>Fallback</a:t>
+            </a:r>
+          </a:p>
+        </p:txBody>
+      </p:sp>
+      <p:sp>
+        <p:nvSpPr>
+          <p:cNvPr id="14" name="TextBox 13"/>
+          <p:cNvSpPr txBox="1"/>
+          <p:nvPr/>
+        </p:nvSpPr>
+        <p:spPr>
+          <a:xfrm>
+            <a:off x="7360920" y="2194560"/>
+            <a:ext cx="2011680" cy="731520"/>
+          </a:xfrm>
+          <a:prstGeom prst="rect">
+            <a:avLst/>
+          </a:prstGeom>
+          <a:noFill/>
+        </p:spPr>
+        <p:txBody>
+          <a:bodyPr wrap="square" anchor="t" lIns="45720" rIns="45720">
+            <a:spAutoFit/>
+          </a:bodyPr>
+          <a:lstStyle/>
+          <a:p>
+            <a:pPr algn="l"/>
+            <a:r>
+              <a:rPr sz="1400" b="0" i="0">
+                <a:solidFill>
+                  <a:srgbClr val="1A1A1A"/>
+                </a:solidFill>
+                <a:latin typeface="Calibri"/>
+              </a:rPr>
+              <a:t>Labelled, deterministic</a:t>
+            </a:r>
+          </a:p>
+        </p:txBody>
+      </p:sp>
+      <p:sp>
+        <p:nvSpPr>
+          <p:cNvPr id="15" name="Chevron 14"/>
+          <p:cNvSpPr/>
+          <p:nvPr/>
+        </p:nvSpPr>
+        <p:spPr>
+          <a:xfrm>
+            <a:off x="9509760" y="1371600"/>
+            <a:ext cx="2148840" cy="731520"/>
+          </a:xfrm>
+          <a:prstGeom prst="chevron">
+            <a:avLst/>
+          </a:prstGeom>
+          <a:solidFill>
+            <a:srgbClr val="1F4E79"/>
+          </a:solidFill>
+          <a:ln>
+            <a:noFill/>
+          </a:ln>
+        </p:spPr>
+        <p:style>
+          <a:lnRef idx="1">
+            <a:schemeClr val="accent1"/>
+          </a:lnRef>
+          <a:fillRef idx="3">
+            <a:schemeClr val="accent1"/>
+          </a:fillRef>
+          <a:effectRef idx="2">
+            <a:schemeClr val="accent1"/>
+          </a:effectRef>
+          <a:fontRef idx="minor">
+            <a:schemeClr val="lt1"/>
+          </a:fontRef>
+        </p:style>
+        <p:txBody>
+          <a:bodyPr rtlCol="0" anchor="ctr"/>
+          <a:lstStyle/>
+          <a:p>
+            <a:pPr algn="ctr"/>
+            <a:r>
+              <a:rPr sz="1600" b="1" i="0">
+                <a:solidFill>
+                  <a:srgbClr val="FFFFFF"/>
+                </a:solidFill>
+                <a:latin typeface="Calibri"/>
+              </a:rPr>
+              <a:t>Log</a:t>
+            </a:r>
+          </a:p>
+        </p:txBody>
+      </p:sp>
+      <p:sp>
+        <p:nvSpPr>
+          <p:cNvPr id="16" name="TextBox 15"/>
+          <p:cNvSpPr txBox="1"/>
+          <p:nvPr/>
+        </p:nvSpPr>
+        <p:spPr>
+          <a:xfrm>
+            <a:off x="9601200" y="2194560"/>
+            <a:ext cx="2011680" cy="731520"/>
+          </a:xfrm>
+          <a:prstGeom prst="rect">
+            <a:avLst/>
+          </a:prstGeom>
+          <a:noFill/>
+        </p:spPr>
+        <p:txBody>
+          <a:bodyPr wrap="square" anchor="t" lIns="45720" rIns="45720">
+            <a:spAutoFit/>
+          </a:bodyPr>
+          <a:lstStyle/>
+          <a:p>
+            <a:pPr algn="l"/>
+            <a:r>
+              <a:rPr sz="1400" b="0" i="0">
+                <a:solidFill>
+                  <a:srgbClr val="1A1A1A"/>
+                </a:solidFill>
+                <a:latin typeface="Calibri"/>
+              </a:rPr>
+              <a:t>One row per request</a:t>
+            </a:r>
+          </a:p>
+        </p:txBody>
+      </p:sp>
+      <p:sp>
+        <p:nvSpPr>
+          <p:cNvPr id="17" name="Rounded Rectangle 16"/>
+          <p:cNvSpPr/>
+          <p:nvPr/>
+        </p:nvSpPr>
+        <p:spPr>
+          <a:xfrm>
+            <a:off x="548640" y="3154680"/>
+            <a:ext cx="5440680" cy="2743200"/>
+          </a:xfrm>
+          <a:prstGeom prst="roundRect">
+            <a:avLst>
+              <a:gd name="adj" fmla="val 6000"/>
+            </a:avLst>
+          </a:prstGeom>
+          <a:solidFill>
+            <a:srgbClr val="EAF1F8"/>
+          </a:solidFill>
+          <a:ln w="15875">
+            <a:solidFill>
+              <a:srgbClr val="1F4E79"/>
+            </a:solidFill>
+          </a:ln>
+        </p:spPr>
+        <p:style>
+          <a:lnRef idx="1">
+            <a:schemeClr val="accent1"/>
+          </a:lnRef>
+          <a:fillRef idx="3">
+            <a:schemeClr val="accent1"/>
+          </a:fillRef>
+          <a:effectRef idx="2">
+            <a:schemeClr val="accent1"/>
+          </a:effectRef>
+          <a:fontRef idx="minor">
+            <a:schemeClr val="lt1"/>
+          </a:fontRef>
+        </p:style>
+        <p:txBody>
+          <a:bodyPr rtlCol="0" anchor="ctr"/>
+          <a:lstStyle/>
+          <a:p>
+            <a:pPr algn="ctr"/>
+          </a:p>
+        </p:txBody>
+      </p:sp>
+      <p:sp>
+        <p:nvSpPr>
+          <p:cNvPr id="18" name="TextBox 17"/>
+          <p:cNvSpPr txBox="1"/>
+          <p:nvPr/>
+        </p:nvSpPr>
+        <p:spPr>
+          <a:xfrm>
+            <a:off x="685800" y="3264408"/>
+            <a:ext cx="5166360" cy="457200"/>
+          </a:xfrm>
+          <a:prstGeom prst="rect">
+            <a:avLst/>
+          </a:prstGeom>
+          <a:noFill/>
+        </p:spPr>
+        <p:txBody>
+          <a:bodyPr wrap="square" anchor="t" lIns="45720" rIns="45720">
+            <a:spAutoFit/>
+          </a:bodyPr>
+          <a:lstStyle/>
+          <a:p>
+            <a:pPr algn="l"/>
+            <a:r>
+              <a:rPr sz="2100" b="1" i="0">
+                <a:solidFill>
+                  <a:srgbClr val="1F4E79"/>
+                </a:solidFill>
+                <a:latin typeface="Calibri"/>
+              </a:rPr>
+              <a:t>Shared kit</a:t>
+            </a:r>
+          </a:p>
+        </p:txBody>
+      </p:sp>
+      <p:sp>
+        <p:nvSpPr>
+          <p:cNvPr id="19" name="TextBox 18"/>
+          <p:cNvSpPr txBox="1"/>
+          <p:nvPr/>
+        </p:nvSpPr>
+        <p:spPr>
+          <a:xfrm>
+            <a:off x="640080" y="3749040"/>
+            <a:ext cx="5257800" cy="2057400"/>
+          </a:xfrm>
+          <a:prstGeom prst="rect">
+            <a:avLst/>
+          </a:prstGeom>
+          <a:noFill/>
+        </p:spPr>
+        <p:txBody>
+          <a:bodyPr wrap="square">
+            <a:spAutoFit/>
+          </a:bodyPr>
+          <a:lstStyle/>
+          <a:p>
+            <a:pPr marL="274320" indent="-228600">
+              <a:spcAft>
+                <a:spcPts val="600"/>
+              </a:spcAft>
+              <a:buChar char="•"/>
+            </a:pPr>
+            <a:r>
+              <a:rPr sz="1900" b="0" i="0">
+                <a:solidFill>
+                  <a:srgbClr val="1A1A1A"/>
+                </a:solidFill>
+                <a:latin typeface="Calibri"/>
+              </a:rPr>
+              <a:t>AiActionSupport: errors, links, logs</a:t>
+            </a:r>
+          </a:p>
+          <a:p>
+            <a:pPr marL="274320" indent="-228600">
+              <a:spcAft>
+                <a:spcPts val="600"/>
+              </a:spcAft>
+              <a:buChar char="•"/>
+            </a:pPr>
+            <a:r>
+              <a:rPr sz="1900" b="0" i="0">
+                <a:solidFill>
+                  <a:srgbClr val="1A1A1A"/>
+                </a:solidFill>
+                <a:latin typeface="Calibri"/>
+              </a:rPr>
+              <a:t>ILlmGateway + MockLlmGateway</a:t>
+            </a:r>
+          </a:p>
+          <a:p>
+            <a:pPr marL="274320" indent="-228600">
+              <a:spcAft>
+                <a:spcPts val="600"/>
+              </a:spcAft>
+              <a:buChar char="•"/>
+            </a:pPr>
+            <a:r>
+              <a:rPr sz="1900" b="0" i="0">
+                <a:solidFill>
+                  <a:srgbClr val="1A1A1A"/>
+                </a:solidFill>
+                <a:latin typeface="Calibri"/>
+              </a:rPr>
+              <a:t>assertBankerFacing on every path</a:t>
+            </a:r>
+          </a:p>
+          <a:p>
+            <a:pPr marL="274320" indent="-228600">
+              <a:spcAft>
+                <a:spcPts val="600"/>
+              </a:spcAft>
+              <a:buChar char="•"/>
+            </a:pPr>
+            <a:r>
+              <a:rPr sz="1900" b="0" i="0">
+                <a:solidFill>
+                  <a:srgbClr val="1A1A1A"/>
+                </a:solidFill>
+                <a:latin typeface="Calibri"/>
+              </a:rPr>
+              <a:t>Replay + mutation scripts</a:t>
+            </a:r>
+          </a:p>
+        </p:txBody>
+      </p:sp>
+      <p:sp>
+        <p:nvSpPr>
+          <p:cNvPr id="20" name="Rounded Rectangle 19"/>
+          <p:cNvSpPr/>
+          <p:nvPr/>
+        </p:nvSpPr>
+        <p:spPr>
+          <a:xfrm>
+            <a:off x="6217920" y="3154680"/>
+            <a:ext cx="5440680" cy="2743200"/>
+          </a:xfrm>
+          <a:prstGeom prst="roundRect">
+            <a:avLst>
+              <a:gd name="adj" fmla="val 6000"/>
+            </a:avLst>
+          </a:prstGeom>
+          <a:solidFill>
+            <a:srgbClr val="EAF1F8"/>
+          </a:solidFill>
+          <a:ln w="15875">
+            <a:solidFill>
+              <a:srgbClr val="1F4E79"/>
+            </a:solidFill>
+          </a:ln>
+        </p:spPr>
+        <p:style>
+          <a:lnRef idx="1">
+            <a:schemeClr val="accent1"/>
+          </a:lnRef>
+          <a:fillRef idx="3">
+            <a:schemeClr val="accent1"/>
+          </a:fillRef>
+          <a:effectRef idx="2">
+            <a:schemeClr val="accent1"/>
+          </a:effectRef>
+          <a:fontRef idx="minor">
+            <a:schemeClr val="lt1"/>
+          </a:fontRef>
+        </p:style>
+        <p:txBody>
+          <a:bodyPr rtlCol="0" anchor="ctr"/>
+          <a:lstStyle/>
+          <a:p>
+            <a:pPr algn="ctr"/>
+          </a:p>
+        </p:txBody>
+      </p:sp>
+      <p:sp>
+        <p:nvSpPr>
+          <p:cNvPr id="21" name="TextBox 20"/>
+          <p:cNvSpPr txBox="1"/>
+          <p:nvPr/>
+        </p:nvSpPr>
+        <p:spPr>
+          <a:xfrm>
+            <a:off x="6355080" y="3264408"/>
+            <a:ext cx="5166360" cy="457200"/>
+          </a:xfrm>
+          <a:prstGeom prst="rect">
+            <a:avLst/>
+          </a:prstGeom>
+          <a:noFill/>
+        </p:spPr>
+        <p:txBody>
+          <a:bodyPr wrap="square" anchor="t" lIns="45720" rIns="45720">
+            <a:spAutoFit/>
+          </a:bodyPr>
+          <a:lstStyle/>
+          <a:p>
+            <a:pPr algn="l"/>
+            <a:r>
+              <a:rPr sz="2100" b="1" i="0">
+                <a:solidFill>
+                  <a:srgbClr val="1F4E79"/>
+                </a:solidFill>
+                <a:latin typeface="Calibri"/>
+              </a:rPr>
+              <a:t>Per-agent rules</a:t>
+            </a:r>
+          </a:p>
+        </p:txBody>
+      </p:sp>
+      <p:sp>
+        <p:nvSpPr>
+          <p:cNvPr id="22" name="TextBox 21"/>
+          <p:cNvSpPr txBox="1"/>
+          <p:nvPr/>
+        </p:nvSpPr>
+        <p:spPr>
+          <a:xfrm>
+            <a:off x="6309360" y="3749040"/>
+            <a:ext cx="5257800" cy="2057400"/>
+          </a:xfrm>
+          <a:prstGeom prst="rect">
+            <a:avLst/>
+          </a:prstGeom>
+          <a:noFill/>
+        </p:spPr>
+        <p:txBody>
+          <a:bodyPr wrap="square">
+            <a:spAutoFit/>
+          </a:bodyPr>
+          <a:lstStyle/>
+          <a:p>
+            <a:pPr marL="274320" indent="-228600">
+              <a:spcAft>
+                <a:spcPts val="600"/>
+              </a:spcAft>
+              <a:buChar char="•"/>
+            </a:pPr>
+            <a:r>
+              <a:rPr sz="1900" b="0" i="0">
+                <a:solidFill>
+                  <a:srgbClr val="1A1A1A"/>
+                </a:solidFill>
+                <a:latin typeface="Calibri"/>
+              </a:rPr>
+              <a:t>Action in the domain's subagent</a:t>
+            </a:r>
+          </a:p>
+          <a:p>
+            <a:pPr marL="274320" indent="-228600">
+              <a:spcAft>
+                <a:spcPts val="600"/>
+              </a:spcAft>
+              <a:buChar char="•"/>
+            </a:pPr>
+            <a:r>
+              <a:rPr sz="1900" b="0" i="0">
+                <a:solidFill>
+                  <a:srgbClr val="1A1A1A"/>
+                </a:solidFill>
+                <a:latin typeface="Calibri"/>
+              </a:rPr>
+              <a:t>Guard: set, available, bound, cleared</a:t>
+            </a:r>
+          </a:p>
+          <a:p>
+            <a:pPr marL="274320" indent="-228600">
+              <a:spcAft>
+                <a:spcPts val="600"/>
+              </a:spcAft>
+              <a:buChar char="•"/>
+            </a:pPr>
+            <a:r>
+              <a:rPr sz="1900" b="0" i="0">
+                <a:solidFill>
+                  <a:srgbClr val="1A1A1A"/>
+                </a:solidFill>
+                <a:latin typeface="Calibri"/>
+              </a:rPr>
+              <a:t>Generate the full script; diff the bundle</a:t>
+            </a:r>
+          </a:p>
+          <a:p>
+            <a:pPr marL="274320" indent="-228600">
+              <a:spcAft>
+                <a:spcPts val="600"/>
+              </a:spcAft>
+              <a:buChar char="•"/>
+            </a:pPr>
+            <a:r>
+              <a:rPr sz="1900" b="0" i="0">
+                <a:solidFill>
+                  <a:srgbClr val="1A1A1A"/>
+                </a:solidFill>
+                <a:latin typeface="Calibri"/>
+              </a:rPr>
+              <a:t>Holdouts run once, at the end</a:t>
+            </a:r>
+          </a:p>
+        </p:txBody>
+      </p:sp>
+    </p:spTree>
+  </p:cSld>
+  <p:clrMapOvr>
+    <a:masterClrMapping/>
+  </p:clrMapOvr>
+</p:sld>
+</file>
+
+<file path=ppt/slides/slide15.xml><?xml version="1.0" encoding="utf-8"?>
+<p:sld xmlns:a="http://schemas.openxmlformats.org/drawingml/2006/main" xmlns:p="http://schemas.openxmlformats.org/presentationml/2006/main" xmlns:r="http://schemas.openxmlformats.org/officeDocument/2006/relationships">
+  <p:cSld>
+    <p:spTree>
+      <p:nvGrpSpPr>
+        <p:cNvPr id="1" name=""/>
+        <p:cNvGrpSpPr/>
+        <p:nvPr/>
+      </p:nvGrpSpPr>
+      <p:grpSpPr/>
+      <p:sp>
+        <p:nvSpPr>
+          <p:cNvPr id="2" name="Rectangle 1"/>
+          <p:cNvSpPr/>
+          <p:nvPr/>
+        </p:nvSpPr>
+        <p:spPr>
+          <a:xfrm>
+            <a:off x="0" y="0"/>
+            <a:ext cx="164592" cy="6858000"/>
+          </a:xfrm>
+          <a:prstGeom prst="rect">
+            <a:avLst/>
+          </a:prstGeom>
+          <a:solidFill>
+            <a:srgbClr val="1F4E79"/>
+          </a:solidFill>
+          <a:ln>
+            <a:noFill/>
+          </a:ln>
+        </p:spPr>
+        <p:style>
+          <a:lnRef idx="1">
+            <a:schemeClr val="accent1"/>
+          </a:lnRef>
+          <a:fillRef idx="3">
+            <a:schemeClr val="accent1"/>
+          </a:fillRef>
+          <a:effectRef idx="2">
+            <a:schemeClr val="accent1"/>
+          </a:effectRef>
+          <a:fontRef idx="minor">
+            <a:schemeClr val="lt1"/>
+          </a:fontRef>
+        </p:style>
+        <p:txBody>
+          <a:bodyPr rtlCol="0" anchor="ctr"/>
+          <a:lstStyle/>
+          <a:p>
+            <a:pPr algn="ctr"/>
+          </a:p>
+        </p:txBody>
+      </p:sp>
+      <p:sp>
+        <p:nvSpPr>
+          <p:cNvPr id="3" name="TextBox 2"/>
+          <p:cNvSpPr txBox="1"/>
+          <p:nvPr/>
+        </p:nvSpPr>
+        <p:spPr>
+          <a:xfrm>
+            <a:off x="502920" y="320040"/>
+            <a:ext cx="11155680" cy="731520"/>
+          </a:xfrm>
+          <a:prstGeom prst="rect">
+            <a:avLst/>
+          </a:prstGeom>
+          <a:noFill/>
+        </p:spPr>
+        <p:txBody>
+          <a:bodyPr wrap="square" anchor="t" lIns="45720" rIns="45720">
+            <a:spAutoFit/>
+          </a:bodyPr>
+          <a:lstStyle/>
+          <a:p>
+            <a:pPr algn="l"/>
+            <a:r>
+              <a:rPr sz="3000" b="1" i="0">
+                <a:solidFill>
+                  <a:srgbClr val="1F4E79"/>
+                </a:solidFill>
+                <a:latin typeface="Calibri"/>
+              </a:rPr>
+              <a:t>Known limitations and next steps</a:t>
+            </a:r>
+          </a:p>
+        </p:txBody>
+      </p:sp>
+      <p:cxnSp>
+        <p:nvCxnSpPr>
+          <p:cNvPr id="4" name="Connector 3"/>
+          <p:cNvCxnSpPr/>
+          <p:nvPr/>
+        </p:nvCxnSpPr>
+        <p:spPr>
+          <a:xfrm>
+            <a:off x="548640" y="1051560"/>
+            <a:ext cx="11109960" cy="0"/>
+          </a:xfrm>
+          <a:prstGeom prst="line">
+            <a:avLst/>
+          </a:prstGeom>
+          <a:ln w="12700">
+            <a:solidFill>
+              <a:srgbClr val="BFBFBF"/>
+            </a:solidFill>
+          </a:ln>
+        </p:spPr>
+        <p:style>
+          <a:lnRef idx="2">
+            <a:schemeClr val="accent1"/>
+          </a:lnRef>
+          <a:fillRef idx="0">
+            <a:schemeClr val="accent1"/>
+          </a:fillRef>
+          <a:effectRef idx="1">
+            <a:schemeClr val="accent1"/>
+          </a:effectRef>
+          <a:fontRef idx="minor">
+            <a:schemeClr val="tx1"/>
+          </a:fontRef>
+        </p:style>
+      </p:cxnSp>
+      <p:sp>
+        <p:nvSpPr>
+          <p:cNvPr id="5" name="TextBox 4"/>
+          <p:cNvSpPr txBox="1"/>
+          <p:nvPr/>
+        </p:nvSpPr>
+        <p:spPr>
+          <a:xfrm>
+            <a:off x="502920" y="6400800"/>
+            <a:ext cx="7315200" cy="320040"/>
+          </a:xfrm>
+          <a:prstGeom prst="rect">
+            <a:avLst/>
+          </a:prstGeom>
+          <a:noFill/>
+        </p:spPr>
+        <p:txBody>
+          <a:bodyPr wrap="square" anchor="t" lIns="45720" rIns="45720">
+            <a:spAutoFit/>
+          </a:bodyPr>
+          <a:lstStyle/>
+          <a:p>
+            <a:pPr algn="l"/>
+            <a:r>
+              <a:rPr sz="1000" b="0" i="0">
+                <a:solidFill>
+                  <a:srgbClr val="595959"/>
+                </a:solidFill>
+                <a:latin typeface="Calibri"/>
+              </a:rPr>
+              <a:t>Agentforce Banking Reference Implementation</a:t>
+            </a:r>
+          </a:p>
+        </p:txBody>
+      </p:sp>
+      <p:sp>
+        <p:nvSpPr>
+          <p:cNvPr id="6" name="TextBox 5"/>
+          <p:cNvSpPr txBox="1"/>
+          <p:nvPr/>
+        </p:nvSpPr>
+        <p:spPr>
+          <a:xfrm>
+            <a:off x="10698480" y="6400800"/>
+            <a:ext cx="1005840" cy="320040"/>
+          </a:xfrm>
+          <a:prstGeom prst="rect">
+            <a:avLst/>
+          </a:prstGeom>
+          <a:noFill/>
+        </p:spPr>
+        <p:txBody>
+          <a:bodyPr wrap="square" anchor="t" lIns="45720" rIns="45720">
+            <a:spAutoFit/>
+          </a:bodyPr>
+          <a:lstStyle/>
+          <a:p>
+            <a:pPr algn="r"/>
+            <a:r>
+              <a:rPr sz="1000" b="0" i="0">
+                <a:solidFill>
+                  <a:srgbClr val="595959"/>
+                </a:solidFill>
+                <a:latin typeface="Calibri"/>
+              </a:rPr>
+              <a:t>15</a:t>
             </a:r>
           </a:p>
         </p:txBody>
@@ -8839,149 +9290,9 @@
           </a:p>
         </p:txBody>
       </p:sp>
-      <p:sp>
-        <p:nvSpPr>
-          <p:cNvPr id="3" name="TextBox 2"/>
-          <p:cNvSpPr txBox="1"/>
-          <p:nvPr/>
-        </p:nvSpPr>
-        <p:spPr>
-          <a:xfrm>
-            <a:off x="502920" y="320040"/>
-            <a:ext cx="11155680" cy="731520"/>
-          </a:xfrm>
-          <a:prstGeom prst="rect">
-            <a:avLst/>
-          </a:prstGeom>
-          <a:noFill/>
-        </p:spPr>
-        <p:txBody>
-          <a:bodyPr wrap="square" anchor="t" lIns="45720" rIns="45720">
-            <a:spAutoFit/>
-          </a:bodyPr>
-          <a:lstStyle/>
-          <a:p>
-            <a:pPr algn="l"/>
-            <a:r>
-              <a:rPr sz="3000" b="1" i="0">
-                <a:solidFill>
-                  <a:srgbClr val="1F4E79"/>
-                </a:solidFill>
-                <a:latin typeface="Calibri"/>
-              </a:rPr>
-              <a:t>Architecture</a:t>
-            </a:r>
-          </a:p>
-        </p:txBody>
-      </p:sp>
-      <p:cxnSp>
-        <p:nvCxnSpPr>
-          <p:cNvPr id="4" name="Connector 3"/>
-          <p:cNvCxnSpPr/>
-          <p:nvPr/>
-        </p:nvCxnSpPr>
-        <p:spPr>
-          <a:xfrm>
-            <a:off x="548640" y="1051560"/>
-            <a:ext cx="11109960" cy="0"/>
-          </a:xfrm>
-          <a:prstGeom prst="line">
-            <a:avLst/>
-          </a:prstGeom>
-          <a:ln w="12700">
-            <a:solidFill>
-              <a:srgbClr val="BFBFBF"/>
-            </a:solidFill>
-          </a:ln>
-        </p:spPr>
-        <p:style>
-          <a:lnRef idx="2">
-            <a:schemeClr val="accent1"/>
-          </a:lnRef>
-          <a:fillRef idx="0">
-            <a:schemeClr val="accent1"/>
-          </a:fillRef>
-          <a:effectRef idx="1">
-            <a:schemeClr val="accent1"/>
-          </a:effectRef>
-          <a:fontRef idx="minor">
-            <a:schemeClr val="tx1"/>
-          </a:fontRef>
-        </p:style>
-      </p:cxnSp>
-      <p:sp>
-        <p:nvSpPr>
-          <p:cNvPr id="5" name="TextBox 4"/>
-          <p:cNvSpPr txBox="1"/>
-          <p:nvPr/>
-        </p:nvSpPr>
-        <p:spPr>
-          <a:xfrm>
-            <a:off x="502920" y="6400800"/>
-            <a:ext cx="7315200" cy="320040"/>
-          </a:xfrm>
-          <a:prstGeom prst="rect">
-            <a:avLst/>
-          </a:prstGeom>
-          <a:noFill/>
-        </p:spPr>
-        <p:txBody>
-          <a:bodyPr wrap="square" anchor="t" lIns="45720" rIns="45720">
-            <a:spAutoFit/>
-          </a:bodyPr>
-          <a:lstStyle/>
-          <a:p>
-            <a:pPr algn="l"/>
-            <a:r>
-              <a:rPr sz="1000" b="0" i="0">
-                <a:solidFill>
-                  <a:srgbClr val="595959"/>
-                </a:solidFill>
-                <a:latin typeface="Calibri"/>
-              </a:rPr>
-              <a:t>Agentforce Banking Reference Implementation</a:t>
-            </a:r>
-          </a:p>
-        </p:txBody>
-      </p:sp>
-      <p:sp>
-        <p:nvSpPr>
-          <p:cNvPr id="6" name="TextBox 5"/>
-          <p:cNvSpPr txBox="1"/>
-          <p:nvPr/>
-        </p:nvSpPr>
-        <p:spPr>
-          <a:xfrm>
-            <a:off x="10698480" y="6400800"/>
-            <a:ext cx="1005840" cy="320040"/>
-          </a:xfrm>
-          <a:prstGeom prst="rect">
-            <a:avLst/>
-          </a:prstGeom>
-          <a:noFill/>
-        </p:spPr>
-        <p:txBody>
-          <a:bodyPr wrap="square" anchor="t" lIns="45720" rIns="45720">
-            <a:spAutoFit/>
-          </a:bodyPr>
-          <a:lstStyle/>
-          <a:p>
-            <a:pPr algn="r"/>
-            <a:r>
-              <a:rPr sz="1000" b="0" i="0">
-                <a:solidFill>
-                  <a:srgbClr val="595959"/>
-                </a:solidFill>
-                <a:latin typeface="Calibri"/>
-              </a:rPr>
-              <a:t>4</a:t>
-            </a:r>
-          </a:p>
-        </p:txBody>
-      </p:sp>
       <p:pic>
         <p:nvPicPr>
-          <p:cNvPr id="7" name="Picture 6" descr="architecture.png"/>
+          <p:cNvPr id="3" name="Picture 2" descr="architecture.png"/>
           <p:cNvPicPr>
             <a:picLocks noChangeAspect="1"/>
           </p:cNvPicPr>
@@ -8995,14 +9306,119 @@
         </p:blipFill>
         <p:spPr>
           <a:xfrm>
-            <a:off x="1866747" y="1188720"/>
-            <a:ext cx="8458200" cy="5074920"/>
+            <a:off x="548640" y="45720"/>
+            <a:ext cx="11247120" cy="6748272"/>
           </a:xfrm>
           <a:prstGeom prst="rect">
             <a:avLst/>
           </a:prstGeom>
         </p:spPr>
       </p:pic>
+      <p:sp>
+        <p:nvSpPr>
+          <p:cNvPr id="4" name="TextBox 3"/>
+          <p:cNvSpPr txBox="1"/>
+          <p:nvPr/>
+        </p:nvSpPr>
+        <p:spPr>
+          <a:xfrm>
+            <a:off x="685800" y="228600"/>
+            <a:ext cx="2011680" cy="548640"/>
+          </a:xfrm>
+          <a:prstGeom prst="rect">
+            <a:avLst/>
+          </a:prstGeom>
+          <a:noFill/>
+        </p:spPr>
+        <p:txBody>
+          <a:bodyPr wrap="square" anchor="t" lIns="45720" rIns="45720">
+            <a:spAutoFit/>
+          </a:bodyPr>
+          <a:lstStyle/>
+          <a:p>
+            <a:pPr algn="l"/>
+            <a:r>
+              <a:rPr sz="2400" b="1" i="0">
+                <a:solidFill>
+                  <a:srgbClr val="1F4E79"/>
+                </a:solidFill>
+                <a:latin typeface="Calibri"/>
+              </a:rPr>
+              <a:t>Architecture</a:t>
+            </a:r>
+          </a:p>
+        </p:txBody>
+      </p:sp>
+      <p:sp>
+        <p:nvSpPr>
+          <p:cNvPr id="5" name="TextBox 4"/>
+          <p:cNvSpPr txBox="1"/>
+          <p:nvPr/>
+        </p:nvSpPr>
+        <p:spPr>
+          <a:xfrm>
+            <a:off x="502920" y="6565392"/>
+            <a:ext cx="7315200" cy="274320"/>
+          </a:xfrm>
+          <a:prstGeom prst="rect">
+            <a:avLst/>
+          </a:prstGeom>
+          <a:noFill/>
+        </p:spPr>
+        <p:txBody>
+          <a:bodyPr wrap="square" anchor="t" lIns="45720" rIns="45720">
+            <a:spAutoFit/>
+          </a:bodyPr>
+          <a:lstStyle/>
+          <a:p>
+            <a:pPr algn="l"/>
+            <a:r>
+              <a:rPr sz="1000" b="0" i="0">
+                <a:solidFill>
+                  <a:srgbClr val="595959"/>
+                </a:solidFill>
+                <a:latin typeface="Calibri"/>
+              </a:rPr>
+              <a:t>Agentforce Banking Reference Implementation</a:t>
+            </a:r>
+          </a:p>
+        </p:txBody>
+      </p:sp>
+      <p:sp>
+        <p:nvSpPr>
+          <p:cNvPr id="6" name="TextBox 5"/>
+          <p:cNvSpPr txBox="1"/>
+          <p:nvPr/>
+        </p:nvSpPr>
+        <p:spPr>
+          <a:xfrm>
+            <a:off x="10698480" y="6565392"/>
+            <a:ext cx="1005840" cy="274320"/>
+          </a:xfrm>
+          <a:prstGeom prst="rect">
+            <a:avLst/>
+          </a:prstGeom>
+          <a:noFill/>
+        </p:spPr>
+        <p:txBody>
+          <a:bodyPr wrap="square" anchor="t" lIns="45720" rIns="45720">
+            <a:spAutoFit/>
+          </a:bodyPr>
+          <a:lstStyle/>
+          <a:p>
+            <a:pPr algn="r"/>
+            <a:r>
+              <a:rPr sz="1000" b="0" i="0">
+                <a:solidFill>
+                  <a:srgbClr val="595959"/>
+                </a:solidFill>
+                <a:latin typeface="Calibri"/>
+              </a:rPr>
+              <a:t>4</a:t>
+            </a:r>
+          </a:p>
+        </p:txBody>
+      </p:sp>
     </p:spTree>
   </p:cSld>
   <p:clrMapOvr>
@@ -9985,7 +10401,7 @@
         </p:nvGraphicFramePr>
         <p:xfrm>
           <a:off x="548640" y="1371600"/>
-          <a:ext cx="5486400" cy="2194560"/>
+          <a:ext cx="4343400" cy="2194560"/>
         </p:xfrm>
         <a:graphic>
           <a:graphicData uri="http://schemas.openxmlformats.org/drawingml/2006/table">
@@ -9994,8 +10410,8 @@
                 <a:tableStyleId>{5C22544A-7EE6-4342-B048-85BDC9FD1C3A}</a:tableStyleId>
               </a:tblPr>
               <a:tblGrid>
-                <a:gridCol w="1645920"/>
-                <a:gridCol w="3840480"/>
+                <a:gridCol w="1463040"/>
+                <a:gridCol w="2880360"/>
               </a:tblGrid>
               <a:tr h="548640">
                 <a:tc>
@@ -10124,7 +10540,7 @@
                           </a:solidFill>
                           <a:latin typeface="Calibri"/>
                         </a:rPr>
-                        <a:t>Code fixes it; status "(Repaired)"</a:t>
+                        <a:t>Code fixes it; "(Repaired)"</a:t>
                       </a:r>
                     </a:p>
                   </a:txBody>
@@ -10194,7 +10610,7 @@
         <p:spPr>
           <a:xfrm>
             <a:off x="548640" y="3840480"/>
-            <a:ext cx="5486400" cy="2377440"/>
+            <a:ext cx="4343400" cy="2377440"/>
           </a:xfrm>
           <a:prstGeom prst="rect">
             <a:avLst/>
@@ -10214,13 +10630,13 @@
               <a:buChar char="•"/>
             </a:pPr>
             <a:r>
-              <a:rPr sz="1900" b="0" i="0">
+              <a:rPr sz="1800" b="0" i="0">
                 <a:solidFill>
                   <a:srgbClr val="1A1A1A"/>
                 </a:solidFill>
                 <a:latin typeface="Calibri"/>
               </a:rPr>
-              <a:t>Block: unknown source id, amount not in context</a:t>
+              <a:t>Block: unknown source id, number not in a cited source</a:t>
             </a:r>
           </a:p>
           <a:p>
@@ -10231,13 +10647,13 @@
               <a:buChar char="•"/>
             </a:pPr>
             <a:r>
-              <a:rPr sz="1900" b="0" i="0">
+              <a:rPr sz="1800" b="0" i="0">
                 <a:solidFill>
                   <a:srgbClr val="1A1A1A"/>
                 </a:solidFill>
                 <a:latin typeface="Calibri"/>
               </a:rPr>
-              <a:t>Repair: next step = full clause; owner set by code</a:t>
+              <a:t>Repair: full clause; owner set by code</a:t>
             </a:r>
           </a:p>
           <a:p>
@@ -10248,7 +10664,7 @@
               <a:buChar char="•"/>
             </a:pPr>
             <a:r>
-              <a:rPr sz="1900" b="0" i="0">
+              <a:rPr sz="1800" b="0" i="0">
                 <a:solidFill>
                   <a:srgbClr val="1A1A1A"/>
                 </a:solidFill>
@@ -10267,8 +10683,8 @@
         </p:nvSpPr>
         <p:spPr>
           <a:xfrm>
-            <a:off x="6309360" y="1371600"/>
-            <a:ext cx="5349240" cy="2240280"/>
+            <a:off x="5120640" y="1325880"/>
+            <a:ext cx="6537960" cy="1371600"/>
           </a:xfrm>
           <a:prstGeom prst="roundRect">
             <a:avLst>
@@ -10314,8 +10730,8 @@
         </p:nvSpPr>
         <p:spPr>
           <a:xfrm>
-            <a:off x="6446520" y="1481328"/>
-            <a:ext cx="5074920" cy="457200"/>
+            <a:off x="5257800" y="1435608"/>
+            <a:ext cx="6263640" cy="457200"/>
           </a:xfrm>
           <a:prstGeom prst="rect">
             <a:avLst/>
@@ -10330,7 +10746,7 @@
           <a:p>
             <a:pPr algn="l"/>
             <a:r>
-              <a:rPr sz="2100" b="1" i="0">
+              <a:rPr sz="1800" b="1" i="0">
                 <a:solidFill>
                   <a:srgbClr val="1F4E79"/>
                 </a:solidFill>
@@ -10349,8 +10765,8 @@
         </p:nvSpPr>
         <p:spPr>
           <a:xfrm>
-            <a:off x="6400800" y="1965960"/>
-            <a:ext cx="5166360" cy="1554480"/>
+            <a:off x="5212080" y="1920240"/>
+            <a:ext cx="6355080" cy="685800"/>
           </a:xfrm>
           <a:prstGeom prst="rect">
             <a:avLst/>
@@ -10370,30 +10786,13 @@
               <a:buChar char="•"/>
             </a:pPr>
             <a:r>
-              <a:rPr sz="1900" b="0" i="0">
+              <a:rPr sz="1600" b="0" i="0">
                 <a:solidFill>
                   <a:srgbClr val="1A1A1A"/>
                 </a:solidFill>
                 <a:latin typeface="Calibri"/>
               </a:rPr>
-              <a:t>Model: "send buyer list", owner Tom Brennan</a:t>
-            </a:r>
-          </a:p>
-          <a:p>
-            <a:pPr marL="274320" indent="-228600">
-              <a:spcAft>
-                <a:spcPts val="600"/>
-              </a:spcAft>
-              <a:buChar char="•"/>
-            </a:pPr>
-            <a:r>
-              <a:rPr sz="1900" b="0" i="0">
-                <a:solidFill>
-                  <a:srgbClr val="1A1A1A"/>
-                </a:solidFill>
-                <a:latin typeface="Calibri"/>
-              </a:rPr>
-              <a:t>Code: "send buyer list (TB)", owner Unassigned</a:t>
+              <a:t>Model "send buyer list", owner Tom Brennan → code "send buyer list (TB)", Unassigned</a:t>
             </a:r>
           </a:p>
         </p:txBody>
@@ -10406,8 +10805,8 @@
         </p:nvSpPr>
         <p:spPr>
           <a:xfrm>
-            <a:off x="6309360" y="3794760"/>
-            <a:ext cx="5349240" cy="2057400"/>
+            <a:off x="5120640" y="2788920"/>
+            <a:ext cx="6537960" cy="1691640"/>
           </a:xfrm>
           <a:prstGeom prst="roundRect">
             <a:avLst>
@@ -10453,8 +10852,8 @@
         </p:nvSpPr>
         <p:spPr>
           <a:xfrm>
-            <a:off x="6446520" y="3904488"/>
-            <a:ext cx="5074920" cy="457200"/>
+            <a:off x="5257800" y="2898648"/>
+            <a:ext cx="6263640" cy="457200"/>
           </a:xfrm>
           <a:prstGeom prst="rect">
             <a:avLst/>
@@ -10469,13 +10868,13 @@
           <a:p>
             <a:pPr algn="l"/>
             <a:r>
-              <a:rPr sz="2100" b="1" i="0">
+              <a:rPr sz="1800" b="1" i="0">
                 <a:solidFill>
                   <a:srgbClr val="1F4E79"/>
                 </a:solidFill>
                 <a:latin typeface="Calibri"/>
               </a:rPr>
-              <a:t>Real block (GPT 5.4, MTG-0016 run 1)</a:t>
+              <a:t>Real block (GPT 5.4, MTG-0016 run 1) and mutations</a:t>
             </a:r>
           </a:p>
         </p:txBody>
@@ -10488,8 +10887,8 @@
         </p:nvSpPr>
         <p:spPr>
           <a:xfrm>
-            <a:off x="6400800" y="4389120"/>
-            <a:ext cx="5166360" cy="1371600"/>
+            <a:off x="5212080" y="3383280"/>
+            <a:ext cx="6355080" cy="1005840"/>
           </a:xfrm>
           <a:prstGeom prst="rect">
             <a:avLst/>
@@ -10509,13 +10908,13 @@
               <a:buChar char="•"/>
             </a:pPr>
             <a:r>
-              <a:rPr sz="1900" b="0" i="0">
+              <a:rPr sz="1600" b="0" i="0">
                 <a:solidFill>
                   <a:srgbClr val="1A1A1A"/>
                 </a:solidFill>
                 <a:latin typeface="Calibri"/>
               </a:rPr>
-              <a:t>Invalid JSON at column 2190</a:t>
+              <a:t>Invalid JSON at column 2190 → one plain retry</a:t>
             </a:r>
           </a:p>
           <a:p>
@@ -10526,13 +10925,152 @@
               <a:buChar char="•"/>
             </a:pPr>
             <a:r>
-              <a:rPr sz="1900" b="0" i="0">
+              <a:rPr sz="1600" b="0" i="0">
                 <a:solidFill>
                   <a:srgbClr val="1A1A1A"/>
                 </a:solidFill>
                 <a:latin typeface="Calibri"/>
               </a:rPr>
-              <a:t>One plain retry of the frozen template</a:t>
+              <a:t>TC-03 mutations: fabricated $5B; "Northwind is also a bidder" in a Halverson answer → INVALID</a:t>
+            </a:r>
+          </a:p>
+        </p:txBody>
+      </p:sp>
+      <p:sp>
+        <p:nvSpPr>
+          <p:cNvPr id="15" name="Rounded Rectangle 14"/>
+          <p:cNvSpPr/>
+          <p:nvPr/>
+        </p:nvSpPr>
+        <p:spPr>
+          <a:xfrm>
+            <a:off x="5120640" y="4572000"/>
+            <a:ext cx="6537960" cy="1645920"/>
+          </a:xfrm>
+          <a:prstGeom prst="roundRect">
+            <a:avLst>
+              <a:gd name="adj" fmla="val 6000"/>
+            </a:avLst>
+          </a:prstGeom>
+          <a:solidFill>
+            <a:srgbClr val="EAF1F8"/>
+          </a:solidFill>
+          <a:ln w="15875">
+            <a:solidFill>
+              <a:srgbClr val="1F4E79"/>
+            </a:solidFill>
+          </a:ln>
+        </p:spPr>
+        <p:style>
+          <a:lnRef idx="1">
+            <a:schemeClr val="accent1"/>
+          </a:lnRef>
+          <a:fillRef idx="3">
+            <a:schemeClr val="accent1"/>
+          </a:fillRef>
+          <a:effectRef idx="2">
+            <a:schemeClr val="accent1"/>
+          </a:effectRef>
+          <a:fontRef idx="minor">
+            <a:schemeClr val="lt1"/>
+          </a:fontRef>
+        </p:style>
+        <p:txBody>
+          <a:bodyPr rtlCol="0" anchor="ctr"/>
+          <a:lstStyle/>
+          <a:p>
+            <a:pPr algn="ctr"/>
+          </a:p>
+        </p:txBody>
+      </p:sp>
+      <p:sp>
+        <p:nvSpPr>
+          <p:cNvPr id="16" name="TextBox 15"/>
+          <p:cNvSpPr txBox="1"/>
+          <p:nvPr/>
+        </p:nvSpPr>
+        <p:spPr>
+          <a:xfrm>
+            <a:off x="5257800" y="4681728"/>
+            <a:ext cx="6263640" cy="457200"/>
+          </a:xfrm>
+          <a:prstGeom prst="rect">
+            <a:avLst/>
+          </a:prstGeom>
+          <a:noFill/>
+        </p:spPr>
+        <p:txBody>
+          <a:bodyPr wrap="square" anchor="t" lIns="45720" rIns="45720">
+            <a:spAutoFit/>
+          </a:bodyPr>
+          <a:lstStyle/>
+          <a:p>
+            <a:pPr algn="l"/>
+            <a:r>
+              <a:rPr sz="1800" b="1" i="0">
+                <a:solidFill>
+                  <a:srgbClr val="1F4E79"/>
+                </a:solidFill>
+                <a:latin typeface="Calibri"/>
+              </a:rPr>
+              <a:t>Q&amp;A trap held (BA-18)</a:t>
+            </a:r>
+          </a:p>
+        </p:txBody>
+      </p:sp>
+      <p:sp>
+        <p:nvSpPr>
+          <p:cNvPr id="17" name="TextBox 16"/>
+          <p:cNvSpPr txBox="1"/>
+          <p:nvPr/>
+        </p:nvSpPr>
+        <p:spPr>
+          <a:xfrm>
+            <a:off x="5212080" y="5166360"/>
+            <a:ext cx="6355080" cy="960120"/>
+          </a:xfrm>
+          <a:prstGeom prst="rect">
+            <a:avLst/>
+          </a:prstGeom>
+          <a:noFill/>
+        </p:spPr>
+        <p:txBody>
+          <a:bodyPr wrap="square">
+            <a:spAutoFit/>
+          </a:bodyPr>
+          <a:lstStyle/>
+          <a:p>
+            <a:pPr marL="274320" indent="-228600">
+              <a:spcAft>
+                <a:spcPts val="600"/>
+              </a:spcAft>
+              <a:buChar char="•"/>
+            </a:pPr>
+            <a:r>
+              <a:rPr sz="1600" b="0" i="0">
+                <a:solidFill>
+                  <a:srgbClr val="1A1A1A"/>
+                </a:solidFill>
+                <a:latin typeface="Calibri"/>
+              </a:rPr>
+              <a:t>"What's Halverson's EBITDA margin?" → Not answerable</a:t>
+            </a:r>
+          </a:p>
+          <a:p>
+            <a:pPr marL="274320" indent="-228600">
+              <a:spcAft>
+                <a:spcPts val="600"/>
+              </a:spcAft>
+              <a:buChar char="•"/>
+            </a:pPr>
+            <a:r>
+              <a:rPr sz="1600" b="0" i="0">
+                <a:solidFill>
+                  <a:srgbClr val="1A1A1A"/>
+                </a:solidFill>
+                <a:latin typeface="Calibri"/>
+              </a:rPr>
+              <a:t>A computed margin (e.g. 1.4%) is INVALID: not in a cited source</a:t>
             </a:r>
           </a:p>
         </p:txBody>

</xml_diff>

<commit_message>
Rebuild docs with test results: Test Protocol (30 pp, conclusion), Functional Spec open items (26 pp), deck results slide (15 slides)
TC-13 Fail confirmed (display; own criterion passed). Holdout pair recorded in PROMPT_ITERATIONS: TC-19 under-block (reached the banker) and TC-21 over-block (failed safe); fixes proposed, not applied. FS: two initials rows in Known limitations, new section 17 Open items. Deck: 'Testing approach and results' with tallies (19/4/2/1 pending) and the pair; initials rules in Next steps. All documents stay 0.1. TC-22 step 4 still pending.
</commit_message>
<xml_diff>
--- a/docs/Panel_Overview.pptx
+++ b/docs/Panel_Overview.pptx
@@ -516,7 +516,7 @@
           <a:lstStyle/>
           <a:p>
             <a:r>
-              <a:t>Welcome. 45 minutes: about 30 of walkthrough and demo, 15 for questions. Everything in this deck comes from the repository: the code, the logs (BUILD_LOG, AI_TOOLING_LOG, PROMPT_ITERATIONS) and the test protocol. Where a test has not been executed yet, the slide says [after execution].</a:t>
+              <a:t>Welcome. 45 minutes: about 30 of walkthrough and demo, 15 for questions. Everything in this deck comes from the repository: the code, the logs (BUILD_LOG, AI_TOOLING_LOG, PROMPT_ITERATIONS) and the executed test protocol.</a:t>
             </a:r>
           </a:p>
         </p:txBody>
@@ -586,7 +586,7 @@
           <a:lstStyle/>
           <a:p>
             <a:r>
-              <a:t>The test protocol was committed before any test ran, including every pass criterion and the expected outputs for the replay, so the commit time proves the criteria weren't fitted to results. The holdout client, Meridian Health Partners, has three meetings designed to probe owners, an ambiguous set of initials (RK), an amount conflict and a cross-client mention; none were used to write prompts or rules. Replay: saved model outputs go through the deployed validators with no LLM, after proving the live context is byte-identical to what the model saw; then deliberate mutations must fail. Evidence rule: every result cites a log row created after the deploy it verifies. So far TC-00 to TC-03 pass: baseline, 173 of 173 Apex tests, security configuration, and replay plus mutation. The UI and holdout results are [after execution].</a:t>
+              <a:t>The test protocol was committed before any test ran, including every pass criterion and the expected replay outputs, so the criteria weren't fitted to results. Every result cites a log row created after the deploy it verifies. Results: 19 Pass, 4 Fail, 2 Not run by decision, and TC-22's last step pending. The baseline held: no deploy or agent change during execution, and the log audit accounted for all 21 rows. No invented fact passed validation, and the injected instruction was never followed. Two failures were display only: TC-13, where the agent dropped the code-written Message, and TC-15, where "yes" replayed the earlier summary; the save time made that replay visible. The holdout client, Meridian, was run once. Five of eight holdout cases passed, including all three summaries' code checks; the amount-conflict check caught Lumen at $1.8bn against $1.4bn in CRM. The two findings are a pair about initials. Under-block, TC-19: the notes say RK, which could be Rachel Kim or Ryan Kowalski; the model picked Rachel Kim, cited her contact record, and passed, so an attribution the notes don't support reached the banker. Over-block, TC-21: an activity line says "P. Raman"; the model correctly wrote Priya Raman, but the name check wants the full name in the cited source, so it blocked both attempts and the banker got a safe fallback. Both fixes are proposed, not applied: the holdout is spent, so they need new unseen data to measure.</a:t>
             </a:r>
           </a:p>
         </p:txBody>
@@ -936,7 +936,7 @@
           <a:lstStyle/>
           <a:p>
             <a:r>
-              <a:t>Honest limits. The agent's LLM is the display layer: it can shorten validated text or replay an earlier result; the system of record is the meeting record, the PDF and the log, and the production fix is a custom Lightning Type renderer so the text shown is the text returned. Confirmation before regenerating is an instruction, not code. Wording and attribution are measured offline, not guaranteed at runtime. Closed deals and older meetings are not in the context. User mode is unit-tested but not shown end to end, because the Developer Edition org has public sharing on these objects. Next: execute the remaining test cases, including the first holdout runs; then the renderer, structured log fields, the name lookup, a load test with an async path, and closed deals in the context, each followed by a re-run of the test set. Questions.</a:t>
+              <a:t>Honest limits. The agent's LLM is the display layer: it can shorten validated text or replay an earlier result; the system of record is the meeting record, the PDF and the log, and the production fix is a custom Lightning Type renderer so the text shown is the text returned. Confirmation before regenerating is an instruction, not code. Wording, attribution and ambiguous initials are measured offline, not guaranteed at runtime; the holdout showed both sides of the initials problem. Closed deals and older meetings are not in the context. User mode is unit-tested but not shown end to end, because the Developer Edition org has public sharing on these objects. Next: the two initials rules from the holdout (accept "P. Raman" when it resolves to exactly one person, which fixes TC-21's over-block; block a full name when the notes only have ambiguous initials, which fixes TC-19), then the renderer, structured log fields, the name lookup, a load test with an async path, and closed deals in the context, each followed by a re-run of the test set and new unseen data. Questions.</a:t>
             </a:r>
           </a:p>
         </p:txBody>
@@ -4847,7 +4847,7 @@
                 </a:solidFill>
                 <a:latin typeface="Calibri"/>
               </a:rPr>
-              <a:t>Testing approach</a:t>
+              <a:t>Testing approach and results</a:t>
             </a:r>
           </a:p>
         </p:txBody>
@@ -4965,8 +4965,8 @@
         </p:nvSpPr>
         <p:spPr>
           <a:xfrm>
-            <a:off x="548640" y="1371600"/>
-            <a:ext cx="5760720" cy="4480560"/>
+            <a:off x="548640" y="1280160"/>
+            <a:ext cx="5486400" cy="2103120"/>
           </a:xfrm>
           <a:prstGeom prst="rect">
             <a:avLst/>
@@ -4981,38 +4981,38 @@
           <a:p>
             <a:pPr marL="274320" indent="-228600">
               <a:spcAft>
-                <a:spcPts val="800"/>
+                <a:spcPts val="600"/>
               </a:spcAft>
               <a:buChar char="•"/>
             </a:pPr>
             <a:r>
-              <a:rPr sz="2000" b="1" i="0">
+              <a:rPr sz="1700" b="1" i="0">
                 <a:solidFill>
                   <a:srgbClr val="1A1A1A"/>
                 </a:solidFill>
                 <a:latin typeface="Calibri"/>
               </a:rPr>
-              <a:t>Pre-registered:</a:t>
-            </a:r>
-            <a:r>
-              <a:rPr sz="2000" b="0" i="0">
+              <a:t>Pre-registered</a:t>
+            </a:r>
+            <a:r>
+              <a:rPr sz="1700" b="0" i="0">
                 <a:solidFill>
                   <a:srgbClr val="1A1A1A"/>
                 </a:solidFill>
                 <a:latin typeface="Calibri"/>
               </a:rPr>
-              <a:t> criteria committed before any run (dd3ce33)</a:t>
+              <a:t> before any run (dd3ce33)</a:t>
             </a:r>
           </a:p>
           <a:p>
             <a:pPr marL="274320" indent="-228600">
               <a:spcAft>
-                <a:spcPts val="800"/>
+                <a:spcPts val="600"/>
               </a:spcAft>
               <a:buChar char="•"/>
             </a:pPr>
             <a:r>
-              <a:rPr sz="2000" b="1" i="0">
+              <a:rPr sz="1700" b="1" i="0">
                 <a:solidFill>
                   <a:srgbClr val="1A1A1A"/>
                 </a:solidFill>
@@ -5021,91 +5021,48 @@
               <a:t>Holdouts:</a:t>
             </a:r>
             <a:r>
-              <a:rPr sz="2000" b="0" i="0">
+              <a:rPr sz="1700" b="0" i="0">
                 <a:solidFill>
                   <a:srgbClr val="1A1A1A"/>
                 </a:solidFill>
                 <a:latin typeface="Calibri"/>
               </a:rPr>
-              <a:t> Meridian, never used to write prompts or rules</a:t>
+              <a:t> Meridian, unseen until this run</a:t>
             </a:r>
           </a:p>
           <a:p>
             <a:pPr marL="274320" indent="-228600">
               <a:spcAft>
-                <a:spcPts val="800"/>
+                <a:spcPts val="600"/>
               </a:spcAft>
               <a:buChar char="•"/>
             </a:pPr>
             <a:r>
-              <a:rPr sz="2000" b="1" i="0">
+              <a:rPr sz="1700" b="1" i="0">
                 <a:solidFill>
                   <a:srgbClr val="1A1A1A"/>
                 </a:solidFill>
                 <a:latin typeface="Calibri"/>
               </a:rPr>
-              <a:t>Replay + mutation:</a:t>
-            </a:r>
-            <a:r>
-              <a:rPr sz="2000" b="0" i="0">
+              <a:t>Replay + mutation</a:t>
+            </a:r>
+            <a:r>
+              <a:rPr sz="1700" b="0" i="0">
                 <a:solidFill>
                   <a:srgbClr val="1A1A1A"/>
                 </a:solidFill>
                 <a:latin typeface="Calibri"/>
               </a:rPr>
-              <a:t> saved outputs through deployed validators</a:t>
-            </a:r>
-          </a:p>
-          <a:p>
-            <a:pPr marL="274320" indent="-228600">
-              <a:spcAft>
-                <a:spcPts val="800"/>
-              </a:spcAft>
-              <a:buChar char="•"/>
-            </a:pPr>
-            <a:r>
-              <a:rPr sz="2000" b="1" i="0">
+              <a:t>; </a:t>
+            </a:r>
+            <a:r>
+              <a:rPr sz="1700" b="1" i="0">
                 <a:solidFill>
                   <a:srgbClr val="1A1A1A"/>
                 </a:solidFill>
                 <a:latin typeface="Calibri"/>
               </a:rPr>
-              <a:t>Evidence after the change:</a:t>
-            </a:r>
-            <a:r>
-              <a:rPr sz="2000" b="0" i="0">
-                <a:solidFill>
-                  <a:srgbClr val="1A1A1A"/>
-                </a:solidFill>
-                <a:latin typeface="Calibri"/>
-              </a:rPr>
-              <a:t> log row Id and time</a:t>
-            </a:r>
-          </a:p>
-          <a:p>
-            <a:pPr marL="274320" indent="-228600">
-              <a:spcAft>
-                <a:spcPts val="800"/>
-              </a:spcAft>
-              <a:buChar char="•"/>
-            </a:pPr>
-            <a:r>
-              <a:rPr sz="2000" b="1" i="0">
-                <a:solidFill>
-                  <a:srgbClr val="1A1A1A"/>
-                </a:solidFill>
-                <a:latin typeface="Calibri"/>
-              </a:rPr>
-              <a:t>Apex:</a:t>
-            </a:r>
-            <a:r>
-              <a:rPr sz="2000" b="0" i="0">
-                <a:solidFill>
-                  <a:srgbClr val="1A1A1A"/>
-                </a:solidFill>
-                <a:latin typeface="Calibri"/>
-              </a:rPr>
-              <a:t> 173/173, every class 90%+, mocked LLM</a:t>
+              <a:t>evidence after the change</a:t>
             </a:r>
           </a:p>
         </p:txBody>
@@ -5119,8 +5076,8 @@
           <p:nvPr/>
         </p:nvGraphicFramePr>
         <p:xfrm>
-          <a:off x="6583680" y="1371600"/>
-          <a:ext cx="5074920" cy="3291840"/>
+          <a:off x="548640" y="2880360"/>
+          <a:ext cx="5486400" cy="3008376"/>
         </p:xfrm>
         <a:graphic>
           <a:graphicData uri="http://schemas.openxmlformats.org/drawingml/2006/table">
@@ -5129,17 +5086,17 @@
                 <a:tableStyleId>{5C22544A-7EE6-4342-B048-85BDC9FD1C3A}</a:tableStyleId>
               </a:tblPr>
               <a:tblGrid>
-                <a:gridCol w="3108960"/>
-                <a:gridCol w="1965960"/>
+                <a:gridCol w="3017520"/>
+                <a:gridCol w="2468880"/>
               </a:tblGrid>
-              <a:tr h="548640">
+              <a:tr h="429768">
                 <a:tc>
                   <a:txBody>
                     <a:bodyPr wrap="square"/>
                     <a:lstStyle/>
                     <a:p>
                       <a:r>
-                        <a:rPr sz="1400" b="1" i="0">
+                        <a:rPr sz="1300" b="1" i="0">
                           <a:solidFill>
                             <a:srgbClr val="FFFFFF"/>
                           </a:solidFill>
@@ -5161,7 +5118,7 @@
                     <a:lstStyle/>
                     <a:p>
                       <a:r>
-                        <a:rPr sz="1400" b="1" i="0">
+                        <a:rPr sz="1300" b="1" i="0">
                           <a:solidFill>
                             <a:srgbClr val="FFFFFF"/>
                           </a:solidFill>
@@ -5178,14 +5135,14 @@
                   </a:tcPr>
                 </a:tc>
               </a:tr>
-              <a:tr h="548640">
+              <a:tr h="429768">
                 <a:tc>
                   <a:txBody>
                     <a:bodyPr wrap="square"/>
                     <a:lstStyle/>
                     <a:p>
                       <a:r>
-                        <a:rPr sz="1400" b="0" i="0">
+                        <a:rPr sz="1300" b="0" i="0">
                           <a:solidFill>
                             <a:srgbClr val="1A1A1A"/>
                           </a:solidFill>
@@ -5207,7 +5164,7 @@
                     <a:lstStyle/>
                     <a:p>
                       <a:r>
-                        <a:rPr sz="1400" b="0" i="0">
+                        <a:rPr sz="1300" b="0" i="0">
                           <a:solidFill>
                             <a:srgbClr val="1A1A1A"/>
                           </a:solidFill>
@@ -5224,20 +5181,20 @@
                   </a:tcPr>
                 </a:tc>
               </a:tr>
-              <a:tr h="548640">
+              <a:tr h="429768">
                 <a:tc>
                   <a:txBody>
                     <a:bodyPr wrap="square"/>
                     <a:lstStyle/>
                     <a:p>
                       <a:r>
-                        <a:rPr sz="1400" b="0" i="0">
+                        <a:rPr sz="1300" b="0" i="0">
                           <a:solidFill>
                             <a:srgbClr val="1A1A1A"/>
                           </a:solidFill>
                           <a:latin typeface="Calibri"/>
                         </a:rPr>
-                        <a:t>TC-04 to TC-13 (UI, agent)</a:t>
+                        <a:t>TC-04 to TC-13 (button, agent)</a:t>
                       </a:r>
                     </a:p>
                   </a:txBody>
@@ -5253,13 +5210,13 @@
                     <a:lstStyle/>
                     <a:p>
                       <a:r>
-                        <a:rPr sz="1400" b="0" i="0">
+                        <a:rPr sz="1300" b="0" i="0">
                           <a:solidFill>
                             <a:srgbClr val="1A1A1A"/>
                           </a:solidFill>
                           <a:latin typeface="Calibri"/>
                         </a:rPr>
-                        <a:t>[after execution]</a:t>
+                        <a:t>9 Pass, 1 Fail (display)</a:t>
                       </a:r>
                     </a:p>
                   </a:txBody>
@@ -5270,14 +5227,14 @@
                   </a:tcPr>
                 </a:tc>
               </a:tr>
-              <a:tr h="548640">
+              <a:tr h="429768">
                 <a:tc>
                   <a:txBody>
                     <a:bodyPr wrap="square"/>
                     <a:lstStyle/>
                     <a:p>
                       <a:r>
-                        <a:rPr sz="1400" b="0" i="0">
+                        <a:rPr sz="1300" b="0" i="0">
                           <a:solidFill>
                             <a:srgbClr val="1A1A1A"/>
                           </a:solidFill>
@@ -5299,13 +5256,13 @@
                     <a:lstStyle/>
                     <a:p>
                       <a:r>
-                        <a:rPr sz="1400" b="0" i="0">
+                        <a:rPr sz="1300" b="0" i="0">
                           <a:solidFill>
                             <a:srgbClr val="1A1A1A"/>
                           </a:solidFill>
                           <a:latin typeface="Calibri"/>
                         </a:rPr>
-                        <a:t>[after execution]</a:t>
+                        <a:t>5 Pass, 3 Fail</a:t>
                       </a:r>
                     </a:p>
                   </a:txBody>
@@ -5316,14 +5273,14 @@
                   </a:tcPr>
                 </a:tc>
               </a:tr>
-              <a:tr h="548640">
+              <a:tr h="429768">
                 <a:tc>
                   <a:txBody>
                     <a:bodyPr wrap="square"/>
                     <a:lstStyle/>
                     <a:p>
                       <a:r>
-                        <a:rPr sz="1400" b="0" i="0">
+                        <a:rPr sz="1300" b="0" i="0">
                           <a:solidFill>
                             <a:srgbClr val="1A1A1A"/>
                           </a:solidFill>
@@ -5345,13 +5302,13 @@
                     <a:lstStyle/>
                     <a:p>
                       <a:r>
-                        <a:rPr sz="1400" b="0" i="0">
+                        <a:rPr sz="1300" b="0" i="0">
                           <a:solidFill>
                             <a:srgbClr val="1A1A1A"/>
                           </a:solidFill>
                           <a:latin typeface="Calibri"/>
                         </a:rPr>
-                        <a:t>[after execution]</a:t>
+                        <a:t>1 Pass, 1 Not run, 1 pending</a:t>
                       </a:r>
                     </a:p>
                   </a:txBody>
@@ -5362,20 +5319,20 @@
                   </a:tcPr>
                 </a:tc>
               </a:tr>
-              <a:tr h="548640">
+              <a:tr h="429768">
                 <a:tc>
                   <a:txBody>
                     <a:bodyPr wrap="square"/>
                     <a:lstStyle/>
                     <a:p>
                       <a:r>
-                        <a:rPr sz="1400" b="0" i="0">
+                        <a:rPr sz="1300" b="0" i="0">
                           <a:solidFill>
                             <a:srgbClr val="1A1A1A"/>
                           </a:solidFill>
                           <a:latin typeface="Calibri"/>
                         </a:rPr>
-                        <a:t>TC-25 (CONFIGURATION)</a:t>
+                        <a:t>TC-25</a:t>
                       </a:r>
                     </a:p>
                   </a:txBody>
@@ -5391,7 +5348,7 @@
                     <a:lstStyle/>
                     <a:p>
                       <a:r>
-                        <a:rPr sz="1400" b="0" i="0">
+                        <a:rPr sz="1300" b="0" i="0">
                           <a:solidFill>
                             <a:srgbClr val="1A1A1A"/>
                           </a:solidFill>
@@ -5408,10 +5365,368 @@
                   </a:tcPr>
                 </a:tc>
               </a:tr>
+              <a:tr h="429768">
+                <a:tc>
+                  <a:txBody>
+                    <a:bodyPr wrap="square"/>
+                    <a:lstStyle/>
+                    <a:p>
+                      <a:r>
+                        <a:rPr sz="1300" b="0" i="0">
+                          <a:solidFill>
+                            <a:srgbClr val="1A1A1A"/>
+                          </a:solidFill>
+                          <a:latin typeface="Calibri"/>
+                        </a:rPr>
+                        <a:t>Total (26)</a:t>
+                      </a:r>
+                    </a:p>
+                  </a:txBody>
+                  <a:tcPr marL="73152" marR="73152" marT="36576" marB="36576" anchor="ctr">
+                    <a:solidFill>
+                      <a:srgbClr val="EAF1F8"/>
+                    </a:solidFill>
+                  </a:tcPr>
+                </a:tc>
+                <a:tc>
+                  <a:txBody>
+                    <a:bodyPr wrap="square"/>
+                    <a:lstStyle/>
+                    <a:p>
+                      <a:r>
+                        <a:rPr sz="1300" b="0" i="0">
+                          <a:solidFill>
+                            <a:srgbClr val="1A1A1A"/>
+                          </a:solidFill>
+                          <a:latin typeface="Calibri"/>
+                        </a:rPr>
+                        <a:t>19 Pass, 4 Fail, 2 Not run, 1 pending</a:t>
+                      </a:r>
+                    </a:p>
+                  </a:txBody>
+                  <a:tcPr marL="73152" marR="73152" marT="36576" marB="36576" anchor="ctr">
+                    <a:solidFill>
+                      <a:srgbClr val="EAF1F8"/>
+                    </a:solidFill>
+                  </a:tcPr>
+                </a:tc>
+              </a:tr>
             </a:tbl>
           </a:graphicData>
         </a:graphic>
       </p:graphicFrame>
+      <p:sp>
+        <p:nvSpPr>
+          <p:cNvPr id="9" name="Rounded Rectangle 8"/>
+          <p:cNvSpPr/>
+          <p:nvPr/>
+        </p:nvSpPr>
+        <p:spPr>
+          <a:xfrm>
+            <a:off x="6309360" y="1325880"/>
+            <a:ext cx="5349240" cy="2377440"/>
+          </a:xfrm>
+          <a:prstGeom prst="roundRect">
+            <a:avLst>
+              <a:gd name="adj" fmla="val 6000"/>
+            </a:avLst>
+          </a:prstGeom>
+          <a:solidFill>
+            <a:srgbClr val="EAF1F8"/>
+          </a:solidFill>
+          <a:ln w="15875">
+            <a:solidFill>
+              <a:srgbClr val="1F4E79"/>
+            </a:solidFill>
+          </a:ln>
+        </p:spPr>
+        <p:style>
+          <a:lnRef idx="1">
+            <a:schemeClr val="accent1"/>
+          </a:lnRef>
+          <a:fillRef idx="3">
+            <a:schemeClr val="accent1"/>
+          </a:fillRef>
+          <a:effectRef idx="2">
+            <a:schemeClr val="accent1"/>
+          </a:effectRef>
+          <a:fontRef idx="minor">
+            <a:schemeClr val="lt1"/>
+          </a:fontRef>
+        </p:style>
+        <p:txBody>
+          <a:bodyPr rtlCol="0" anchor="ctr"/>
+          <a:lstStyle/>
+          <a:p>
+            <a:pPr algn="ctr"/>
+          </a:p>
+        </p:txBody>
+      </p:sp>
+      <p:sp>
+        <p:nvSpPr>
+          <p:cNvPr id="10" name="TextBox 9"/>
+          <p:cNvSpPr txBox="1"/>
+          <p:nvPr/>
+        </p:nvSpPr>
+        <p:spPr>
+          <a:xfrm>
+            <a:off x="6446520" y="1435608"/>
+            <a:ext cx="5074920" cy="457200"/>
+          </a:xfrm>
+          <a:prstGeom prst="rect">
+            <a:avLst/>
+          </a:prstGeom>
+          <a:noFill/>
+        </p:spPr>
+        <p:txBody>
+          <a:bodyPr wrap="square" anchor="t" lIns="45720" rIns="45720">
+            <a:spAutoFit/>
+          </a:bodyPr>
+          <a:lstStyle/>
+          <a:p>
+            <a:pPr algn="l"/>
+            <a:r>
+              <a:rPr sz="1700" b="1" i="0">
+                <a:solidFill>
+                  <a:srgbClr val="1F4E79"/>
+                </a:solidFill>
+                <a:latin typeface="Calibri"/>
+              </a:rPr>
+              <a:t>Holdout under-block (TC-19)</a:t>
+            </a:r>
+          </a:p>
+        </p:txBody>
+      </p:sp>
+      <p:sp>
+        <p:nvSpPr>
+          <p:cNvPr id="11" name="TextBox 10"/>
+          <p:cNvSpPr txBox="1"/>
+          <p:nvPr/>
+        </p:nvSpPr>
+        <p:spPr>
+          <a:xfrm>
+            <a:off x="6400800" y="1920240"/>
+            <a:ext cx="5166360" cy="1691640"/>
+          </a:xfrm>
+          <a:prstGeom prst="rect">
+            <a:avLst/>
+          </a:prstGeom>
+          <a:noFill/>
+        </p:spPr>
+        <p:txBody>
+          <a:bodyPr wrap="square">
+            <a:spAutoFit/>
+          </a:bodyPr>
+          <a:lstStyle/>
+          <a:p>
+            <a:pPr marL="274320" indent="-228600">
+              <a:spcAft>
+                <a:spcPts val="600"/>
+              </a:spcAft>
+              <a:buChar char="•"/>
+            </a:pPr>
+            <a:r>
+              <a:rPr sz="1500" b="0" i="0">
+                <a:solidFill>
+                  <a:srgbClr val="1A1A1A"/>
+                </a:solidFill>
+                <a:latin typeface="Calibri"/>
+              </a:rPr>
+              <a:t>"RK" (Rachel Kim or Ryan Kowalski) → model said "Rachel Kim"</a:t>
+            </a:r>
+          </a:p>
+          <a:p>
+            <a:pPr marL="274320" indent="-228600">
+              <a:spcAft>
+                <a:spcPts val="600"/>
+              </a:spcAft>
+              <a:buChar char="•"/>
+            </a:pPr>
+            <a:r>
+              <a:rPr sz="1500" b="0" i="0">
+                <a:solidFill>
+                  <a:srgbClr val="1A1A1A"/>
+                </a:solidFill>
+                <a:latin typeface="Calibri"/>
+              </a:rPr>
+              <a:t>Passed: the name was in a cited source; shown to the banker</a:t>
+            </a:r>
+          </a:p>
+          <a:p>
+            <a:pPr marL="274320" indent="-228600">
+              <a:spcAft>
+                <a:spcPts val="600"/>
+              </a:spcAft>
+              <a:buChar char="•"/>
+            </a:pPr>
+            <a:r>
+              <a:rPr sz="1500" b="0" i="0">
+                <a:solidFill>
+                  <a:srgbClr val="1A1A1A"/>
+                </a:solidFill>
+                <a:latin typeface="Calibri"/>
+              </a:rPr>
+              <a:t>Fix: block a full name when initials are ambiguous</a:t>
+            </a:r>
+          </a:p>
+        </p:txBody>
+      </p:sp>
+      <p:sp>
+        <p:nvSpPr>
+          <p:cNvPr id="12" name="Rounded Rectangle 11"/>
+          <p:cNvSpPr/>
+          <p:nvPr/>
+        </p:nvSpPr>
+        <p:spPr>
+          <a:xfrm>
+            <a:off x="6309360" y="3840480"/>
+            <a:ext cx="5349240" cy="2377440"/>
+          </a:xfrm>
+          <a:prstGeom prst="roundRect">
+            <a:avLst>
+              <a:gd name="adj" fmla="val 6000"/>
+            </a:avLst>
+          </a:prstGeom>
+          <a:solidFill>
+            <a:srgbClr val="EAF1F8"/>
+          </a:solidFill>
+          <a:ln w="15875">
+            <a:solidFill>
+              <a:srgbClr val="1F4E79"/>
+            </a:solidFill>
+          </a:ln>
+        </p:spPr>
+        <p:style>
+          <a:lnRef idx="1">
+            <a:schemeClr val="accent1"/>
+          </a:lnRef>
+          <a:fillRef idx="3">
+            <a:schemeClr val="accent1"/>
+          </a:fillRef>
+          <a:effectRef idx="2">
+            <a:schemeClr val="accent1"/>
+          </a:effectRef>
+          <a:fontRef idx="minor">
+            <a:schemeClr val="lt1"/>
+          </a:fontRef>
+        </p:style>
+        <p:txBody>
+          <a:bodyPr rtlCol="0" anchor="ctr"/>
+          <a:lstStyle/>
+          <a:p>
+            <a:pPr algn="ctr"/>
+          </a:p>
+        </p:txBody>
+      </p:sp>
+      <p:sp>
+        <p:nvSpPr>
+          <p:cNvPr id="13" name="TextBox 12"/>
+          <p:cNvSpPr txBox="1"/>
+          <p:nvPr/>
+        </p:nvSpPr>
+        <p:spPr>
+          <a:xfrm>
+            <a:off x="6446520" y="3950208"/>
+            <a:ext cx="5074920" cy="457200"/>
+          </a:xfrm>
+          <a:prstGeom prst="rect">
+            <a:avLst/>
+          </a:prstGeom>
+          <a:noFill/>
+        </p:spPr>
+        <p:txBody>
+          <a:bodyPr wrap="square" anchor="t" lIns="45720" rIns="45720">
+            <a:spAutoFit/>
+          </a:bodyPr>
+          <a:lstStyle/>
+          <a:p>
+            <a:pPr algn="l"/>
+            <a:r>
+              <a:rPr sz="1700" b="1" i="0">
+                <a:solidFill>
+                  <a:srgbClr val="1F4E79"/>
+                </a:solidFill>
+                <a:latin typeface="Calibri"/>
+              </a:rPr>
+              <a:t>Holdout over-block (TC-21)</a:t>
+            </a:r>
+          </a:p>
+        </p:txBody>
+      </p:sp>
+      <p:sp>
+        <p:nvSpPr>
+          <p:cNvPr id="14" name="TextBox 13"/>
+          <p:cNvSpPr txBox="1"/>
+          <p:nvPr/>
+        </p:nvSpPr>
+        <p:spPr>
+          <a:xfrm>
+            <a:off x="6400800" y="4434840"/>
+            <a:ext cx="5166360" cy="1691640"/>
+          </a:xfrm>
+          <a:prstGeom prst="rect">
+            <a:avLst/>
+          </a:prstGeom>
+          <a:noFill/>
+        </p:spPr>
+        <p:txBody>
+          <a:bodyPr wrap="square">
+            <a:spAutoFit/>
+          </a:bodyPr>
+          <a:lstStyle/>
+          <a:p>
+            <a:pPr marL="274320" indent="-228600">
+              <a:spcAft>
+                <a:spcPts val="600"/>
+              </a:spcAft>
+              <a:buChar char="•"/>
+            </a:pPr>
+            <a:r>
+              <a:rPr sz="1500" b="0" i="0">
+                <a:solidFill>
+                  <a:srgbClr val="1A1A1A"/>
+                </a:solidFill>
+                <a:latin typeface="Calibri"/>
+              </a:rPr>
+              <a:t>"P. Raman" in the source → model wrote "Priya Raman"</a:t>
+            </a:r>
+          </a:p>
+          <a:p>
+            <a:pPr marL="274320" indent="-228600">
+              <a:spcAft>
+                <a:spcPts val="600"/>
+              </a:spcAft>
+              <a:buChar char="•"/>
+            </a:pPr>
+            <a:r>
+              <a:rPr sz="1500" b="0" i="0">
+                <a:solidFill>
+                  <a:srgbClr val="1A1A1A"/>
+                </a:solidFill>
+                <a:latin typeface="Calibri"/>
+              </a:rPr>
+              <a:t>Blocked twice → safe fallback, no answer</a:t>
+            </a:r>
+          </a:p>
+          <a:p>
+            <a:pPr marL="274320" indent="-228600">
+              <a:spcAft>
+                <a:spcPts val="600"/>
+              </a:spcAft>
+              <a:buChar char="•"/>
+            </a:pPr>
+            <a:r>
+              <a:rPr sz="1500" b="0" i="0">
+                <a:solidFill>
+                  <a:srgbClr val="1A1A1A"/>
+                </a:solidFill>
+                <a:latin typeface="Calibri"/>
+              </a:rPr>
+              <a:t>Fix: match "&lt;Initial&gt;. &lt;Surname&gt;" to one person</a:t>
+            </a:r>
+          </a:p>
+        </p:txBody>
+      </p:sp>
     </p:spTree>
   </p:cSld>
   <p:clrMapOvr>
@@ -8132,7 +8447,7 @@
                 </a:solidFill>
                 <a:latin typeface="Calibri"/>
               </a:rPr>
-              <a:t>Wording and attribution checked offline only</a:t>
+              <a:t>Wording, attribution, initials: offline only</a:t>
             </a:r>
           </a:p>
           <a:p>
@@ -8305,7 +8620,7 @@
                 </a:solidFill>
                 <a:latin typeface="Calibri"/>
               </a:rPr>
-              <a:t>Run TC-04 to TC-24, including the holdouts</a:t>
+              <a:t>Initials rules: "P. Raman" match; ambiguous block</a:t>
             </a:r>
           </a:p>
           <a:p>

</xml_diff>

<commit_message>
Version 1.0 (approved): results incorporated; TC-22 Pass with deviation; two unsupported RK attributions; final checks
TC-22: Pass, deviation 'step 4 not executed; TC-02 shows no banker permission on the log object'. Final tally 20 Pass, 4 Fail, 2 Not run. Holdout under-block now covers both surfaces: RK -> Rachel Kim in Q&A (TC-19) and Ryan Kowalski in the MTG-0021 summary (TC-15); proposed rule for CitationValidator and SummaryValidator. Functional Specification, Test Protocol and deck at 1.0, status Approved (Test Protocol approval: author 2026-10-14). Final checks: org retrieve vs repo clean (agent, templates, 26 Apex classes: line endings only; permission sets: org adds default viewAllFields=false, committed); 173/173 tests (707gK00000z5UiN, 97%); 22 README links resolve; BUILD_PLAN Day 5 ticked except rehearsal.
</commit_message>
<xml_diff>
--- a/docs/Panel_Overview.pptx
+++ b/docs/Panel_Overview.pptx
@@ -586,7 +586,7 @@
           <a:lstStyle/>
           <a:p>
             <a:r>
-              <a:t>The test protocol was committed before any test ran, including every pass criterion and the expected replay outputs, so the criteria weren't fitted to results. Every result cites a log row created after the deploy it verifies. Results: 19 Pass, 4 Fail, 2 Not run by decision, and TC-22's last step pending. The baseline held: no deploy or agent change during execution, and the log audit accounted for all 21 rows. No invented fact passed validation, and the injected instruction was never followed. Two failures were display only: TC-13, where the agent dropped the code-written Message, and TC-15, where "yes" replayed the earlier summary; the save time made that replay visible. The holdout client, Meridian, was run once. Five of eight holdout cases passed, including all three summaries' code checks; the amount-conflict check caught Lumen at $1.8bn against $1.4bn in CRM. The two findings are a pair about initials. Under-block, TC-19: the notes say RK, which could be Rachel Kim or Ryan Kowalski; the model picked Rachel Kim, cited her contact record, and passed, so an attribution the notes don't support reached the banker. Over-block, TC-21: an activity line says "P. Raman"; the model correctly wrote Priya Raman, but the name check wants the full name in the cited source, so it blocked both attempts and the banker got a safe fallback. Both fixes are proposed, not applied: the holdout is spent, so they need new unseen data to measure.</a:t>
+              <a:t>The test protocol was committed before any test ran, including every pass criterion and the expected replay outputs, so the criteria weren't fitted to results. Every result cites a log row created after the deploy it verifies. Results: 20 Pass, 4 Fail, 2 Not run by decision; TC-22 passed with its last step not executed. The baseline held: no deploy or agent change during execution, and the log audit accounted for all 21 rows. No invented fact passed validation, and the injected instruction was never followed. Two failures were on the display layer: TC-13, where the agent dropped the code-written Message, and TC-15, where "yes" replayed the earlier summary; the save time made that replay visible. The holdout client, Meridian, was run once. Five of eight holdout cases passed, including all three summaries' code checks; the amount-conflict check caught Lumen at $1.8bn against $1.4bn in CRM. The two findings are a pair about initials. Under-block: the notes say RK, which could be Rachel Kim or Ryan Kowalski. Same ambiguity, different guesses, both surfaces: in Q&amp;A, TC-19, the model picked Rachel Kim and cited her contact record; in the MTG-0021 summary, TC-15, the executive summary said Ryan Kowalski preferred the 7-year tenor. Both passed validation, because each name is in a cited source, so two attributions the notes don't support reached the banker. The proposed rule covers both validators. Over-block, TC-21: an activity line says "P. Raman"; the model correctly wrote Priya Raman, but the name check wants the full name in the cited source, so it blocked both attempts and the banker got a safe fallback. Both fixes are proposed, not applied: the holdout is spent, so they need new unseen data to measure.</a:t>
             </a:r>
           </a:p>
         </p:txBody>
@@ -4729,6 +4729,41 @@
         </p:nvSpPr>
         <p:spPr>
           <a:xfrm>
+            <a:off x="5303520" y="5394960"/>
+            <a:ext cx="6400800" cy="365760"/>
+          </a:xfrm>
+          <a:prstGeom prst="rect">
+            <a:avLst/>
+          </a:prstGeom>
+          <a:noFill/>
+        </p:spPr>
+        <p:txBody>
+          <a:bodyPr wrap="square" anchor="t" lIns="45720" rIns="45720">
+            <a:spAutoFit/>
+          </a:bodyPr>
+          <a:lstStyle/>
+          <a:p>
+            <a:pPr algn="l"/>
+            <a:r>
+              <a:rPr sz="1200" b="0" i="0">
+                <a:solidFill>
+                  <a:srgbClr val="595959"/>
+                </a:solidFill>
+                <a:latin typeface="Calibri"/>
+              </a:rPr>
+              <a:t>Version 1.0  ·  Approved  ·  2026-10-14</a:t>
+            </a:r>
+          </a:p>
+        </p:txBody>
+      </p:sp>
+      <p:sp>
+        <p:nvSpPr>
+          <p:cNvPr id="8" name="TextBox 7"/>
+          <p:cNvSpPr txBox="1"/>
+          <p:nvPr/>
+        </p:nvSpPr>
+        <p:spPr>
+          <a:xfrm>
             <a:off x="10698480" y="6400800"/>
             <a:ext cx="1005840" cy="320040"/>
           </a:xfrm>
@@ -5308,7 +5343,7 @@
                           </a:solidFill>
                           <a:latin typeface="Calibri"/>
                         </a:rPr>
-                        <a:t>1 Pass, 1 Not run, 1 pending</a:t>
+                        <a:t>2 Pass, 1 Not run</a:t>
                       </a:r>
                     </a:p>
                   </a:txBody>
@@ -5400,7 +5435,7 @@
                           </a:solidFill>
                           <a:latin typeface="Calibri"/>
                         </a:rPr>
-                        <a:t>19 Pass, 4 Fail, 2 Not run, 1 pending</a:t>
+                        <a:t>20 Pass, 4 Fail, 2 Not run</a:t>
                       </a:r>
                     </a:p>
                   </a:txBody>
@@ -5492,7 +5527,7 @@
                 </a:solidFill>
                 <a:latin typeface="Calibri"/>
               </a:rPr>
-              <a:t>Holdout under-block (TC-19)</a:t>
+              <a:t>Holdout under-block (TC-19, TC-15)</a:t>
             </a:r>
           </a:p>
         </p:txBody>
@@ -5532,7 +5567,7 @@
                 </a:solidFill>
                 <a:latin typeface="Calibri"/>
               </a:rPr>
-              <a:t>"RK" (Rachel Kim or Ryan Kowalski) → model said "Rachel Kim"</a:t>
+              <a:t>"RK" → Rachel Kim in Q&amp;A, Ryan Kowalski in a summary</a:t>
             </a:r>
           </a:p>
           <a:p>
@@ -5549,7 +5584,7 @@
                 </a:solidFill>
                 <a:latin typeface="Calibri"/>
               </a:rPr>
-              <a:t>Passed: the name was in a cited source; shown to the banker</a:t>
+              <a:t>Both passed: name in a cited source; both shown to the banker</a:t>
             </a:r>
           </a:p>
           <a:p>

</xml_diff>

<commit_message>
Deck slide 13: plain-language 'What changes at bank scale' (five stacked cards, 16pt minimum)
Replaces the risk table with numbered cards: headline, 'Why it matters', 'What we do' (accent). Footer line: measured on this build, not load-tested; all 13 risks in SCALABILITY_RISKS.md. Speaker notes rewritten in plain language from the card content. Rendered through PowerPoint: no overflow.
</commit_message>
<xml_diff>
--- a/docs/Panel_Overview.pptx
+++ b/docs/Panel_Overview.pptx
@@ -796,7 +796,7 @@
           <a:lstStyle/>
           <a:p>
             <a:r>
-              <a:t>Measured from 39 log rows; nothing was load-tested, and the full register in SCALABILITY_RISKS.md has 13 risks. The binding limits are inside the banker's own transaction: the template's grounding Apex adds about 5 SOQL and half a second of CPU per call, so the service processes at most 3 records per call and makes every LLM call before any DML. Latency: 3.1 to 9.9 seconds for a summary, median 7.2, 14.6 with a retry. Consumption doubles on a retry, so only invalid output and transient errors are retried. The log needs a retention policy because it holds raw client data. And the cross-client check loads at most 2,000 other names, so in a large book it is incomplete: that is now logged, and the proposed fix is to look up only the names in the question and answer. Two more to mention: concurrent long-running requests need a load test, and model lifecycle means a model change forces a full re-test.</a:t>
+              <a:t>These are the five things that change when hundreds of bankers and 30+ agents use this pattern. One: every click uses the banker's own Salesforce limits. Gathering the facts runs extra database queries inside that click, so we cap it at 3 meetings per click and call the AI before saving anything. Two: a summary takes about 7 seconds, up to 15 if the AI has to try again. We retry only once and watch the slowest requests. Three: every AI call costs money, and a retry costs double. We retry only when the answer fails a check or the service glitches, and never retry permission errors. Four: the log keeps client data indefinitely today. The bank needs to agree a retention period, and a scheduled job would clear old raw text but keep the statistics. Five: the wrong-client check stops at 2,000 names. A large bank has more clients than that, so every time the cap is hit it is now logged, and the next step is to look up only the names in the question. These were measured on this build and not load-tested; all 13 risks are in SCALABILITY_RISKS.md.</a:t>
             </a:r>
           </a:p>
         </p:txBody>
@@ -6714,8 +6714,8 @@
         </p:nvSpPr>
         <p:spPr>
           <a:xfrm>
-            <a:off x="502920" y="320040"/>
-            <a:ext cx="11155680" cy="731520"/>
+            <a:off x="502920" y="228600"/>
+            <a:ext cx="11155680" cy="548640"/>
           </a:xfrm>
           <a:prstGeom prst="rect">
             <a:avLst/>
@@ -6730,26 +6730,61 @@
           <a:p>
             <a:pPr algn="l"/>
             <a:r>
-              <a:rPr sz="3000" b="1" i="0">
+              <a:rPr sz="2800" b="1" i="0">
                 <a:solidFill>
                   <a:srgbClr val="1F4E79"/>
                 </a:solidFill>
                 <a:latin typeface="Calibri"/>
               </a:rPr>
-              <a:t>Scalability: top risks</a:t>
+              <a:t>What changes at bank scale</a:t>
+            </a:r>
+          </a:p>
+        </p:txBody>
+      </p:sp>
+      <p:sp>
+        <p:nvSpPr>
+          <p:cNvPr id="4" name="TextBox 3"/>
+          <p:cNvSpPr txBox="1"/>
+          <p:nvPr/>
+        </p:nvSpPr>
+        <p:spPr>
+          <a:xfrm>
+            <a:off x="502920" y="777240"/>
+            <a:ext cx="11155680" cy="365760"/>
+          </a:xfrm>
+          <a:prstGeom prst="rect">
+            <a:avLst/>
+          </a:prstGeom>
+          <a:noFill/>
+        </p:spPr>
+        <p:txBody>
+          <a:bodyPr wrap="square" anchor="t" lIns="45720" rIns="45720">
+            <a:spAutoFit/>
+          </a:bodyPr>
+          <a:lstStyle/>
+          <a:p>
+            <a:pPr algn="l"/>
+            <a:r>
+              <a:rPr sz="1700" b="0" i="0">
+                <a:solidFill>
+                  <a:srgbClr val="595959"/>
+                </a:solidFill>
+                <a:latin typeface="Calibri"/>
+              </a:rPr>
+              <a:t>Five things to watch when hundreds of bankers and 30+ agents use this pattern</a:t>
             </a:r>
           </a:p>
         </p:txBody>
       </p:sp>
       <p:cxnSp>
         <p:nvCxnSpPr>
-          <p:cNvPr id="4" name="Connector 3"/>
+          <p:cNvPr id="5" name="Connector 4"/>
           <p:cNvCxnSpPr/>
           <p:nvPr/>
         </p:nvCxnSpPr>
         <p:spPr>
           <a:xfrm>
-            <a:off x="548640" y="1051560"/>
+            <a:off x="548640" y="1216152"/>
             <a:ext cx="11109960" cy="0"/>
           </a:xfrm>
           <a:prstGeom prst="line">
@@ -6778,14 +6813,96 @@
       </p:cxnSp>
       <p:sp>
         <p:nvSpPr>
-          <p:cNvPr id="5" name="TextBox 4"/>
+          <p:cNvPr id="6" name="Rounded Rectangle 5"/>
+          <p:cNvSpPr/>
+          <p:nvPr/>
+        </p:nvSpPr>
+        <p:spPr>
+          <a:xfrm>
+            <a:off x="548640" y="1298448"/>
+            <a:ext cx="11109960" cy="1179576"/>
+          </a:xfrm>
+          <a:prstGeom prst="roundRect">
+            <a:avLst>
+              <a:gd name="adj" fmla="val 8000"/>
+            </a:avLst>
+          </a:prstGeom>
+          <a:solidFill>
+            <a:srgbClr val="EAF1F8"/>
+          </a:solidFill>
+          <a:ln w="12700">
+            <a:solidFill>
+              <a:srgbClr val="1F4E79"/>
+            </a:solidFill>
+          </a:ln>
+        </p:spPr>
+        <p:style>
+          <a:lnRef idx="1">
+            <a:schemeClr val="accent1"/>
+          </a:lnRef>
+          <a:fillRef idx="3">
+            <a:schemeClr val="accent1"/>
+          </a:fillRef>
+          <a:effectRef idx="2">
+            <a:schemeClr val="accent1"/>
+          </a:effectRef>
+          <a:fontRef idx="minor">
+            <a:schemeClr val="lt1"/>
+          </a:fontRef>
+        </p:style>
+        <p:txBody>
+          <a:bodyPr rtlCol="0" anchor="ctr"/>
+          <a:lstStyle/>
+          <a:p>
+            <a:pPr algn="ctr"/>
+          </a:p>
+        </p:txBody>
+      </p:sp>
+      <p:sp>
+        <p:nvSpPr>
+          <p:cNvPr id="7" name="TextBox 6"/>
           <p:cNvSpPr txBox="1"/>
           <p:nvPr/>
         </p:nvSpPr>
         <p:spPr>
           <a:xfrm>
-            <a:off x="502920" y="6400800"/>
-            <a:ext cx="7315200" cy="320040"/>
+            <a:off x="640080" y="1298448"/>
+            <a:ext cx="685800" cy="1179576"/>
+          </a:xfrm>
+          <a:prstGeom prst="rect">
+            <a:avLst/>
+          </a:prstGeom>
+          <a:noFill/>
+        </p:spPr>
+        <p:txBody>
+          <a:bodyPr wrap="square" anchor="ctr" lIns="45720" rIns="45720">
+            <a:spAutoFit/>
+          </a:bodyPr>
+          <a:lstStyle/>
+          <a:p>
+            <a:pPr algn="ctr"/>
+            <a:r>
+              <a:rPr sz="3400" b="1" i="0">
+                <a:solidFill>
+                  <a:srgbClr val="1F4E79"/>
+                </a:solidFill>
+                <a:latin typeface="Calibri"/>
+              </a:rPr>
+              <a:t>1</a:t>
+            </a:r>
+          </a:p>
+        </p:txBody>
+      </p:sp>
+      <p:sp>
+        <p:nvSpPr>
+          <p:cNvPr id="8" name="TextBox 7"/>
+          <p:cNvSpPr txBox="1"/>
+          <p:nvPr/>
+        </p:nvSpPr>
+        <p:spPr>
+          <a:xfrm>
+            <a:off x="1417320" y="1344168"/>
+            <a:ext cx="10149840" cy="329184"/>
           </a:xfrm>
           <a:prstGeom prst="rect">
             <a:avLst/>
@@ -6800,27 +6917,172 @@
           <a:p>
             <a:pPr algn="l"/>
             <a:r>
-              <a:rPr sz="1000" b="0" i="0">
+              <a:rPr sz="1800" b="1" i="0">
+                <a:solidFill>
+                  <a:srgbClr val="1A1A1A"/>
+                </a:solidFill>
+                <a:latin typeface="Calibri"/>
+              </a:rPr>
+              <a:t>Every click uses the banker's own Salesforce limits</a:t>
+            </a:r>
+          </a:p>
+        </p:txBody>
+      </p:sp>
+      <p:sp>
+        <p:nvSpPr>
+          <p:cNvPr id="9" name="TextBox 8"/>
+          <p:cNvSpPr txBox="1"/>
+          <p:nvPr/>
+        </p:nvSpPr>
+        <p:spPr>
+          <a:xfrm>
+            <a:off x="1417320" y="1673351"/>
+            <a:ext cx="10149840" cy="786384"/>
+          </a:xfrm>
+          <a:prstGeom prst="rect">
+            <a:avLst/>
+          </a:prstGeom>
+          <a:noFill/>
+        </p:spPr>
+        <p:txBody>
+          <a:bodyPr wrap="square" lIns="45720" rIns="45720" tIns="0" bIns="0">
+            <a:spAutoFit/>
+          </a:bodyPr>
+          <a:lstStyle/>
+          <a:p>
+            <a:r>
+              <a:rPr sz="1600" b="1" i="0">
                 <a:solidFill>
                   <a:srgbClr val="595959"/>
                 </a:solidFill>
                 <a:latin typeface="Calibri"/>
               </a:rPr>
-              <a:t>Agentforce Banking Reference Implementation</a:t>
-            </a:r>
-          </a:p>
-        </p:txBody>
-      </p:sp>
-      <p:sp>
-        <p:nvSpPr>
-          <p:cNvPr id="6" name="TextBox 5"/>
+              <a:t>Why it matters: </a:t>
+            </a:r>
+            <a:r>
+              <a:rPr sz="1600" b="0" i="0">
+                <a:solidFill>
+                  <a:srgbClr val="1A1A1A"/>
+                </a:solidFill>
+                <a:latin typeface="Calibri"/>
+              </a:rPr>
+              <a:t>Gathering the facts runs extra database queries inside the banker's click. Too many at once and the click fails</a:t>
+            </a:r>
+          </a:p>
+          <a:p>
+            <a:r>
+              <a:rPr sz="1600" b="1" i="0">
+                <a:solidFill>
+                  <a:srgbClr val="1F4E79"/>
+                </a:solidFill>
+                <a:latin typeface="Calibri"/>
+              </a:rPr>
+              <a:t>What we do: </a:t>
+            </a:r>
+            <a:r>
+              <a:rPr sz="1600" b="0" i="0">
+                <a:solidFill>
+                  <a:srgbClr val="1A1A1A"/>
+                </a:solidFill>
+                <a:latin typeface="Calibri"/>
+              </a:rPr>
+              <a:t>Cap it at 3 meetings per click, and call the AI before saving anything</a:t>
+            </a:r>
+          </a:p>
+        </p:txBody>
+      </p:sp>
+      <p:sp>
+        <p:nvSpPr>
+          <p:cNvPr id="10" name="Rounded Rectangle 9"/>
+          <p:cNvSpPr/>
+          <p:nvPr/>
+        </p:nvSpPr>
+        <p:spPr>
+          <a:xfrm>
+            <a:off x="548640" y="2523744"/>
+            <a:ext cx="11109960" cy="932688"/>
+          </a:xfrm>
+          <a:prstGeom prst="roundRect">
+            <a:avLst>
+              <a:gd name="adj" fmla="val 8000"/>
+            </a:avLst>
+          </a:prstGeom>
+          <a:solidFill>
+            <a:srgbClr val="EAF1F8"/>
+          </a:solidFill>
+          <a:ln w="12700">
+            <a:solidFill>
+              <a:srgbClr val="1F4E79"/>
+            </a:solidFill>
+          </a:ln>
+        </p:spPr>
+        <p:style>
+          <a:lnRef idx="1">
+            <a:schemeClr val="accent1"/>
+          </a:lnRef>
+          <a:fillRef idx="3">
+            <a:schemeClr val="accent1"/>
+          </a:fillRef>
+          <a:effectRef idx="2">
+            <a:schemeClr val="accent1"/>
+          </a:effectRef>
+          <a:fontRef idx="minor">
+            <a:schemeClr val="lt1"/>
+          </a:fontRef>
+        </p:style>
+        <p:txBody>
+          <a:bodyPr rtlCol="0" anchor="ctr"/>
+          <a:lstStyle/>
+          <a:p>
+            <a:pPr algn="ctr"/>
+          </a:p>
+        </p:txBody>
+      </p:sp>
+      <p:sp>
+        <p:nvSpPr>
+          <p:cNvPr id="11" name="TextBox 10"/>
           <p:cNvSpPr txBox="1"/>
           <p:nvPr/>
         </p:nvSpPr>
         <p:spPr>
           <a:xfrm>
-            <a:off x="10698480" y="6400800"/>
-            <a:ext cx="1005840" cy="320040"/>
+            <a:off x="640080" y="2523744"/>
+            <a:ext cx="685800" cy="932688"/>
+          </a:xfrm>
+          <a:prstGeom prst="rect">
+            <a:avLst/>
+          </a:prstGeom>
+          <a:noFill/>
+        </p:spPr>
+        <p:txBody>
+          <a:bodyPr wrap="square" anchor="ctr" lIns="45720" rIns="45720">
+            <a:spAutoFit/>
+          </a:bodyPr>
+          <a:lstStyle/>
+          <a:p>
+            <a:pPr algn="ctr"/>
+            <a:r>
+              <a:rPr sz="3400" b="1" i="0">
+                <a:solidFill>
+                  <a:srgbClr val="1F4E79"/>
+                </a:solidFill>
+                <a:latin typeface="Calibri"/>
+              </a:rPr>
+              <a:t>2</a:t>
+            </a:r>
+          </a:p>
+        </p:txBody>
+      </p:sp>
+      <p:sp>
+        <p:nvSpPr>
+          <p:cNvPr id="12" name="TextBox 11"/>
+          <p:cNvSpPr txBox="1"/>
+          <p:nvPr/>
+        </p:nvSpPr>
+        <p:spPr>
+          <a:xfrm>
+            <a:off x="1417320" y="2569463"/>
+            <a:ext cx="10149840" cy="329184"/>
           </a:xfrm>
           <a:prstGeom prst="rect">
             <a:avLst/>
@@ -6833,6 +7095,679 @@
           </a:bodyPr>
           <a:lstStyle/>
           <a:p>
+            <a:pPr algn="l"/>
+            <a:r>
+              <a:rPr sz="1800" b="1" i="0">
+                <a:solidFill>
+                  <a:srgbClr val="1A1A1A"/>
+                </a:solidFill>
+                <a:latin typeface="Calibri"/>
+              </a:rPr>
+              <a:t>A summary takes about 7 seconds</a:t>
+            </a:r>
+          </a:p>
+        </p:txBody>
+      </p:sp>
+      <p:sp>
+        <p:nvSpPr>
+          <p:cNvPr id="13" name="TextBox 12"/>
+          <p:cNvSpPr txBox="1"/>
+          <p:nvPr/>
+        </p:nvSpPr>
+        <p:spPr>
+          <a:xfrm>
+            <a:off x="1417320" y="2898648"/>
+            <a:ext cx="10149840" cy="539496"/>
+          </a:xfrm>
+          <a:prstGeom prst="rect">
+            <a:avLst/>
+          </a:prstGeom>
+          <a:noFill/>
+        </p:spPr>
+        <p:txBody>
+          <a:bodyPr wrap="square" lIns="45720" rIns="45720" tIns="0" bIns="0">
+            <a:spAutoFit/>
+          </a:bodyPr>
+          <a:lstStyle/>
+          <a:p>
+            <a:r>
+              <a:rPr sz="1600" b="1" i="0">
+                <a:solidFill>
+                  <a:srgbClr val="595959"/>
+                </a:solidFill>
+                <a:latin typeface="Calibri"/>
+              </a:rPr>
+              <a:t>Why it matters: </a:t>
+            </a:r>
+            <a:r>
+              <a:rPr sz="1600" b="0" i="0">
+                <a:solidFill>
+                  <a:srgbClr val="1A1A1A"/>
+                </a:solidFill>
+                <a:latin typeface="Calibri"/>
+              </a:rPr>
+              <a:t>Up to 15 seconds if the AI has to try again. Bankers notice waits</a:t>
+            </a:r>
+          </a:p>
+          <a:p>
+            <a:r>
+              <a:rPr sz="1600" b="1" i="0">
+                <a:solidFill>
+                  <a:srgbClr val="1F4E79"/>
+                </a:solidFill>
+                <a:latin typeface="Calibri"/>
+              </a:rPr>
+              <a:t>What we do: </a:t>
+            </a:r>
+            <a:r>
+              <a:rPr sz="1600" b="0" i="0">
+                <a:solidFill>
+                  <a:srgbClr val="1A1A1A"/>
+                </a:solidFill>
+                <a:latin typeface="Calibri"/>
+              </a:rPr>
+              <a:t>Retry only once, and watch the slowest requests</a:t>
+            </a:r>
+          </a:p>
+        </p:txBody>
+      </p:sp>
+      <p:sp>
+        <p:nvSpPr>
+          <p:cNvPr id="14" name="Rounded Rectangle 13"/>
+          <p:cNvSpPr/>
+          <p:nvPr/>
+        </p:nvSpPr>
+        <p:spPr>
+          <a:xfrm>
+            <a:off x="548640" y="3502152"/>
+            <a:ext cx="11109960" cy="932688"/>
+          </a:xfrm>
+          <a:prstGeom prst="roundRect">
+            <a:avLst>
+              <a:gd name="adj" fmla="val 8000"/>
+            </a:avLst>
+          </a:prstGeom>
+          <a:solidFill>
+            <a:srgbClr val="EAF1F8"/>
+          </a:solidFill>
+          <a:ln w="12700">
+            <a:solidFill>
+              <a:srgbClr val="1F4E79"/>
+            </a:solidFill>
+          </a:ln>
+        </p:spPr>
+        <p:style>
+          <a:lnRef idx="1">
+            <a:schemeClr val="accent1"/>
+          </a:lnRef>
+          <a:fillRef idx="3">
+            <a:schemeClr val="accent1"/>
+          </a:fillRef>
+          <a:effectRef idx="2">
+            <a:schemeClr val="accent1"/>
+          </a:effectRef>
+          <a:fontRef idx="minor">
+            <a:schemeClr val="lt1"/>
+          </a:fontRef>
+        </p:style>
+        <p:txBody>
+          <a:bodyPr rtlCol="0" anchor="ctr"/>
+          <a:lstStyle/>
+          <a:p>
+            <a:pPr algn="ctr"/>
+          </a:p>
+        </p:txBody>
+      </p:sp>
+      <p:sp>
+        <p:nvSpPr>
+          <p:cNvPr id="15" name="TextBox 14"/>
+          <p:cNvSpPr txBox="1"/>
+          <p:nvPr/>
+        </p:nvSpPr>
+        <p:spPr>
+          <a:xfrm>
+            <a:off x="640080" y="3502152"/>
+            <a:ext cx="685800" cy="932688"/>
+          </a:xfrm>
+          <a:prstGeom prst="rect">
+            <a:avLst/>
+          </a:prstGeom>
+          <a:noFill/>
+        </p:spPr>
+        <p:txBody>
+          <a:bodyPr wrap="square" anchor="ctr" lIns="45720" rIns="45720">
+            <a:spAutoFit/>
+          </a:bodyPr>
+          <a:lstStyle/>
+          <a:p>
+            <a:pPr algn="ctr"/>
+            <a:r>
+              <a:rPr sz="3400" b="1" i="0">
+                <a:solidFill>
+                  <a:srgbClr val="1F4E79"/>
+                </a:solidFill>
+                <a:latin typeface="Calibri"/>
+              </a:rPr>
+              <a:t>3</a:t>
+            </a:r>
+          </a:p>
+        </p:txBody>
+      </p:sp>
+      <p:sp>
+        <p:nvSpPr>
+          <p:cNvPr id="16" name="TextBox 15"/>
+          <p:cNvSpPr txBox="1"/>
+          <p:nvPr/>
+        </p:nvSpPr>
+        <p:spPr>
+          <a:xfrm>
+            <a:off x="1417320" y="3547872"/>
+            <a:ext cx="10149840" cy="329184"/>
+          </a:xfrm>
+          <a:prstGeom prst="rect">
+            <a:avLst/>
+          </a:prstGeom>
+          <a:noFill/>
+        </p:spPr>
+        <p:txBody>
+          <a:bodyPr wrap="square" anchor="t" lIns="45720" rIns="45720">
+            <a:spAutoFit/>
+          </a:bodyPr>
+          <a:lstStyle/>
+          <a:p>
+            <a:pPr algn="l"/>
+            <a:r>
+              <a:rPr sz="1800" b="1" i="0">
+                <a:solidFill>
+                  <a:srgbClr val="1A1A1A"/>
+                </a:solidFill>
+                <a:latin typeface="Calibri"/>
+              </a:rPr>
+              <a:t>Every AI call costs money, and a retry costs double</a:t>
+            </a:r>
+          </a:p>
+        </p:txBody>
+      </p:sp>
+      <p:sp>
+        <p:nvSpPr>
+          <p:cNvPr id="17" name="TextBox 16"/>
+          <p:cNvSpPr txBox="1"/>
+          <p:nvPr/>
+        </p:nvSpPr>
+        <p:spPr>
+          <a:xfrm>
+            <a:off x="1417320" y="3877056"/>
+            <a:ext cx="10149840" cy="539496"/>
+          </a:xfrm>
+          <a:prstGeom prst="rect">
+            <a:avLst/>
+          </a:prstGeom>
+          <a:noFill/>
+        </p:spPr>
+        <p:txBody>
+          <a:bodyPr wrap="square" lIns="45720" rIns="45720" tIns="0" bIns="0">
+            <a:spAutoFit/>
+          </a:bodyPr>
+          <a:lstStyle/>
+          <a:p>
+            <a:r>
+              <a:rPr sz="1600" b="1" i="0">
+                <a:solidFill>
+                  <a:srgbClr val="595959"/>
+                </a:solidFill>
+                <a:latin typeface="Calibri"/>
+              </a:rPr>
+              <a:t>Why it matters: </a:t>
+            </a:r>
+            <a:r>
+              <a:rPr sz="1600" b="0" i="0">
+                <a:solidFill>
+                  <a:srgbClr val="1A1A1A"/>
+                </a:solidFill>
+                <a:latin typeface="Calibri"/>
+              </a:rPr>
+              <a:t>Usage grows with every banker and every agent</a:t>
+            </a:r>
+          </a:p>
+          <a:p>
+            <a:r>
+              <a:rPr sz="1600" b="1" i="0">
+                <a:solidFill>
+                  <a:srgbClr val="1F4E79"/>
+                </a:solidFill>
+                <a:latin typeface="Calibri"/>
+              </a:rPr>
+              <a:t>What we do: </a:t>
+            </a:r>
+            <a:r>
+              <a:rPr sz="1600" b="0" i="0">
+                <a:solidFill>
+                  <a:srgbClr val="1A1A1A"/>
+                </a:solidFill>
+                <a:latin typeface="Calibri"/>
+              </a:rPr>
+              <a:t>Retry only when the answer fails a check or the service glitches. Never retry permission errors</a:t>
+            </a:r>
+          </a:p>
+        </p:txBody>
+      </p:sp>
+      <p:sp>
+        <p:nvSpPr>
+          <p:cNvPr id="18" name="Rounded Rectangle 17"/>
+          <p:cNvSpPr/>
+          <p:nvPr/>
+        </p:nvSpPr>
+        <p:spPr>
+          <a:xfrm>
+            <a:off x="548640" y="4480560"/>
+            <a:ext cx="11109960" cy="932688"/>
+          </a:xfrm>
+          <a:prstGeom prst="roundRect">
+            <a:avLst>
+              <a:gd name="adj" fmla="val 8000"/>
+            </a:avLst>
+          </a:prstGeom>
+          <a:solidFill>
+            <a:srgbClr val="EAF1F8"/>
+          </a:solidFill>
+          <a:ln w="12700">
+            <a:solidFill>
+              <a:srgbClr val="1F4E79"/>
+            </a:solidFill>
+          </a:ln>
+        </p:spPr>
+        <p:style>
+          <a:lnRef idx="1">
+            <a:schemeClr val="accent1"/>
+          </a:lnRef>
+          <a:fillRef idx="3">
+            <a:schemeClr val="accent1"/>
+          </a:fillRef>
+          <a:effectRef idx="2">
+            <a:schemeClr val="accent1"/>
+          </a:effectRef>
+          <a:fontRef idx="minor">
+            <a:schemeClr val="lt1"/>
+          </a:fontRef>
+        </p:style>
+        <p:txBody>
+          <a:bodyPr rtlCol="0" anchor="ctr"/>
+          <a:lstStyle/>
+          <a:p>
+            <a:pPr algn="ctr"/>
+          </a:p>
+        </p:txBody>
+      </p:sp>
+      <p:sp>
+        <p:nvSpPr>
+          <p:cNvPr id="19" name="TextBox 18"/>
+          <p:cNvSpPr txBox="1"/>
+          <p:nvPr/>
+        </p:nvSpPr>
+        <p:spPr>
+          <a:xfrm>
+            <a:off x="640080" y="4480560"/>
+            <a:ext cx="685800" cy="932688"/>
+          </a:xfrm>
+          <a:prstGeom prst="rect">
+            <a:avLst/>
+          </a:prstGeom>
+          <a:noFill/>
+        </p:spPr>
+        <p:txBody>
+          <a:bodyPr wrap="square" anchor="ctr" lIns="45720" rIns="45720">
+            <a:spAutoFit/>
+          </a:bodyPr>
+          <a:lstStyle/>
+          <a:p>
+            <a:pPr algn="ctr"/>
+            <a:r>
+              <a:rPr sz="3400" b="1" i="0">
+                <a:solidFill>
+                  <a:srgbClr val="1F4E79"/>
+                </a:solidFill>
+                <a:latin typeface="Calibri"/>
+              </a:rPr>
+              <a:t>4</a:t>
+            </a:r>
+          </a:p>
+        </p:txBody>
+      </p:sp>
+      <p:sp>
+        <p:nvSpPr>
+          <p:cNvPr id="20" name="TextBox 19"/>
+          <p:cNvSpPr txBox="1"/>
+          <p:nvPr/>
+        </p:nvSpPr>
+        <p:spPr>
+          <a:xfrm>
+            <a:off x="1417320" y="4526280"/>
+            <a:ext cx="10149840" cy="329184"/>
+          </a:xfrm>
+          <a:prstGeom prst="rect">
+            <a:avLst/>
+          </a:prstGeom>
+          <a:noFill/>
+        </p:spPr>
+        <p:txBody>
+          <a:bodyPr wrap="square" anchor="t" lIns="45720" rIns="45720">
+            <a:spAutoFit/>
+          </a:bodyPr>
+          <a:lstStyle/>
+          <a:p>
+            <a:pPr algn="l"/>
+            <a:r>
+              <a:rPr sz="1800" b="1" i="0">
+                <a:solidFill>
+                  <a:srgbClr val="1A1A1A"/>
+                </a:solidFill>
+                <a:latin typeface="Calibri"/>
+              </a:rPr>
+              <a:t>The log keeps client data indefinitely</a:t>
+            </a:r>
+          </a:p>
+        </p:txBody>
+      </p:sp>
+      <p:sp>
+        <p:nvSpPr>
+          <p:cNvPr id="21" name="TextBox 20"/>
+          <p:cNvSpPr txBox="1"/>
+          <p:nvPr/>
+        </p:nvSpPr>
+        <p:spPr>
+          <a:xfrm>
+            <a:off x="1417320" y="4855464"/>
+            <a:ext cx="10149840" cy="539496"/>
+          </a:xfrm>
+          <a:prstGeom prst="rect">
+            <a:avLst/>
+          </a:prstGeom>
+          <a:noFill/>
+        </p:spPr>
+        <p:txBody>
+          <a:bodyPr wrap="square" lIns="45720" rIns="45720" tIns="0" bIns="0">
+            <a:spAutoFit/>
+          </a:bodyPr>
+          <a:lstStyle/>
+          <a:p>
+            <a:r>
+              <a:rPr sz="1600" b="1" i="0">
+                <a:solidFill>
+                  <a:srgbClr val="595959"/>
+                </a:solidFill>
+                <a:latin typeface="Calibri"/>
+              </a:rPr>
+              <a:t>Why it matters: </a:t>
+            </a:r>
+            <a:r>
+              <a:rPr sz="1600" b="0" i="0">
+                <a:solidFill>
+                  <a:srgbClr val="1A1A1A"/>
+                </a:solidFill>
+                <a:latin typeface="Calibri"/>
+              </a:rPr>
+              <a:t>Raw AI output contains client details, and bank policy limits how long that can be kept</a:t>
+            </a:r>
+          </a:p>
+          <a:p>
+            <a:r>
+              <a:rPr sz="1600" b="1" i="0">
+                <a:solidFill>
+                  <a:srgbClr val="1F4E79"/>
+                </a:solidFill>
+                <a:latin typeface="Calibri"/>
+              </a:rPr>
+              <a:t>What we do: </a:t>
+            </a:r>
+            <a:r>
+              <a:rPr sz="1600" b="0" i="0">
+                <a:solidFill>
+                  <a:srgbClr val="1A1A1A"/>
+                </a:solidFill>
+                <a:latin typeface="Calibri"/>
+              </a:rPr>
+              <a:t>Agree a retention period. A scheduled job clears old raw text but keeps the stats</a:t>
+            </a:r>
+          </a:p>
+        </p:txBody>
+      </p:sp>
+      <p:sp>
+        <p:nvSpPr>
+          <p:cNvPr id="22" name="Rounded Rectangle 21"/>
+          <p:cNvSpPr/>
+          <p:nvPr/>
+        </p:nvSpPr>
+        <p:spPr>
+          <a:xfrm>
+            <a:off x="548640" y="5458968"/>
+            <a:ext cx="11109960" cy="932688"/>
+          </a:xfrm>
+          <a:prstGeom prst="roundRect">
+            <a:avLst>
+              <a:gd name="adj" fmla="val 8000"/>
+            </a:avLst>
+          </a:prstGeom>
+          <a:solidFill>
+            <a:srgbClr val="EAF1F8"/>
+          </a:solidFill>
+          <a:ln w="12700">
+            <a:solidFill>
+              <a:srgbClr val="1F4E79"/>
+            </a:solidFill>
+          </a:ln>
+        </p:spPr>
+        <p:style>
+          <a:lnRef idx="1">
+            <a:schemeClr val="accent1"/>
+          </a:lnRef>
+          <a:fillRef idx="3">
+            <a:schemeClr val="accent1"/>
+          </a:fillRef>
+          <a:effectRef idx="2">
+            <a:schemeClr val="accent1"/>
+          </a:effectRef>
+          <a:fontRef idx="minor">
+            <a:schemeClr val="lt1"/>
+          </a:fontRef>
+        </p:style>
+        <p:txBody>
+          <a:bodyPr rtlCol="0" anchor="ctr"/>
+          <a:lstStyle/>
+          <a:p>
+            <a:pPr algn="ctr"/>
+          </a:p>
+        </p:txBody>
+      </p:sp>
+      <p:sp>
+        <p:nvSpPr>
+          <p:cNvPr id="23" name="TextBox 22"/>
+          <p:cNvSpPr txBox="1"/>
+          <p:nvPr/>
+        </p:nvSpPr>
+        <p:spPr>
+          <a:xfrm>
+            <a:off x="640080" y="5458968"/>
+            <a:ext cx="685800" cy="932688"/>
+          </a:xfrm>
+          <a:prstGeom prst="rect">
+            <a:avLst/>
+          </a:prstGeom>
+          <a:noFill/>
+        </p:spPr>
+        <p:txBody>
+          <a:bodyPr wrap="square" anchor="ctr" lIns="45720" rIns="45720">
+            <a:spAutoFit/>
+          </a:bodyPr>
+          <a:lstStyle/>
+          <a:p>
+            <a:pPr algn="ctr"/>
+            <a:r>
+              <a:rPr sz="3400" b="1" i="0">
+                <a:solidFill>
+                  <a:srgbClr val="1F4E79"/>
+                </a:solidFill>
+                <a:latin typeface="Calibri"/>
+              </a:rPr>
+              <a:t>5</a:t>
+            </a:r>
+          </a:p>
+        </p:txBody>
+      </p:sp>
+      <p:sp>
+        <p:nvSpPr>
+          <p:cNvPr id="24" name="TextBox 23"/>
+          <p:cNvSpPr txBox="1"/>
+          <p:nvPr/>
+        </p:nvSpPr>
+        <p:spPr>
+          <a:xfrm>
+            <a:off x="1417320" y="5504688"/>
+            <a:ext cx="10149840" cy="329184"/>
+          </a:xfrm>
+          <a:prstGeom prst="rect">
+            <a:avLst/>
+          </a:prstGeom>
+          <a:noFill/>
+        </p:spPr>
+        <p:txBody>
+          <a:bodyPr wrap="square" anchor="t" lIns="45720" rIns="45720">
+            <a:spAutoFit/>
+          </a:bodyPr>
+          <a:lstStyle/>
+          <a:p>
+            <a:pPr algn="l"/>
+            <a:r>
+              <a:rPr sz="1800" b="1" i="0">
+                <a:solidFill>
+                  <a:srgbClr val="1A1A1A"/>
+                </a:solidFill>
+                <a:latin typeface="Calibri"/>
+              </a:rPr>
+              <a:t>The "wrong client" check stops at 2,000 names</a:t>
+            </a:r>
+          </a:p>
+        </p:txBody>
+      </p:sp>
+      <p:sp>
+        <p:nvSpPr>
+          <p:cNvPr id="25" name="TextBox 24"/>
+          <p:cNvSpPr txBox="1"/>
+          <p:nvPr/>
+        </p:nvSpPr>
+        <p:spPr>
+          <a:xfrm>
+            <a:off x="1417320" y="5833872"/>
+            <a:ext cx="10149840" cy="539496"/>
+          </a:xfrm>
+          <a:prstGeom prst="rect">
+            <a:avLst/>
+          </a:prstGeom>
+          <a:noFill/>
+        </p:spPr>
+        <p:txBody>
+          <a:bodyPr wrap="square" lIns="45720" rIns="45720" tIns="0" bIns="0">
+            <a:spAutoFit/>
+          </a:bodyPr>
+          <a:lstStyle/>
+          <a:p>
+            <a:r>
+              <a:rPr sz="1600" b="1" i="0">
+                <a:solidFill>
+                  <a:srgbClr val="595959"/>
+                </a:solidFill>
+                <a:latin typeface="Calibri"/>
+              </a:rPr>
+              <a:t>Why it matters: </a:t>
+            </a:r>
+            <a:r>
+              <a:rPr sz="1600" b="0" i="0">
+                <a:solidFill>
+                  <a:srgbClr val="1A1A1A"/>
+                </a:solidFill>
+                <a:latin typeface="Calibri"/>
+              </a:rPr>
+              <a:t>A large bank has more clients than that, so some names wouldn't be checked</a:t>
+            </a:r>
+          </a:p>
+          <a:p>
+            <a:r>
+              <a:rPr sz="1600" b="1" i="0">
+                <a:solidFill>
+                  <a:srgbClr val="1F4E79"/>
+                </a:solidFill>
+                <a:latin typeface="Calibri"/>
+              </a:rPr>
+              <a:t>What we do: </a:t>
+            </a:r>
+            <a:r>
+              <a:rPr sz="1600" b="0" i="0">
+                <a:solidFill>
+                  <a:srgbClr val="1A1A1A"/>
+                </a:solidFill>
+                <a:latin typeface="Calibri"/>
+              </a:rPr>
+              <a:t>Every time the cap is hit, it's now logged. Next: look up only the names in the question</a:t>
+            </a:r>
+          </a:p>
+        </p:txBody>
+      </p:sp>
+      <p:sp>
+        <p:nvSpPr>
+          <p:cNvPr id="26" name="TextBox 25"/>
+          <p:cNvSpPr txBox="1"/>
+          <p:nvPr/>
+        </p:nvSpPr>
+        <p:spPr>
+          <a:xfrm>
+            <a:off x="502920" y="6400800"/>
+            <a:ext cx="8686800" cy="320040"/>
+          </a:xfrm>
+          <a:prstGeom prst="rect">
+            <a:avLst/>
+          </a:prstGeom>
+          <a:noFill/>
+        </p:spPr>
+        <p:txBody>
+          <a:bodyPr wrap="square" anchor="t" lIns="45720" rIns="45720">
+            <a:spAutoFit/>
+          </a:bodyPr>
+          <a:lstStyle/>
+          <a:p>
+            <a:pPr algn="l"/>
+            <a:r>
+              <a:rPr sz="1100" b="0" i="1">
+                <a:solidFill>
+                  <a:srgbClr val="595959"/>
+                </a:solidFill>
+                <a:latin typeface="Calibri"/>
+              </a:rPr>
+              <a:t>Measured on this build, not load-tested. All 13 risks are in SCALABILITY_RISKS.md.</a:t>
+            </a:r>
+          </a:p>
+        </p:txBody>
+      </p:sp>
+      <p:sp>
+        <p:nvSpPr>
+          <p:cNvPr id="27" name="TextBox 26"/>
+          <p:cNvSpPr txBox="1"/>
+          <p:nvPr/>
+        </p:nvSpPr>
+        <p:spPr>
+          <a:xfrm>
+            <a:off x="10698480" y="6400800"/>
+            <a:ext cx="1005840" cy="320040"/>
+          </a:xfrm>
+          <a:prstGeom prst="rect">
+            <a:avLst/>
+          </a:prstGeom>
+          <a:noFill/>
+        </p:spPr>
+        <p:txBody>
+          <a:bodyPr wrap="square" anchor="t" lIns="45720" rIns="45720">
+            <a:spAutoFit/>
+          </a:bodyPr>
+          <a:lstStyle/>
+          <a:p>
             <a:pPr algn="r"/>
             <a:r>
               <a:rPr sz="1000" b="0" i="0">
@@ -6846,308 +7781,6 @@
           </a:p>
         </p:txBody>
       </p:sp>
-      <p:graphicFrame>
-        <p:nvGraphicFramePr>
-          <p:cNvPr id="7" name="Table 6"/>
-          <p:cNvGraphicFramePr>
-            <a:graphicFrameLocks noGrp="1"/>
-          </p:cNvGraphicFramePr>
-          <p:nvPr/>
-        </p:nvGraphicFramePr>
-        <p:xfrm>
-          <a:off x="548640" y="1325880"/>
-          <a:ext cx="11109960" cy="3950208"/>
-        </p:xfrm>
-        <a:graphic>
-          <a:graphicData uri="http://schemas.openxmlformats.org/drawingml/2006/table">
-            <a:tbl>
-              <a:tblPr firstRow="1" bandRow="1">
-                <a:tableStyleId>{5C22544A-7EE6-4342-B048-85BDC9FD1C3A}</a:tableStyleId>
-              </a:tblPr>
-              <a:tblGrid>
-                <a:gridCol w="6949440"/>
-                <a:gridCol w="4160520"/>
-              </a:tblGrid>
-              <a:tr h="658368">
-                <a:tc>
-                  <a:txBody>
-                    <a:bodyPr wrap="square"/>
-                    <a:lstStyle/>
-                    <a:p>
-                      <a:r>
-                        <a:rPr sz="1500" b="1" i="0">
-                          <a:solidFill>
-                            <a:srgbClr val="FFFFFF"/>
-                          </a:solidFill>
-                          <a:latin typeface="Calibri"/>
-                        </a:rPr>
-                        <a:t>Risk</a:t>
-                      </a:r>
-                    </a:p>
-                  </a:txBody>
-                  <a:tcPr marL="73152" marR="73152" marT="36576" marB="36576" anchor="ctr">
-                    <a:solidFill>
-                      <a:srgbClr val="1F4E79"/>
-                    </a:solidFill>
-                  </a:tcPr>
-                </a:tc>
-                <a:tc>
-                  <a:txBody>
-                    <a:bodyPr wrap="square"/>
-                    <a:lstStyle/>
-                    <a:p>
-                      <a:r>
-                        <a:rPr sz="1500" b="1" i="0">
-                          <a:solidFill>
-                            <a:srgbClr val="FFFFFF"/>
-                          </a:solidFill>
-                          <a:latin typeface="Calibri"/>
-                        </a:rPr>
-                        <a:t>Mitigation</a:t>
-                      </a:r>
-                    </a:p>
-                  </a:txBody>
-                  <a:tcPr marL="73152" marR="73152" marT="36576" marB="36576" anchor="ctr">
-                    <a:solidFill>
-                      <a:srgbClr val="1F4E79"/>
-                    </a:solidFill>
-                  </a:tcPr>
-                </a:tc>
-              </a:tr>
-              <a:tr h="658368">
-                <a:tc>
-                  <a:txBody>
-                    <a:bodyPr wrap="square"/>
-                    <a:lstStyle/>
-                    <a:p>
-                      <a:r>
-                        <a:rPr sz="1500" b="0" i="0">
-                          <a:solidFill>
-                            <a:srgbClr val="1A1A1A"/>
-                          </a:solidFill>
-                          <a:latin typeface="Calibri"/>
-                        </a:rPr>
-                        <a:t>Grounding adds +5 SOQL and 0.5–0.7 s CPU per call to the banker's transaction</a:t>
-                      </a:r>
-                    </a:p>
-                  </a:txBody>
-                  <a:tcPr marL="73152" marR="73152" marT="36576" marB="36576" anchor="ctr">
-                    <a:solidFill>
-                      <a:srgbClr val="FFFFFF"/>
-                    </a:solidFill>
-                  </a:tcPr>
-                </a:tc>
-                <a:tc>
-                  <a:txBody>
-                    <a:bodyPr wrap="square"/>
-                    <a:lstStyle/>
-                    <a:p>
-                      <a:r>
-                        <a:rPr sz="1500" b="0" i="0">
-                          <a:solidFill>
-                            <a:srgbClr val="1A1A1A"/>
-                          </a:solidFill>
-                          <a:latin typeface="Calibri"/>
-                        </a:rPr>
-                        <a:t>MAX_PER_CALL = 3; LLM before DML</a:t>
-                      </a:r>
-                    </a:p>
-                  </a:txBody>
-                  <a:tcPr marL="73152" marR="73152" marT="36576" marB="36576" anchor="ctr">
-                    <a:solidFill>
-                      <a:srgbClr val="FFFFFF"/>
-                    </a:solidFill>
-                  </a:tcPr>
-                </a:tc>
-              </a:tr>
-              <a:tr h="658368">
-                <a:tc>
-                  <a:txBody>
-                    <a:bodyPr wrap="square"/>
-                    <a:lstStyle/>
-                    <a:p>
-                      <a:r>
-                        <a:rPr sz="1500" b="0" i="0">
-                          <a:solidFill>
-                            <a:srgbClr val="1A1A1A"/>
-                          </a:solidFill>
-                          <a:latin typeface="Calibri"/>
-                        </a:rPr>
-                        <a:t>Summary latency: median 7.2 s, 14.6 s with a retry</a:t>
-                      </a:r>
-                    </a:p>
-                  </a:txBody>
-                  <a:tcPr marL="73152" marR="73152" marT="36576" marB="36576" anchor="ctr">
-                    <a:solidFill>
-                      <a:srgbClr val="EAF1F8"/>
-                    </a:solidFill>
-                  </a:tcPr>
-                </a:tc>
-                <a:tc>
-                  <a:txBody>
-                    <a:bodyPr wrap="square"/>
-                    <a:lstStyle/>
-                    <a:p>
-                      <a:r>
-                        <a:rPr sz="1500" b="0" i="0">
-                          <a:solidFill>
-                            <a:srgbClr val="1A1A1A"/>
-                          </a:solidFill>
-                          <a:latin typeface="Calibri"/>
-                        </a:rPr>
-                        <a:t>One retry only; track p95</a:t>
-                      </a:r>
-                    </a:p>
-                  </a:txBody>
-                  <a:tcPr marL="73152" marR="73152" marT="36576" marB="36576" anchor="ctr">
-                    <a:solidFill>
-                      <a:srgbClr val="EAF1F8"/>
-                    </a:solidFill>
-                  </a:tcPr>
-                </a:tc>
-              </a:tr>
-              <a:tr h="658368">
-                <a:tc>
-                  <a:txBody>
-                    <a:bodyPr wrap="square"/>
-                    <a:lstStyle/>
-                    <a:p>
-                      <a:r>
-                        <a:rPr sz="1500" b="0" i="0">
-                          <a:solidFill>
-                            <a:srgbClr val="1A1A1A"/>
-                          </a:solidFill>
-                          <a:latin typeface="Calibri"/>
-                        </a:rPr>
-                        <a:t>Einstein consumption scales with use; a retry doubles it</a:t>
-                      </a:r>
-                    </a:p>
-                  </a:txBody>
-                  <a:tcPr marL="73152" marR="73152" marT="36576" marB="36576" anchor="ctr">
-                    <a:solidFill>
-                      <a:srgbClr val="FFFFFF"/>
-                    </a:solidFill>
-                  </a:tcPr>
-                </a:tc>
-                <a:tc>
-                  <a:txBody>
-                    <a:bodyPr wrap="square"/>
-                    <a:lstStyle/>
-                    <a:p>
-                      <a:r>
-                        <a:rPr sz="1500" b="0" i="0">
-                          <a:solidFill>
-                            <a:srgbClr val="1A1A1A"/>
-                          </a:solidFill>
-                          <a:latin typeface="Calibri"/>
-                        </a:rPr>
-                        <a:t>Retry only invalid or transient</a:t>
-                      </a:r>
-                    </a:p>
-                  </a:txBody>
-                  <a:tcPr marL="73152" marR="73152" marT="36576" marB="36576" anchor="ctr">
-                    <a:solidFill>
-                      <a:srgbClr val="FFFFFF"/>
-                    </a:solidFill>
-                  </a:tcPr>
-                </a:tc>
-              </a:tr>
-              <a:tr h="658368">
-                <a:tc>
-                  <a:txBody>
-                    <a:bodyPr wrap="square"/>
-                    <a:lstStyle/>
-                    <a:p>
-                      <a:r>
-                        <a:rPr sz="1500" b="0" i="0">
-                          <a:solidFill>
-                            <a:srgbClr val="1A1A1A"/>
-                          </a:solidFill>
-                          <a:latin typeface="Calibri"/>
-                        </a:rPr>
-                        <a:t>Log holds raw client data; no purge job yet</a:t>
-                      </a:r>
-                    </a:p>
-                  </a:txBody>
-                  <a:tcPr marL="73152" marR="73152" marT="36576" marB="36576" anchor="ctr">
-                    <a:solidFill>
-                      <a:srgbClr val="EAF1F8"/>
-                    </a:solidFill>
-                  </a:tcPr>
-                </a:tc>
-                <a:tc>
-                  <a:txBody>
-                    <a:bodyPr wrap="square"/>
-                    <a:lstStyle/>
-                    <a:p>
-                      <a:r>
-                        <a:rPr sz="1500" b="0" i="0">
-                          <a:solidFill>
-                            <a:srgbClr val="1A1A1A"/>
-                          </a:solidFill>
-                          <a:latin typeface="Calibri"/>
-                        </a:rPr>
-                        <a:t>Retention policy and purge batch</a:t>
-                      </a:r>
-                    </a:p>
-                  </a:txBody>
-                  <a:tcPr marL="73152" marR="73152" marT="36576" marB="36576" anchor="ctr">
-                    <a:solidFill>
-                      <a:srgbClr val="EAF1F8"/>
-                    </a:solidFill>
-                  </a:tcPr>
-                </a:tc>
-              </a:tr>
-              <a:tr h="658368">
-                <a:tc>
-                  <a:txBody>
-                    <a:bodyPr wrap="square"/>
-                    <a:lstStyle/>
-                    <a:p>
-                      <a:r>
-                        <a:rPr sz="1500" b="0" i="0">
-                          <a:solidFill>
-                            <a:srgbClr val="1A1A1A"/>
-                          </a:solidFill>
-                          <a:latin typeface="Calibri"/>
-                        </a:rPr>
-                        <a:t>Cross-client name list capped at 2,000</a:t>
-                      </a:r>
-                    </a:p>
-                  </a:txBody>
-                  <a:tcPr marL="73152" marR="73152" marT="36576" marB="36576" anchor="ctr">
-                    <a:solidFill>
-                      <a:srgbClr val="FFFFFF"/>
-                    </a:solidFill>
-                  </a:tcPr>
-                </a:tc>
-                <a:tc>
-                  <a:txBody>
-                    <a:bodyPr wrap="square"/>
-                    <a:lstStyle/>
-                    <a:p>
-                      <a:r>
-                        <a:rPr sz="1500" b="0" i="0">
-                          <a:solidFill>
-                            <a:srgbClr val="1A1A1A"/>
-                          </a:solidFill>
-                          <a:latin typeface="Calibri"/>
-                        </a:rPr>
-                        <a:t>Cap logged; look up only names used</a:t>
-                      </a:r>
-                    </a:p>
-                  </a:txBody>
-                  <a:tcPr marL="73152" marR="73152" marT="36576" marB="36576" anchor="ctr">
-                    <a:solidFill>
-                      <a:srgbClr val="FFFFFF"/>
-                    </a:solidFill>
-                  </a:tcPr>
-                </a:tc>
-              </a:tr>
-            </a:tbl>
-          </a:graphicData>
-        </a:graphic>
-      </p:graphicFrame>
     </p:spTree>
   </p:cSld>
   <p:clrMapOvr>

</xml_diff>

<commit_message>
Updated files for formatting and consistency
</commit_message>
<xml_diff>
--- a/docs/Panel_Overview.pptx
+++ b/docs/Panel_Overview.pptx
@@ -6,7 +6,7 @@
     <p:sldMasterId id="2147483660" r:id="rId2"/>
   </p:sldMasterIdLst>
   <p:notesMasterIdLst>
-    <p:notesMasterId r:id="rId20"/>
+    <p:notesMasterId r:id="rId21"/>
   </p:notesMasterIdLst>
   <p:sldIdLst>
     <p:sldId id="256" r:id="rId3"/>
@@ -25,7 +25,8 @@
     <p:sldId id="273" r:id="rId16"/>
     <p:sldId id="275" r:id="rId17"/>
     <p:sldId id="276" r:id="rId18"/>
-    <p:sldId id="281" r:id="rId19"/>
+    <p:sldId id="288" r:id="rId19"/>
+    <p:sldId id="281" r:id="rId20"/>
   </p:sldIdLst>
   <p:sldSz cx="12192000" cy="6858000"/>
   <p:notesSz cx="6858000" cy="9144000"/>
@@ -724,6 +725,93 @@
             <a:fld id="{F7021451-1387-4CA6-816F-3879F97B5CBC}" type="slidenum">
               <a:rPr lang="en-US"/>
               <a:t>16</a:t>
+            </a:fld>
+            <a:endParaRPr lang="en-US"/>
+          </a:p>
+        </p:txBody>
+      </p:sp>
+    </p:spTree>
+    <p:extLst>
+      <p:ext uri="{BB962C8B-B14F-4D97-AF65-F5344CB8AC3E}">
+        <p14:creationId xmlns:p14="http://schemas.microsoft.com/office/powerpoint/2010/main" val="1024086991"/>
+      </p:ext>
+    </p:extLst>
+  </p:cSld>
+  <p:clrMapOvr>
+    <a:masterClrMapping/>
+  </p:clrMapOvr>
+</p:notes>
+</file>
+
+<file path=ppt/notesSlides/notesSlide14.xml><?xml version="1.0" encoding="utf-8"?>
+<p:notes xmlns:a="http://schemas.openxmlformats.org/drawingml/2006/main" xmlns:r="http://schemas.openxmlformats.org/officeDocument/2006/relationships" xmlns:p="http://schemas.openxmlformats.org/presentationml/2006/main">
+  <p:cSld>
+    <p:spTree>
+      <p:nvGrpSpPr>
+        <p:cNvPr id="1" name=""/>
+        <p:cNvGrpSpPr/>
+        <p:nvPr/>
+      </p:nvGrpSpPr>
+      <p:grpSpPr>
+        <a:xfrm>
+          <a:off x="0" y="0"/>
+          <a:ext cx="0" cy="0"/>
+          <a:chOff x="0" y="0"/>
+          <a:chExt cx="0" cy="0"/>
+        </a:xfrm>
+      </p:grpSpPr>
+      <p:sp>
+        <p:nvSpPr>
+          <p:cNvPr id="2" name="Slide Image Placeholder 1"/>
+          <p:cNvSpPr>
+            <a:spLocks noGrp="1" noRot="1" noChangeAspect="1"/>
+          </p:cNvSpPr>
+          <p:nvPr>
+            <p:ph type="sldImg"/>
+          </p:nvPr>
+        </p:nvSpPr>
+        <p:spPr/>
+      </p:sp>
+      <p:sp>
+        <p:nvSpPr>
+          <p:cNvPr id="3" name="Notes Placeholder 2"/>
+          <p:cNvSpPr>
+            <a:spLocks noGrp="1"/>
+          </p:cNvSpPr>
+          <p:nvPr>
+            <p:ph type="body" idx="1"/>
+          </p:nvPr>
+        </p:nvSpPr>
+        <p:spPr/>
+        <p:txBody>
+          <a:bodyPr/>
+          <a:lstStyle/>
+          <a:p>
+            <a:r>
+              <a:rPr lang="en-US" dirty="0"/>
+              <a:t>These are next steps, not features of this build. Salesforce announced Headless 360 at TDX in April and AIforce at Dreamforce in September. Together they let the same agent be reached from Slack, Claude, Agentforce Coworker or any app through APIs and MCP tools. The reason my design is ready for that is that none of the guarantees live in the chat window: the facts, the checks, the fallback and the log are all in Salesforce Apex, so wherever the question comes from, the same code answers as that banker. What I'd test first: the display layer, because I already saw the Lightning chat trim and replay results, and the new Experience Layer may fix that; that the banker's own identity carries through rather than a shared integration user; and request consumption per channel. Salesforce in Claude is in beta, so I'd treat all of this as a pilot.</a:t>
+            </a:r>
+          </a:p>
+        </p:txBody>
+      </p:sp>
+      <p:sp>
+        <p:nvSpPr>
+          <p:cNvPr id="4" name="Slide Number Placeholder 3"/>
+          <p:cNvSpPr>
+            <a:spLocks noGrp="1"/>
+          </p:cNvSpPr>
+          <p:nvPr>
+            <p:ph type="sldNum" sz="quarter" idx="10"/>
+          </p:nvPr>
+        </p:nvSpPr>
+        <p:spPr/>
+        <p:txBody>
+          <a:bodyPr/>
+          <a:lstStyle/>
+          <a:p>
+            <a:fld id="{F7021451-1387-4CA6-816F-3879F97B5CBC}" type="slidenum">
+              <a:rPr lang="en-US"/>
+              <a:t>17</a:t>
             </a:fld>
             <a:endParaRPr lang="en-US"/>
           </a:p>
@@ -1559,7 +1647,7 @@
           <a:p>
             <a:fld id="{5BCAD085-E8A6-8845-BD4E-CB4CCA059FC4}" type="datetimeFigureOut">
               <a:rPr lang="en-US" smtClean="0"/>
-              <a:t>10/14/2026</a:t>
+              <a:t>10/15/2026</a:t>
             </a:fld>
             <a:endParaRPr lang="en-US"/>
           </a:p>
@@ -1727,7 +1815,7 @@
           <a:p>
             <a:fld id="{5BCAD085-E8A6-8845-BD4E-CB4CCA059FC4}" type="datetimeFigureOut">
               <a:rPr lang="en-US" smtClean="0"/>
-              <a:t>10/14/2026</a:t>
+              <a:t>10/15/2026</a:t>
             </a:fld>
             <a:endParaRPr lang="en-US"/>
           </a:p>
@@ -1905,7 +1993,7 @@
           <a:p>
             <a:fld id="{5BCAD085-E8A6-8845-BD4E-CB4CCA059FC4}" type="datetimeFigureOut">
               <a:rPr lang="en-US" smtClean="0"/>
-              <a:t>10/14/2026</a:t>
+              <a:t>10/15/2026</a:t>
             </a:fld>
             <a:endParaRPr lang="en-US"/>
           </a:p>
@@ -2143,7 +2231,7 @@
           <a:p>
             <a:fld id="{5BCAD085-E8A6-8845-BD4E-CB4CCA059FC4}" type="datetimeFigureOut">
               <a:rPr lang="en-US" smtClean="0"/>
-              <a:t>10/14/2026</a:t>
+              <a:t>10/15/2026</a:t>
             </a:fld>
             <a:endParaRPr lang="en-US"/>
           </a:p>
@@ -2388,7 +2476,7 @@
           <a:p>
             <a:fld id="{5BCAD085-E8A6-8845-BD4E-CB4CCA059FC4}" type="datetimeFigureOut">
               <a:rPr lang="en-US" smtClean="0"/>
-              <a:t>10/14/2026</a:t>
+              <a:t>10/15/2026</a:t>
             </a:fld>
             <a:endParaRPr lang="en-US"/>
           </a:p>
@@ -2673,7 +2761,7 @@
           <a:p>
             <a:fld id="{5BCAD085-E8A6-8845-BD4E-CB4CCA059FC4}" type="datetimeFigureOut">
               <a:rPr lang="en-US" smtClean="0"/>
-              <a:t>10/14/2026</a:t>
+              <a:t>10/15/2026</a:t>
             </a:fld>
             <a:endParaRPr lang="en-US"/>
           </a:p>
@@ -3092,7 +3180,7 @@
           <a:p>
             <a:fld id="{5BCAD085-E8A6-8845-BD4E-CB4CCA059FC4}" type="datetimeFigureOut">
               <a:rPr lang="en-US" smtClean="0"/>
-              <a:t>10/14/2026</a:t>
+              <a:t>10/15/2026</a:t>
             </a:fld>
             <a:endParaRPr lang="en-US"/>
           </a:p>
@@ -3209,7 +3297,7 @@
           <a:p>
             <a:fld id="{5BCAD085-E8A6-8845-BD4E-CB4CCA059FC4}" type="datetimeFigureOut">
               <a:rPr lang="en-US" smtClean="0"/>
-              <a:t>10/14/2026</a:t>
+              <a:t>10/15/2026</a:t>
             </a:fld>
             <a:endParaRPr lang="en-US"/>
           </a:p>
@@ -3304,7 +3392,7 @@
           <a:p>
             <a:fld id="{5BCAD085-E8A6-8845-BD4E-CB4CCA059FC4}" type="datetimeFigureOut">
               <a:rPr lang="en-US" smtClean="0"/>
-              <a:t>10/14/2026</a:t>
+              <a:t>10/15/2026</a:t>
             </a:fld>
             <a:endParaRPr lang="en-US"/>
           </a:p>
@@ -3579,7 +3667,7 @@
           <a:p>
             <a:fld id="{5BCAD085-E8A6-8845-BD4E-CB4CCA059FC4}" type="datetimeFigureOut">
               <a:rPr lang="en-US" smtClean="0"/>
-              <a:t>10/14/2026</a:t>
+              <a:t>10/15/2026</a:t>
             </a:fld>
             <a:endParaRPr lang="en-US"/>
           </a:p>
@@ -3831,7 +3919,7 @@
           <a:p>
             <a:fld id="{5BCAD085-E8A6-8845-BD4E-CB4CCA059FC4}" type="datetimeFigureOut">
               <a:rPr lang="en-US" smtClean="0"/>
-              <a:t>10/14/2026</a:t>
+              <a:t>10/15/2026</a:t>
             </a:fld>
             <a:endParaRPr lang="en-US"/>
           </a:p>
@@ -4042,7 +4130,7 @@
           <a:p>
             <a:fld id="{5BCAD085-E8A6-8845-BD4E-CB4CCA059FC4}" type="datetimeFigureOut">
               <a:rPr lang="en-US" smtClean="0"/>
-              <a:t>10/14/2026</a:t>
+              <a:t>10/15/2026</a:t>
             </a:fld>
             <a:endParaRPr lang="en-US"/>
           </a:p>
@@ -4929,41 +5017,6 @@
       </p:sp>
       <p:sp>
         <p:nvSpPr>
-          <p:cNvPr id="7" name="TextBox 6"/>
-          <p:cNvSpPr txBox="1"/>
-          <p:nvPr/>
-        </p:nvSpPr>
-        <p:spPr>
-          <a:xfrm>
-            <a:off x="5303520" y="5394960"/>
-            <a:ext cx="6400800" cy="365760"/>
-          </a:xfrm>
-          <a:prstGeom prst="rect">
-            <a:avLst/>
-          </a:prstGeom>
-          <a:noFill/>
-        </p:spPr>
-        <p:txBody>
-          <a:bodyPr wrap="square" lIns="45720" rIns="45720" anchor="t">
-            <a:spAutoFit/>
-          </a:bodyPr>
-          <a:lstStyle/>
-          <a:p>
-            <a:pPr algn="l"/>
-            <a:r>
-              <a:rPr sz="1200" b="0" i="0">
-                <a:solidFill>
-                  <a:srgbClr val="595959"/>
-                </a:solidFill>
-                <a:latin typeface="Calibri"/>
-              </a:rPr>
-              <a:t>Version 1.0  ·  Approved  ·  2026-10-14</a:t>
-            </a:r>
-          </a:p>
-        </p:txBody>
-      </p:sp>
-      <p:sp>
-        <p:nvSpPr>
           <p:cNvPr id="8" name="TextBox 7"/>
           <p:cNvSpPr txBox="1"/>
           <p:nvPr/>
@@ -7589,7 +7642,7 @@
           <p:nvPr>
             <p:extLst>
               <p:ext uri="{D42A27DB-BD31-4B8C-83A1-F6EECF244321}">
-                <p14:modId xmlns:p14="http://schemas.microsoft.com/office/powerpoint/2010/main" val="106512584"/>
+                <p14:modId xmlns:p14="http://schemas.microsoft.com/office/powerpoint/2010/main" val="4093105599"/>
               </p:ext>
             </p:extLst>
           </p:nvPr>
@@ -7816,14 +7869,20 @@
                     <a:lstStyle/>
                     <a:p>
                       <a:r>
-                        <a:rPr sz="1500" b="0" i="0">
+                        <a:rPr lang="en-US" sz="1500" b="0" i="0" dirty="0">
                           <a:solidFill>
                             <a:srgbClr val="1A1A1A"/>
                           </a:solidFill>
                           <a:latin typeface="Calibri"/>
                         </a:rPr>
-                        <a:t>0/3</a:t>
-                      </a:r>
+                        <a:t>N/A</a:t>
+                      </a:r>
+                      <a:endParaRPr sz="1500" b="0" i="0" dirty="0">
+                        <a:solidFill>
+                          <a:srgbClr val="1A1A1A"/>
+                        </a:solidFill>
+                        <a:latin typeface="Calibri"/>
+                      </a:endParaRPr>
                     </a:p>
                   </a:txBody>
                   <a:tcPr marL="73152" marR="73152" marT="36576" marB="36576" anchor="ctr">
@@ -18710,6 +18769,2032 @@
 </file>
 
 <file path=ppt/slides/slide17.xml><?xml version="1.0" encoding="utf-8"?>
+<p:sld xmlns:a="http://schemas.openxmlformats.org/drawingml/2006/main" xmlns:r="http://schemas.openxmlformats.org/officeDocument/2006/relationships" xmlns:p="http://schemas.openxmlformats.org/presentationml/2006/main">
+  <p:cSld>
+    <p:spTree>
+      <p:nvGrpSpPr>
+        <p:cNvPr id="1" name=""/>
+        <p:cNvGrpSpPr/>
+        <p:nvPr/>
+      </p:nvGrpSpPr>
+      <p:grpSpPr>
+        <a:xfrm>
+          <a:off x="0" y="0"/>
+          <a:ext cx="0" cy="0"/>
+          <a:chOff x="0" y="0"/>
+          <a:chExt cx="0" cy="0"/>
+        </a:xfrm>
+      </p:grpSpPr>
+      <p:sp>
+        <p:nvSpPr>
+          <p:cNvPr id="2" name="Shape 0"/>
+          <p:cNvSpPr/>
+          <p:nvPr/>
+        </p:nvSpPr>
+        <p:spPr>
+          <a:xfrm>
+            <a:off x="0" y="0"/>
+            <a:ext cx="164592" cy="6858000"/>
+          </a:xfrm>
+          <a:prstGeom prst="rect">
+            <a:avLst/>
+          </a:prstGeom>
+          <a:solidFill>
+            <a:srgbClr val="1F4E79"/>
+          </a:solidFill>
+          <a:ln w="12700">
+            <a:solidFill>
+              <a:srgbClr val="1F4E79"/>
+            </a:solidFill>
+            <a:prstDash val="solid"/>
+          </a:ln>
+        </p:spPr>
+        <p:txBody>
+          <a:bodyPr/>
+          <a:lstStyle/>
+          <a:p>
+            <a:endParaRPr lang="en-US"/>
+          </a:p>
+        </p:txBody>
+      </p:sp>
+      <p:sp>
+        <p:nvSpPr>
+          <p:cNvPr id="3" name="Text 1"/>
+          <p:cNvSpPr txBox="1"/>
+          <p:nvPr/>
+        </p:nvSpPr>
+        <p:spPr>
+          <a:xfrm>
+            <a:off x="502920" y="320040"/>
+            <a:ext cx="11155680" cy="548640"/>
+          </a:xfrm>
+          <a:prstGeom prst="rect">
+            <a:avLst/>
+          </a:prstGeom>
+          <a:noFill/>
+          <a:ln/>
+        </p:spPr>
+        <p:txBody>
+          <a:bodyPr wrap="square" lIns="0" tIns="0" rIns="0" bIns="0" rtlCol="0" anchor="ctr"/>
+          <a:lstStyle/>
+          <a:p>
+            <a:pPr marL="0" indent="0">
+              <a:buNone/>
+            </a:pPr>
+            <a:r>
+              <a:rPr lang="en-US" sz="3000" b="1" dirty="0">
+                <a:solidFill>
+                  <a:srgbClr val="1F4E79"/>
+                </a:solidFill>
+                <a:latin typeface="Calibri" pitchFamily="34" charset="0"/>
+                <a:ea typeface="Calibri" pitchFamily="34" charset="-122"/>
+                <a:cs typeface="Calibri" pitchFamily="34" charset="-120"/>
+              </a:rPr>
+              <a:t>Potential Next Steps…</a:t>
+            </a:r>
+            <a:endParaRPr lang="en-US" sz="3000" dirty="0"/>
+          </a:p>
+        </p:txBody>
+      </p:sp>
+      <p:sp>
+        <p:nvSpPr>
+          <p:cNvPr id="4" name="Text 2"/>
+          <p:cNvSpPr txBox="1"/>
+          <p:nvPr/>
+        </p:nvSpPr>
+        <p:spPr>
+          <a:xfrm>
+            <a:off x="502920" y="841248"/>
+            <a:ext cx="11155680" cy="320040"/>
+          </a:xfrm>
+          <a:prstGeom prst="rect">
+            <a:avLst/>
+          </a:prstGeom>
+          <a:noFill/>
+          <a:ln/>
+        </p:spPr>
+        <p:txBody>
+          <a:bodyPr wrap="square" lIns="0" tIns="0" rIns="0" bIns="0" rtlCol="0" anchor="ctr"/>
+          <a:lstStyle/>
+          <a:p>
+            <a:pPr marL="0" indent="0">
+              <a:buNone/>
+            </a:pPr>
+            <a:r>
+              <a:rPr lang="en-US" sz="1500" dirty="0">
+                <a:solidFill>
+                  <a:srgbClr val="595959"/>
+                </a:solidFill>
+                <a:latin typeface="Calibri" pitchFamily="34" charset="0"/>
+                <a:ea typeface="Calibri" pitchFamily="34" charset="-122"/>
+                <a:cs typeface="Calibri" pitchFamily="34" charset="-120"/>
+              </a:rPr>
+              <a:t>Headless 360 and AIforce let bankers reach the same agent from Slack, Claude or other AI tools</a:t>
+            </a:r>
+            <a:endParaRPr lang="en-US" sz="1500" dirty="0"/>
+          </a:p>
+        </p:txBody>
+      </p:sp>
+      <p:graphicFrame>
+        <p:nvGraphicFramePr>
+          <p:cNvPr id="5" name="Table 0"/>
+          <p:cNvGraphicFramePr>
+            <a:graphicFrameLocks noGrp="1"/>
+          </p:cNvGraphicFramePr>
+          <p:nvPr>
+            <p:extLst>
+              <p:ext uri="{D42A27DB-BD31-4B8C-83A1-F6EECF244321}">
+                <p14:modId xmlns:p14="http://schemas.microsoft.com/office/powerpoint/2010/main" val="590472788"/>
+              </p:ext>
+            </p:extLst>
+          </p:nvPr>
+        </p:nvGraphicFramePr>
+        <p:xfrm>
+          <a:off x="502920" y="1325880"/>
+          <a:ext cx="11155680" cy="4343400"/>
+        </p:xfrm>
+        <a:graphic>
+          <a:graphicData uri="http://schemas.openxmlformats.org/drawingml/2006/table">
+            <a:tbl>
+              <a:tblPr/>
+              <a:tblGrid>
+                <a:gridCol w="2651760">
+                  <a:extLst>
+                    <a:ext uri="{9D8B030D-6E8A-4147-A177-3AD203B41FA5}">
+                      <a16:colId xmlns:a16="http://schemas.microsoft.com/office/drawing/2014/main" val="20000"/>
+                    </a:ext>
+                  </a:extLst>
+                </a:gridCol>
+                <a:gridCol w="3108960">
+                  <a:extLst>
+                    <a:ext uri="{9D8B030D-6E8A-4147-A177-3AD203B41FA5}">
+                      <a16:colId xmlns:a16="http://schemas.microsoft.com/office/drawing/2014/main" val="20001"/>
+                    </a:ext>
+                  </a:extLst>
+                </a:gridCol>
+                <a:gridCol w="2926080">
+                  <a:extLst>
+                    <a:ext uri="{9D8B030D-6E8A-4147-A177-3AD203B41FA5}">
+                      <a16:colId xmlns:a16="http://schemas.microsoft.com/office/drawing/2014/main" val="20002"/>
+                    </a:ext>
+                  </a:extLst>
+                </a:gridCol>
+                <a:gridCol w="2468880">
+                  <a:extLst>
+                    <a:ext uri="{9D8B030D-6E8A-4147-A177-3AD203B41FA5}">
+                      <a16:colId xmlns:a16="http://schemas.microsoft.com/office/drawing/2014/main" val="20003"/>
+                    </a:ext>
+                  </a:extLst>
+                </a:gridCol>
+              </a:tblGrid>
+              <a:tr h="411480">
+                <a:tc>
+                  <a:txBody>
+                    <a:bodyPr/>
+                    <a:lstStyle/>
+                    <a:p>
+                      <a:pPr marL="0" indent="0">
+                        <a:buNone/>
+                      </a:pPr>
+                      <a:r>
+                        <a:rPr lang="en-US" sz="1400" b="1" dirty="0">
+                          <a:solidFill>
+                            <a:srgbClr val="FFFFFF"/>
+                          </a:solidFill>
+                          <a:latin typeface="Calibri" pitchFamily="34" charset="0"/>
+                          <a:ea typeface="Calibri" pitchFamily="34" charset="-122"/>
+                          <a:cs typeface="Calibri" pitchFamily="34" charset="-120"/>
+                        </a:rPr>
+                        <a:t>Enhancement</a:t>
+                      </a:r>
+                      <a:endParaRPr lang="en-US" sz="1400" dirty="0">
+                        <a:latin typeface="Calibri" charset="0"/>
+                        <a:ea typeface="Calibri" charset="0"/>
+                        <a:cs typeface="Calibri" charset="0"/>
+                      </a:endParaRPr>
+                    </a:p>
+                  </a:txBody>
+                  <a:tcPr marT="54864" marB="54864" anchor="ctr">
+                    <a:lnL w="9525" cap="flat" cmpd="sng" algn="ctr">
+                      <a:solidFill>
+                        <a:srgbClr val="D0D7E2"/>
+                      </a:solidFill>
+                      <a:prstDash val="solid"/>
+                      <a:round/>
+                      <a:headEnd type="none" w="med" len="med"/>
+                      <a:tailEnd type="none" w="med" len="med"/>
+                    </a:lnL>
+                    <a:lnR w="9525" cap="flat" cmpd="sng" algn="ctr">
+                      <a:solidFill>
+                        <a:srgbClr val="D0D7E2"/>
+                      </a:solidFill>
+                      <a:prstDash val="solid"/>
+                      <a:round/>
+                      <a:headEnd type="none" w="med" len="med"/>
+                      <a:tailEnd type="none" w="med" len="med"/>
+                    </a:lnR>
+                    <a:lnT w="9525" cap="flat" cmpd="sng" algn="ctr">
+                      <a:solidFill>
+                        <a:srgbClr val="D0D7E2"/>
+                      </a:solidFill>
+                      <a:prstDash val="solid"/>
+                      <a:round/>
+                      <a:headEnd type="none" w="med" len="med"/>
+                      <a:tailEnd type="none" w="med" len="med"/>
+                    </a:lnT>
+                    <a:lnB w="9525" cap="flat" cmpd="sng" algn="ctr">
+                      <a:solidFill>
+                        <a:srgbClr val="D0D7E2"/>
+                      </a:solidFill>
+                      <a:prstDash val="solid"/>
+                      <a:round/>
+                      <a:headEnd type="none" w="med" len="med"/>
+                      <a:tailEnd type="none" w="med" len="med"/>
+                    </a:lnB>
+                    <a:solidFill>
+                      <a:srgbClr val="1F4E79"/>
+                    </a:solidFill>
+                  </a:tcPr>
+                </a:tc>
+                <a:tc>
+                  <a:txBody>
+                    <a:bodyPr/>
+                    <a:lstStyle/>
+                    <a:p>
+                      <a:pPr marL="0" indent="0">
+                        <a:buNone/>
+                      </a:pPr>
+                      <a:r>
+                        <a:rPr lang="en-US" sz="1400" b="1" dirty="0">
+                          <a:solidFill>
+                            <a:srgbClr val="FFFFFF"/>
+                          </a:solidFill>
+                          <a:latin typeface="Calibri" pitchFamily="34" charset="0"/>
+                          <a:ea typeface="Calibri" pitchFamily="34" charset="-122"/>
+                          <a:cs typeface="Calibri" pitchFamily="34" charset="-120"/>
+                        </a:rPr>
+                        <a:t>What changes</a:t>
+                      </a:r>
+                      <a:endParaRPr lang="en-US" sz="1400" dirty="0">
+                        <a:latin typeface="Calibri" charset="0"/>
+                        <a:ea typeface="Calibri" charset="0"/>
+                        <a:cs typeface="Calibri" charset="0"/>
+                      </a:endParaRPr>
+                    </a:p>
+                  </a:txBody>
+                  <a:tcPr marT="54864" marB="54864" anchor="ctr">
+                    <a:lnL w="9525" cap="flat" cmpd="sng" algn="ctr">
+                      <a:solidFill>
+                        <a:srgbClr val="D0D7E2"/>
+                      </a:solidFill>
+                      <a:prstDash val="solid"/>
+                      <a:round/>
+                      <a:headEnd type="none" w="med" len="med"/>
+                      <a:tailEnd type="none" w="med" len="med"/>
+                    </a:lnL>
+                    <a:lnR w="9525" cap="flat" cmpd="sng" algn="ctr">
+                      <a:solidFill>
+                        <a:srgbClr val="D0D7E2"/>
+                      </a:solidFill>
+                      <a:prstDash val="solid"/>
+                      <a:round/>
+                      <a:headEnd type="none" w="med" len="med"/>
+                      <a:tailEnd type="none" w="med" len="med"/>
+                    </a:lnR>
+                    <a:lnT w="9525" cap="flat" cmpd="sng" algn="ctr">
+                      <a:solidFill>
+                        <a:srgbClr val="D0D7E2"/>
+                      </a:solidFill>
+                      <a:prstDash val="solid"/>
+                      <a:round/>
+                      <a:headEnd type="none" w="med" len="med"/>
+                      <a:tailEnd type="none" w="med" len="med"/>
+                    </a:lnT>
+                    <a:lnB w="9525" cap="flat" cmpd="sng" algn="ctr">
+                      <a:solidFill>
+                        <a:srgbClr val="D0D7E2"/>
+                      </a:solidFill>
+                      <a:prstDash val="solid"/>
+                      <a:round/>
+                      <a:headEnd type="none" w="med" len="med"/>
+                      <a:tailEnd type="none" w="med" len="med"/>
+                    </a:lnB>
+                    <a:solidFill>
+                      <a:srgbClr val="1F4E79"/>
+                    </a:solidFill>
+                  </a:tcPr>
+                </a:tc>
+                <a:tc>
+                  <a:txBody>
+                    <a:bodyPr/>
+                    <a:lstStyle/>
+                    <a:p>
+                      <a:pPr marL="0" indent="0">
+                        <a:buNone/>
+                      </a:pPr>
+                      <a:r>
+                        <a:rPr lang="en-US" sz="1400" b="1" dirty="0">
+                          <a:solidFill>
+                            <a:srgbClr val="FFFFFF"/>
+                          </a:solidFill>
+                          <a:latin typeface="Calibri" pitchFamily="34" charset="0"/>
+                          <a:ea typeface="Calibri" pitchFamily="34" charset="-122"/>
+                          <a:cs typeface="Calibri" pitchFamily="34" charset="-120"/>
+                        </a:rPr>
+                        <a:t>What stays the same</a:t>
+                      </a:r>
+                      <a:endParaRPr lang="en-US" sz="1400" dirty="0">
+                        <a:latin typeface="Calibri" charset="0"/>
+                        <a:ea typeface="Calibri" charset="0"/>
+                        <a:cs typeface="Calibri" charset="0"/>
+                      </a:endParaRPr>
+                    </a:p>
+                  </a:txBody>
+                  <a:tcPr marT="54864" marB="54864" anchor="ctr">
+                    <a:lnL w="9525" cap="flat" cmpd="sng" algn="ctr">
+                      <a:solidFill>
+                        <a:srgbClr val="D0D7E2"/>
+                      </a:solidFill>
+                      <a:prstDash val="solid"/>
+                      <a:round/>
+                      <a:headEnd type="none" w="med" len="med"/>
+                      <a:tailEnd type="none" w="med" len="med"/>
+                    </a:lnL>
+                    <a:lnR w="9525" cap="flat" cmpd="sng" algn="ctr">
+                      <a:solidFill>
+                        <a:srgbClr val="D0D7E2"/>
+                      </a:solidFill>
+                      <a:prstDash val="solid"/>
+                      <a:round/>
+                      <a:headEnd type="none" w="med" len="med"/>
+                      <a:tailEnd type="none" w="med" len="med"/>
+                    </a:lnR>
+                    <a:lnT w="9525" cap="flat" cmpd="sng" algn="ctr">
+                      <a:solidFill>
+                        <a:srgbClr val="D0D7E2"/>
+                      </a:solidFill>
+                      <a:prstDash val="solid"/>
+                      <a:round/>
+                      <a:headEnd type="none" w="med" len="med"/>
+                      <a:tailEnd type="none" w="med" len="med"/>
+                    </a:lnT>
+                    <a:lnB w="9525" cap="flat" cmpd="sng" algn="ctr">
+                      <a:solidFill>
+                        <a:srgbClr val="D0D7E2"/>
+                      </a:solidFill>
+                      <a:prstDash val="solid"/>
+                      <a:round/>
+                      <a:headEnd type="none" w="med" len="med"/>
+                      <a:tailEnd type="none" w="med" len="med"/>
+                    </a:lnB>
+                    <a:solidFill>
+                      <a:srgbClr val="1F4E79"/>
+                    </a:solidFill>
+                  </a:tcPr>
+                </a:tc>
+                <a:tc>
+                  <a:txBody>
+                    <a:bodyPr/>
+                    <a:lstStyle/>
+                    <a:p>
+                      <a:pPr marL="0" indent="0">
+                        <a:buNone/>
+                      </a:pPr>
+                      <a:r>
+                        <a:rPr lang="en-US" sz="1400" b="1" dirty="0">
+                          <a:solidFill>
+                            <a:srgbClr val="FFFFFF"/>
+                          </a:solidFill>
+                          <a:latin typeface="Calibri" pitchFamily="34" charset="0"/>
+                          <a:ea typeface="Calibri" pitchFamily="34" charset="-122"/>
+                          <a:cs typeface="Calibri" pitchFamily="34" charset="-120"/>
+                        </a:rPr>
+                        <a:t>First test</a:t>
+                      </a:r>
+                      <a:endParaRPr lang="en-US" sz="1400" dirty="0">
+                        <a:latin typeface="Calibri" charset="0"/>
+                        <a:ea typeface="Calibri" charset="0"/>
+                        <a:cs typeface="Calibri" charset="0"/>
+                      </a:endParaRPr>
+                    </a:p>
+                  </a:txBody>
+                  <a:tcPr marT="54864" marB="54864" anchor="ctr">
+                    <a:lnL w="9525" cap="flat" cmpd="sng" algn="ctr">
+                      <a:solidFill>
+                        <a:srgbClr val="D0D7E2"/>
+                      </a:solidFill>
+                      <a:prstDash val="solid"/>
+                      <a:round/>
+                      <a:headEnd type="none" w="med" len="med"/>
+                      <a:tailEnd type="none" w="med" len="med"/>
+                    </a:lnL>
+                    <a:lnR w="9525" cap="flat" cmpd="sng" algn="ctr">
+                      <a:solidFill>
+                        <a:srgbClr val="D0D7E2"/>
+                      </a:solidFill>
+                      <a:prstDash val="solid"/>
+                      <a:round/>
+                      <a:headEnd type="none" w="med" len="med"/>
+                      <a:tailEnd type="none" w="med" len="med"/>
+                    </a:lnR>
+                    <a:lnT w="9525" cap="flat" cmpd="sng" algn="ctr">
+                      <a:solidFill>
+                        <a:srgbClr val="D0D7E2"/>
+                      </a:solidFill>
+                      <a:prstDash val="solid"/>
+                      <a:round/>
+                      <a:headEnd type="none" w="med" len="med"/>
+                      <a:tailEnd type="none" w="med" len="med"/>
+                    </a:lnT>
+                    <a:lnB w="9525" cap="flat" cmpd="sng" algn="ctr">
+                      <a:solidFill>
+                        <a:srgbClr val="D0D7E2"/>
+                      </a:solidFill>
+                      <a:prstDash val="solid"/>
+                      <a:round/>
+                      <a:headEnd type="none" w="med" len="med"/>
+                      <a:tailEnd type="none" w="med" len="med"/>
+                    </a:lnB>
+                    <a:solidFill>
+                      <a:srgbClr val="1F4E79"/>
+                    </a:solidFill>
+                  </a:tcPr>
+                </a:tc>
+                <a:extLst>
+                  <a:ext uri="{0D108BD9-81ED-4DB2-BD59-A6C34878D82A}">
+                    <a16:rowId xmlns:a16="http://schemas.microsoft.com/office/drawing/2014/main" val="10000"/>
+                  </a:ext>
+                </a:extLst>
+              </a:tr>
+              <a:tr h="868680">
+                <a:tc>
+                  <a:txBody>
+                    <a:bodyPr/>
+                    <a:lstStyle/>
+                    <a:p>
+                      <a:pPr marL="0" indent="0">
+                        <a:buNone/>
+                      </a:pPr>
+                      <a:r>
+                        <a:rPr lang="en-US" sz="1800" b="1" dirty="0">
+                          <a:solidFill>
+                            <a:srgbClr val="1F4E79"/>
+                          </a:solidFill>
+                          <a:latin typeface="Calibri" pitchFamily="34" charset="0"/>
+                          <a:ea typeface="Calibri" pitchFamily="34" charset="-122"/>
+                          <a:cs typeface="Calibri" pitchFamily="34" charset="-120"/>
+                        </a:rPr>
+                        <a:t>1  </a:t>
+                      </a:r>
+                      <a:r>
+                        <a:rPr lang="en-US" sz="1200" b="1" dirty="0">
+                          <a:solidFill>
+                            <a:srgbClr val="262626"/>
+                          </a:solidFill>
+                          <a:latin typeface="Calibri" pitchFamily="34" charset="0"/>
+                          <a:ea typeface="Calibri" pitchFamily="34" charset="-122"/>
+                          <a:cs typeface="Calibri" pitchFamily="34" charset="-120"/>
+                        </a:rPr>
+                        <a:t>Reach bankers where they work</a:t>
+                      </a:r>
+                      <a:endParaRPr lang="en-US" sz="1200" dirty="0">
+                        <a:latin typeface="Calibri" charset="0"/>
+                        <a:ea typeface="Calibri" charset="0"/>
+                        <a:cs typeface="Calibri" charset="0"/>
+                      </a:endParaRPr>
+                    </a:p>
+                  </a:txBody>
+                  <a:tcPr marT="54864" marB="54864" anchor="ctr">
+                    <a:lnL w="9525" cap="flat" cmpd="sng" algn="ctr">
+                      <a:solidFill>
+                        <a:srgbClr val="D0D7E2"/>
+                      </a:solidFill>
+                      <a:prstDash val="solid"/>
+                      <a:round/>
+                      <a:headEnd type="none" w="med" len="med"/>
+                      <a:tailEnd type="none" w="med" len="med"/>
+                    </a:lnL>
+                    <a:lnR w="9525" cap="flat" cmpd="sng" algn="ctr">
+                      <a:solidFill>
+                        <a:srgbClr val="D0D7E2"/>
+                      </a:solidFill>
+                      <a:prstDash val="solid"/>
+                      <a:round/>
+                      <a:headEnd type="none" w="med" len="med"/>
+                      <a:tailEnd type="none" w="med" len="med"/>
+                    </a:lnR>
+                    <a:lnT w="9525" cap="flat" cmpd="sng" algn="ctr">
+                      <a:solidFill>
+                        <a:srgbClr val="D0D7E2"/>
+                      </a:solidFill>
+                      <a:prstDash val="solid"/>
+                      <a:round/>
+                      <a:headEnd type="none" w="med" len="med"/>
+                      <a:tailEnd type="none" w="med" len="med"/>
+                    </a:lnT>
+                    <a:lnB w="9525" cap="flat" cmpd="sng" algn="ctr">
+                      <a:solidFill>
+                        <a:srgbClr val="D0D7E2"/>
+                      </a:solidFill>
+                      <a:prstDash val="solid"/>
+                      <a:round/>
+                      <a:headEnd type="none" w="med" len="med"/>
+                      <a:tailEnd type="none" w="med" len="med"/>
+                    </a:lnB>
+                    <a:solidFill>
+                      <a:srgbClr val="FFFFFF"/>
+                    </a:solidFill>
+                  </a:tcPr>
+                </a:tc>
+                <a:tc>
+                  <a:txBody>
+                    <a:bodyPr/>
+                    <a:lstStyle/>
+                    <a:p>
+                      <a:pPr marL="0" indent="0">
+                        <a:buNone/>
+                      </a:pPr>
+                      <a:r>
+                        <a:rPr lang="en-US" sz="1200" dirty="0">
+                          <a:solidFill>
+                            <a:srgbClr val="262626"/>
+                          </a:solidFill>
+                          <a:latin typeface="Calibri" pitchFamily="34" charset="0"/>
+                          <a:ea typeface="Calibri" pitchFamily="34" charset="-122"/>
+                          <a:cs typeface="Calibri" pitchFamily="34" charset="-120"/>
+                        </a:rPr>
+                        <a:t>The agent is called from Slack (Slackforce), Claude (Salesforce in Claude) or Agentforce Coworker</a:t>
+                      </a:r>
+                      <a:endParaRPr lang="en-US" sz="1200" dirty="0">
+                        <a:latin typeface="Calibri" charset="0"/>
+                        <a:ea typeface="Calibri" charset="0"/>
+                        <a:cs typeface="Calibri" charset="0"/>
+                      </a:endParaRPr>
+                    </a:p>
+                  </a:txBody>
+                  <a:tcPr marT="54864" marB="54864" anchor="ctr">
+                    <a:lnL w="9525" cap="flat" cmpd="sng" algn="ctr">
+                      <a:solidFill>
+                        <a:srgbClr val="D0D7E2"/>
+                      </a:solidFill>
+                      <a:prstDash val="solid"/>
+                      <a:round/>
+                      <a:headEnd type="none" w="med" len="med"/>
+                      <a:tailEnd type="none" w="med" len="med"/>
+                    </a:lnL>
+                    <a:lnR w="9525" cap="flat" cmpd="sng" algn="ctr">
+                      <a:solidFill>
+                        <a:srgbClr val="D0D7E2"/>
+                      </a:solidFill>
+                      <a:prstDash val="solid"/>
+                      <a:round/>
+                      <a:headEnd type="none" w="med" len="med"/>
+                      <a:tailEnd type="none" w="med" len="med"/>
+                    </a:lnR>
+                    <a:lnT w="9525" cap="flat" cmpd="sng" algn="ctr">
+                      <a:solidFill>
+                        <a:srgbClr val="D0D7E2"/>
+                      </a:solidFill>
+                      <a:prstDash val="solid"/>
+                      <a:round/>
+                      <a:headEnd type="none" w="med" len="med"/>
+                      <a:tailEnd type="none" w="med" len="med"/>
+                    </a:lnT>
+                    <a:lnB w="9525" cap="flat" cmpd="sng" algn="ctr">
+                      <a:solidFill>
+                        <a:srgbClr val="D0D7E2"/>
+                      </a:solidFill>
+                      <a:prstDash val="solid"/>
+                      <a:round/>
+                      <a:headEnd type="none" w="med" len="med"/>
+                      <a:tailEnd type="none" w="med" len="med"/>
+                    </a:lnB>
+                    <a:solidFill>
+                      <a:srgbClr val="FFFFFF"/>
+                    </a:solidFill>
+                  </a:tcPr>
+                </a:tc>
+                <a:tc>
+                  <a:txBody>
+                    <a:bodyPr/>
+                    <a:lstStyle/>
+                    <a:p>
+                      <a:pPr marL="0" indent="0">
+                        <a:buNone/>
+                      </a:pPr>
+                      <a:r>
+                        <a:rPr lang="en-US" sz="1200" b="1" dirty="0">
+                          <a:solidFill>
+                            <a:srgbClr val="1F4E79"/>
+                          </a:solidFill>
+                          <a:latin typeface="Calibri" pitchFamily="34" charset="0"/>
+                          <a:ea typeface="Calibri" pitchFamily="34" charset="-122"/>
+                          <a:cs typeface="Calibri" pitchFamily="34" charset="-120"/>
+                        </a:rPr>
+                        <a:t>Our Apex still gathers facts as the banker, checks the answer and writes the log</a:t>
+                      </a:r>
+                      <a:endParaRPr lang="en-US" sz="1200" dirty="0">
+                        <a:latin typeface="Calibri" charset="0"/>
+                        <a:ea typeface="Calibri" charset="0"/>
+                        <a:cs typeface="Calibri" charset="0"/>
+                      </a:endParaRPr>
+                    </a:p>
+                  </a:txBody>
+                  <a:tcPr marT="54864" marB="54864" anchor="ctr">
+                    <a:lnL w="9525" cap="flat" cmpd="sng" algn="ctr">
+                      <a:solidFill>
+                        <a:srgbClr val="D0D7E2"/>
+                      </a:solidFill>
+                      <a:prstDash val="solid"/>
+                      <a:round/>
+                      <a:headEnd type="none" w="med" len="med"/>
+                      <a:tailEnd type="none" w="med" len="med"/>
+                    </a:lnL>
+                    <a:lnR w="9525" cap="flat" cmpd="sng" algn="ctr">
+                      <a:solidFill>
+                        <a:srgbClr val="D0D7E2"/>
+                      </a:solidFill>
+                      <a:prstDash val="solid"/>
+                      <a:round/>
+                      <a:headEnd type="none" w="med" len="med"/>
+                      <a:tailEnd type="none" w="med" len="med"/>
+                    </a:lnR>
+                    <a:lnT w="9525" cap="flat" cmpd="sng" algn="ctr">
+                      <a:solidFill>
+                        <a:srgbClr val="D0D7E2"/>
+                      </a:solidFill>
+                      <a:prstDash val="solid"/>
+                      <a:round/>
+                      <a:headEnd type="none" w="med" len="med"/>
+                      <a:tailEnd type="none" w="med" len="med"/>
+                    </a:lnT>
+                    <a:lnB w="9525" cap="flat" cmpd="sng" algn="ctr">
+                      <a:solidFill>
+                        <a:srgbClr val="D0D7E2"/>
+                      </a:solidFill>
+                      <a:prstDash val="solid"/>
+                      <a:round/>
+                      <a:headEnd type="none" w="med" len="med"/>
+                      <a:tailEnd type="none" w="med" len="med"/>
+                    </a:lnB>
+                    <a:solidFill>
+                      <a:srgbClr val="FFFFFF"/>
+                    </a:solidFill>
+                  </a:tcPr>
+                </a:tc>
+                <a:tc>
+                  <a:txBody>
+                    <a:bodyPr/>
+                    <a:lstStyle/>
+                    <a:p>
+                      <a:pPr marL="0" indent="0">
+                        <a:buNone/>
+                      </a:pPr>
+                      <a:r>
+                        <a:rPr lang="en-US" sz="1200" dirty="0">
+                          <a:solidFill>
+                            <a:srgbClr val="262626"/>
+                          </a:solidFill>
+                          <a:latin typeface="Calibri" pitchFamily="34" charset="0"/>
+                          <a:ea typeface="Calibri" pitchFamily="34" charset="-122"/>
+                          <a:cs typeface="Calibri" pitchFamily="34" charset="-120"/>
+                        </a:rPr>
+                        <a:t>Run the agent test set from each new interface</a:t>
+                      </a:r>
+                      <a:endParaRPr lang="en-US" sz="1200" dirty="0">
+                        <a:latin typeface="Calibri" charset="0"/>
+                        <a:ea typeface="Calibri" charset="0"/>
+                        <a:cs typeface="Calibri" charset="0"/>
+                      </a:endParaRPr>
+                    </a:p>
+                  </a:txBody>
+                  <a:tcPr marT="54864" marB="54864" anchor="ctr">
+                    <a:lnL w="9525" cap="flat" cmpd="sng" algn="ctr">
+                      <a:solidFill>
+                        <a:srgbClr val="D0D7E2"/>
+                      </a:solidFill>
+                      <a:prstDash val="solid"/>
+                      <a:round/>
+                      <a:headEnd type="none" w="med" len="med"/>
+                      <a:tailEnd type="none" w="med" len="med"/>
+                    </a:lnL>
+                    <a:lnR w="9525" cap="flat" cmpd="sng" algn="ctr">
+                      <a:solidFill>
+                        <a:srgbClr val="D0D7E2"/>
+                      </a:solidFill>
+                      <a:prstDash val="solid"/>
+                      <a:round/>
+                      <a:headEnd type="none" w="med" len="med"/>
+                      <a:tailEnd type="none" w="med" len="med"/>
+                    </a:lnR>
+                    <a:lnT w="9525" cap="flat" cmpd="sng" algn="ctr">
+                      <a:solidFill>
+                        <a:srgbClr val="D0D7E2"/>
+                      </a:solidFill>
+                      <a:prstDash val="solid"/>
+                      <a:round/>
+                      <a:headEnd type="none" w="med" len="med"/>
+                      <a:tailEnd type="none" w="med" len="med"/>
+                    </a:lnT>
+                    <a:lnB w="9525" cap="flat" cmpd="sng" algn="ctr">
+                      <a:solidFill>
+                        <a:srgbClr val="D0D7E2"/>
+                      </a:solidFill>
+                      <a:prstDash val="solid"/>
+                      <a:round/>
+                      <a:headEnd type="none" w="med" len="med"/>
+                      <a:tailEnd type="none" w="med" len="med"/>
+                    </a:lnB>
+                    <a:solidFill>
+                      <a:srgbClr val="FFFFFF"/>
+                    </a:solidFill>
+                  </a:tcPr>
+                </a:tc>
+                <a:extLst>
+                  <a:ext uri="{0D108BD9-81ED-4DB2-BD59-A6C34878D82A}">
+                    <a16:rowId xmlns:a16="http://schemas.microsoft.com/office/drawing/2014/main" val="10001"/>
+                  </a:ext>
+                </a:extLst>
+              </a:tr>
+              <a:tr h="777240">
+                <a:tc>
+                  <a:txBody>
+                    <a:bodyPr/>
+                    <a:lstStyle/>
+                    <a:p>
+                      <a:pPr marL="0" indent="0">
+                        <a:buNone/>
+                      </a:pPr>
+                      <a:r>
+                        <a:rPr lang="en-US" sz="1800" b="1" dirty="0">
+                          <a:solidFill>
+                            <a:srgbClr val="1F4E79"/>
+                          </a:solidFill>
+                          <a:latin typeface="Calibri" pitchFamily="34" charset="0"/>
+                          <a:ea typeface="Calibri" pitchFamily="34" charset="-122"/>
+                          <a:cs typeface="Calibri" pitchFamily="34" charset="-120"/>
+                        </a:rPr>
+                        <a:t>2  </a:t>
+                      </a:r>
+                      <a:r>
+                        <a:rPr lang="en-US" sz="1200" b="1" dirty="0">
+                          <a:solidFill>
+                            <a:srgbClr val="262626"/>
+                          </a:solidFill>
+                          <a:latin typeface="Calibri" pitchFamily="34" charset="0"/>
+                          <a:ea typeface="Calibri" pitchFamily="34" charset="-122"/>
+                          <a:cs typeface="Calibri" pitchFamily="34" charset="-120"/>
+                        </a:rPr>
+                        <a:t>Call it headlessly</a:t>
+                      </a:r>
+                      <a:endParaRPr lang="en-US" sz="1200" dirty="0">
+                        <a:latin typeface="Calibri" charset="0"/>
+                        <a:ea typeface="Calibri" charset="0"/>
+                        <a:cs typeface="Calibri" charset="0"/>
+                      </a:endParaRPr>
+                    </a:p>
+                  </a:txBody>
+                  <a:tcPr marT="54864" marB="54864" anchor="ctr">
+                    <a:lnL w="9525" cap="flat" cmpd="sng" algn="ctr">
+                      <a:solidFill>
+                        <a:srgbClr val="D0D7E2"/>
+                      </a:solidFill>
+                      <a:prstDash val="solid"/>
+                      <a:round/>
+                      <a:headEnd type="none" w="med" len="med"/>
+                      <a:tailEnd type="none" w="med" len="med"/>
+                    </a:lnL>
+                    <a:lnR w="9525" cap="flat" cmpd="sng" algn="ctr">
+                      <a:solidFill>
+                        <a:srgbClr val="D0D7E2"/>
+                      </a:solidFill>
+                      <a:prstDash val="solid"/>
+                      <a:round/>
+                      <a:headEnd type="none" w="med" len="med"/>
+                      <a:tailEnd type="none" w="med" len="med"/>
+                    </a:lnR>
+                    <a:lnT w="9525" cap="flat" cmpd="sng" algn="ctr">
+                      <a:solidFill>
+                        <a:srgbClr val="D0D7E2"/>
+                      </a:solidFill>
+                      <a:prstDash val="solid"/>
+                      <a:round/>
+                      <a:headEnd type="none" w="med" len="med"/>
+                      <a:tailEnd type="none" w="med" len="med"/>
+                    </a:lnT>
+                    <a:lnB w="9525" cap="flat" cmpd="sng" algn="ctr">
+                      <a:solidFill>
+                        <a:srgbClr val="D0D7E2"/>
+                      </a:solidFill>
+                      <a:prstDash val="solid"/>
+                      <a:round/>
+                      <a:headEnd type="none" w="med" len="med"/>
+                      <a:tailEnd type="none" w="med" len="med"/>
+                    </a:lnB>
+                    <a:solidFill>
+                      <a:srgbClr val="EAF0F7"/>
+                    </a:solidFill>
+                  </a:tcPr>
+                </a:tc>
+                <a:tc>
+                  <a:txBody>
+                    <a:bodyPr/>
+                    <a:lstStyle/>
+                    <a:p>
+                      <a:pPr marL="0" indent="0">
+                        <a:buNone/>
+                      </a:pPr>
+                      <a:r>
+                        <a:rPr lang="en-US" sz="1200" dirty="0">
+                          <a:solidFill>
+                            <a:srgbClr val="262626"/>
+                          </a:solidFill>
+                          <a:latin typeface="Calibri" pitchFamily="34" charset="0"/>
+                          <a:ea typeface="Calibri" pitchFamily="34" charset="-122"/>
+                          <a:cs typeface="Calibri" pitchFamily="34" charset="-120"/>
+                        </a:rPr>
+                        <a:t>Other apps start agent sessions through the Agent API or MCP tools</a:t>
+                      </a:r>
+                      <a:endParaRPr lang="en-US" sz="1200" dirty="0">
+                        <a:latin typeface="Calibri" charset="0"/>
+                        <a:ea typeface="Calibri" charset="0"/>
+                        <a:cs typeface="Calibri" charset="0"/>
+                      </a:endParaRPr>
+                    </a:p>
+                  </a:txBody>
+                  <a:tcPr marT="54864" marB="54864" anchor="ctr">
+                    <a:lnL w="9525" cap="flat" cmpd="sng" algn="ctr">
+                      <a:solidFill>
+                        <a:srgbClr val="D0D7E2"/>
+                      </a:solidFill>
+                      <a:prstDash val="solid"/>
+                      <a:round/>
+                      <a:headEnd type="none" w="med" len="med"/>
+                      <a:tailEnd type="none" w="med" len="med"/>
+                    </a:lnL>
+                    <a:lnR w="9525" cap="flat" cmpd="sng" algn="ctr">
+                      <a:solidFill>
+                        <a:srgbClr val="D0D7E2"/>
+                      </a:solidFill>
+                      <a:prstDash val="solid"/>
+                      <a:round/>
+                      <a:headEnd type="none" w="med" len="med"/>
+                      <a:tailEnd type="none" w="med" len="med"/>
+                    </a:lnR>
+                    <a:lnT w="9525" cap="flat" cmpd="sng" algn="ctr">
+                      <a:solidFill>
+                        <a:srgbClr val="D0D7E2"/>
+                      </a:solidFill>
+                      <a:prstDash val="solid"/>
+                      <a:round/>
+                      <a:headEnd type="none" w="med" len="med"/>
+                      <a:tailEnd type="none" w="med" len="med"/>
+                    </a:lnT>
+                    <a:lnB w="9525" cap="flat" cmpd="sng" algn="ctr">
+                      <a:solidFill>
+                        <a:srgbClr val="D0D7E2"/>
+                      </a:solidFill>
+                      <a:prstDash val="solid"/>
+                      <a:round/>
+                      <a:headEnd type="none" w="med" len="med"/>
+                      <a:tailEnd type="none" w="med" len="med"/>
+                    </a:lnB>
+                    <a:solidFill>
+                      <a:srgbClr val="EAF0F7"/>
+                    </a:solidFill>
+                  </a:tcPr>
+                </a:tc>
+                <a:tc>
+                  <a:txBody>
+                    <a:bodyPr/>
+                    <a:lstStyle/>
+                    <a:p>
+                      <a:pPr marL="0" indent="0">
+                        <a:buNone/>
+                      </a:pPr>
+                      <a:r>
+                        <a:rPr lang="en-US" sz="1200" b="1" dirty="0">
+                          <a:solidFill>
+                            <a:srgbClr val="1F4E79"/>
+                          </a:solidFill>
+                          <a:latin typeface="Calibri" pitchFamily="34" charset="0"/>
+                          <a:ea typeface="Calibri" pitchFamily="34" charset="-122"/>
+                          <a:cs typeface="Calibri" pitchFamily="34" charset="-120"/>
+                        </a:rPr>
+                        <a:t>Find sets the guard; Generate validates, saves and logs</a:t>
+                      </a:r>
+                      <a:endParaRPr lang="en-US" sz="1200" dirty="0">
+                        <a:latin typeface="Calibri" charset="0"/>
+                        <a:ea typeface="Calibri" charset="0"/>
+                        <a:cs typeface="Calibri" charset="0"/>
+                      </a:endParaRPr>
+                    </a:p>
+                  </a:txBody>
+                  <a:tcPr marT="54864" marB="54864" anchor="ctr">
+                    <a:lnL w="9525" cap="flat" cmpd="sng" algn="ctr">
+                      <a:solidFill>
+                        <a:srgbClr val="D0D7E2"/>
+                      </a:solidFill>
+                      <a:prstDash val="solid"/>
+                      <a:round/>
+                      <a:headEnd type="none" w="med" len="med"/>
+                      <a:tailEnd type="none" w="med" len="med"/>
+                    </a:lnL>
+                    <a:lnR w="9525" cap="flat" cmpd="sng" algn="ctr">
+                      <a:solidFill>
+                        <a:srgbClr val="D0D7E2"/>
+                      </a:solidFill>
+                      <a:prstDash val="solid"/>
+                      <a:round/>
+                      <a:headEnd type="none" w="med" len="med"/>
+                      <a:tailEnd type="none" w="med" len="med"/>
+                    </a:lnR>
+                    <a:lnT w="9525" cap="flat" cmpd="sng" algn="ctr">
+                      <a:solidFill>
+                        <a:srgbClr val="D0D7E2"/>
+                      </a:solidFill>
+                      <a:prstDash val="solid"/>
+                      <a:round/>
+                      <a:headEnd type="none" w="med" len="med"/>
+                      <a:tailEnd type="none" w="med" len="med"/>
+                    </a:lnT>
+                    <a:lnB w="9525" cap="flat" cmpd="sng" algn="ctr">
+                      <a:solidFill>
+                        <a:srgbClr val="D0D7E2"/>
+                      </a:solidFill>
+                      <a:prstDash val="solid"/>
+                      <a:round/>
+                      <a:headEnd type="none" w="med" len="med"/>
+                      <a:tailEnd type="none" w="med" len="med"/>
+                    </a:lnB>
+                    <a:solidFill>
+                      <a:srgbClr val="EAF0F7"/>
+                    </a:solidFill>
+                  </a:tcPr>
+                </a:tc>
+                <a:tc>
+                  <a:txBody>
+                    <a:bodyPr/>
+                    <a:lstStyle/>
+                    <a:p>
+                      <a:pPr marL="0" indent="0">
+                        <a:buNone/>
+                      </a:pPr>
+                      <a:r>
+                        <a:rPr lang="en-US" sz="1200" dirty="0">
+                          <a:solidFill>
+                            <a:srgbClr val="262626"/>
+                          </a:solidFill>
+                          <a:latin typeface="Calibri" pitchFamily="34" charset="0"/>
+                          <a:ea typeface="Calibri" pitchFamily="34" charset="-122"/>
+                          <a:cs typeface="Calibri" pitchFamily="34" charset="-120"/>
+                        </a:rPr>
+                        <a:t>The banker’s own identity carries through, not a shared integration user</a:t>
+                      </a:r>
+                      <a:endParaRPr lang="en-US" sz="1200" dirty="0">
+                        <a:latin typeface="Calibri" charset="0"/>
+                        <a:ea typeface="Calibri" charset="0"/>
+                        <a:cs typeface="Calibri" charset="0"/>
+                      </a:endParaRPr>
+                    </a:p>
+                  </a:txBody>
+                  <a:tcPr marT="54864" marB="54864" anchor="ctr">
+                    <a:lnL w="9525" cap="flat" cmpd="sng" algn="ctr">
+                      <a:solidFill>
+                        <a:srgbClr val="D0D7E2"/>
+                      </a:solidFill>
+                      <a:prstDash val="solid"/>
+                      <a:round/>
+                      <a:headEnd type="none" w="med" len="med"/>
+                      <a:tailEnd type="none" w="med" len="med"/>
+                    </a:lnL>
+                    <a:lnR w="9525" cap="flat" cmpd="sng" algn="ctr">
+                      <a:solidFill>
+                        <a:srgbClr val="D0D7E2"/>
+                      </a:solidFill>
+                      <a:prstDash val="solid"/>
+                      <a:round/>
+                      <a:headEnd type="none" w="med" len="med"/>
+                      <a:tailEnd type="none" w="med" len="med"/>
+                    </a:lnR>
+                    <a:lnT w="9525" cap="flat" cmpd="sng" algn="ctr">
+                      <a:solidFill>
+                        <a:srgbClr val="D0D7E2"/>
+                      </a:solidFill>
+                      <a:prstDash val="solid"/>
+                      <a:round/>
+                      <a:headEnd type="none" w="med" len="med"/>
+                      <a:tailEnd type="none" w="med" len="med"/>
+                    </a:lnT>
+                    <a:lnB w="9525" cap="flat" cmpd="sng" algn="ctr">
+                      <a:solidFill>
+                        <a:srgbClr val="D0D7E2"/>
+                      </a:solidFill>
+                      <a:prstDash val="solid"/>
+                      <a:round/>
+                      <a:headEnd type="none" w="med" len="med"/>
+                      <a:tailEnd type="none" w="med" len="med"/>
+                    </a:lnB>
+                    <a:solidFill>
+                      <a:srgbClr val="EAF0F7"/>
+                    </a:solidFill>
+                  </a:tcPr>
+                </a:tc>
+                <a:extLst>
+                  <a:ext uri="{0D108BD9-81ED-4DB2-BD59-A6C34878D82A}">
+                    <a16:rowId xmlns:a16="http://schemas.microsoft.com/office/drawing/2014/main" val="10002"/>
+                  </a:ext>
+                </a:extLst>
+              </a:tr>
+              <a:tr h="777240">
+                <a:tc>
+                  <a:txBody>
+                    <a:bodyPr/>
+                    <a:lstStyle/>
+                    <a:p>
+                      <a:pPr marL="0" indent="0">
+                        <a:buNone/>
+                      </a:pPr>
+                      <a:r>
+                        <a:rPr lang="en-US" sz="1800" b="1" dirty="0">
+                          <a:solidFill>
+                            <a:srgbClr val="1F4E79"/>
+                          </a:solidFill>
+                          <a:latin typeface="Calibri" pitchFamily="34" charset="0"/>
+                          <a:ea typeface="Calibri" pitchFamily="34" charset="-122"/>
+                          <a:cs typeface="Calibri" pitchFamily="34" charset="-120"/>
+                        </a:rPr>
+                        <a:t>3  </a:t>
+                      </a:r>
+                      <a:r>
+                        <a:rPr lang="en-US" sz="1200" b="1" dirty="0">
+                          <a:solidFill>
+                            <a:srgbClr val="262626"/>
+                          </a:solidFill>
+                          <a:latin typeface="Calibri" pitchFamily="34" charset="0"/>
+                          <a:ea typeface="Calibri" pitchFamily="34" charset="-122"/>
+                          <a:cs typeface="Calibri" pitchFamily="34" charset="-120"/>
+                        </a:rPr>
+                        <a:t>Better display of results</a:t>
+                      </a:r>
+                      <a:endParaRPr lang="en-US" sz="1200" dirty="0">
+                        <a:latin typeface="Calibri" charset="0"/>
+                        <a:ea typeface="Calibri" charset="0"/>
+                        <a:cs typeface="Calibri" charset="0"/>
+                      </a:endParaRPr>
+                    </a:p>
+                  </a:txBody>
+                  <a:tcPr marT="54864" marB="54864" anchor="ctr">
+                    <a:lnL w="9525" cap="flat" cmpd="sng" algn="ctr">
+                      <a:solidFill>
+                        <a:srgbClr val="D0D7E2"/>
+                      </a:solidFill>
+                      <a:prstDash val="solid"/>
+                      <a:round/>
+                      <a:headEnd type="none" w="med" len="med"/>
+                      <a:tailEnd type="none" w="med" len="med"/>
+                    </a:lnL>
+                    <a:lnR w="9525" cap="flat" cmpd="sng" algn="ctr">
+                      <a:solidFill>
+                        <a:srgbClr val="D0D7E2"/>
+                      </a:solidFill>
+                      <a:prstDash val="solid"/>
+                      <a:round/>
+                      <a:headEnd type="none" w="med" len="med"/>
+                      <a:tailEnd type="none" w="med" len="med"/>
+                    </a:lnR>
+                    <a:lnT w="9525" cap="flat" cmpd="sng" algn="ctr">
+                      <a:solidFill>
+                        <a:srgbClr val="D0D7E2"/>
+                      </a:solidFill>
+                      <a:prstDash val="solid"/>
+                      <a:round/>
+                      <a:headEnd type="none" w="med" len="med"/>
+                      <a:tailEnd type="none" w="med" len="med"/>
+                    </a:lnT>
+                    <a:lnB w="9525" cap="flat" cmpd="sng" algn="ctr">
+                      <a:solidFill>
+                        <a:srgbClr val="D0D7E2"/>
+                      </a:solidFill>
+                      <a:prstDash val="solid"/>
+                      <a:round/>
+                      <a:headEnd type="none" w="med" len="med"/>
+                      <a:tailEnd type="none" w="med" len="med"/>
+                    </a:lnB>
+                    <a:solidFill>
+                      <a:srgbClr val="FFFFFF"/>
+                    </a:solidFill>
+                  </a:tcPr>
+                </a:tc>
+                <a:tc>
+                  <a:txBody>
+                    <a:bodyPr/>
+                    <a:lstStyle/>
+                    <a:p>
+                      <a:pPr marL="0" indent="0">
+                        <a:buNone/>
+                      </a:pPr>
+                      <a:r>
+                        <a:rPr lang="en-US" sz="1200" dirty="0">
+                          <a:solidFill>
+                            <a:srgbClr val="262626"/>
+                          </a:solidFill>
+                          <a:latin typeface="Calibri" pitchFamily="34" charset="0"/>
+                          <a:ea typeface="Calibri" pitchFamily="34" charset="-122"/>
+                          <a:cs typeface="Calibri" pitchFamily="34" charset="-120"/>
+                        </a:rPr>
+                        <a:t>The Experience Layer shows structured summaries instead of plain chat text</a:t>
+                      </a:r>
+                      <a:endParaRPr lang="en-US" sz="1200" dirty="0">
+                        <a:latin typeface="Calibri" charset="0"/>
+                        <a:ea typeface="Calibri" charset="0"/>
+                        <a:cs typeface="Calibri" charset="0"/>
+                      </a:endParaRPr>
+                    </a:p>
+                  </a:txBody>
+                  <a:tcPr marT="54864" marB="54864" anchor="ctr">
+                    <a:lnL w="9525" cap="flat" cmpd="sng" algn="ctr">
+                      <a:solidFill>
+                        <a:srgbClr val="D0D7E2"/>
+                      </a:solidFill>
+                      <a:prstDash val="solid"/>
+                      <a:round/>
+                      <a:headEnd type="none" w="med" len="med"/>
+                      <a:tailEnd type="none" w="med" len="med"/>
+                    </a:lnL>
+                    <a:lnR w="9525" cap="flat" cmpd="sng" algn="ctr">
+                      <a:solidFill>
+                        <a:srgbClr val="D0D7E2"/>
+                      </a:solidFill>
+                      <a:prstDash val="solid"/>
+                      <a:round/>
+                      <a:headEnd type="none" w="med" len="med"/>
+                      <a:tailEnd type="none" w="med" len="med"/>
+                    </a:lnR>
+                    <a:lnT w="9525" cap="flat" cmpd="sng" algn="ctr">
+                      <a:solidFill>
+                        <a:srgbClr val="D0D7E2"/>
+                      </a:solidFill>
+                      <a:prstDash val="solid"/>
+                      <a:round/>
+                      <a:headEnd type="none" w="med" len="med"/>
+                      <a:tailEnd type="none" w="med" len="med"/>
+                    </a:lnT>
+                    <a:lnB w="9525" cap="flat" cmpd="sng" algn="ctr">
+                      <a:solidFill>
+                        <a:srgbClr val="D0D7E2"/>
+                      </a:solidFill>
+                      <a:prstDash val="solid"/>
+                      <a:round/>
+                      <a:headEnd type="none" w="med" len="med"/>
+                      <a:tailEnd type="none" w="med" len="med"/>
+                    </a:lnB>
+                    <a:solidFill>
+                      <a:srgbClr val="FFFFFF"/>
+                    </a:solidFill>
+                  </a:tcPr>
+                </a:tc>
+                <a:tc>
+                  <a:txBody>
+                    <a:bodyPr/>
+                    <a:lstStyle/>
+                    <a:p>
+                      <a:pPr marL="0" indent="0">
+                        <a:buNone/>
+                      </a:pPr>
+                      <a:r>
+                        <a:rPr lang="en-US" sz="1200" b="1" dirty="0">
+                          <a:solidFill>
+                            <a:srgbClr val="1F4E79"/>
+                          </a:solidFill>
+                          <a:latin typeface="Calibri" pitchFamily="34" charset="0"/>
+                          <a:ea typeface="Calibri" pitchFamily="34" charset="-122"/>
+                          <a:cs typeface="Calibri" pitchFamily="34" charset="-120"/>
+                        </a:rPr>
+                        <a:t>Record, PDF and log stay the system of record</a:t>
+                      </a:r>
+                      <a:endParaRPr lang="en-US" sz="1200" dirty="0">
+                        <a:latin typeface="Calibri" charset="0"/>
+                        <a:ea typeface="Calibri" charset="0"/>
+                        <a:cs typeface="Calibri" charset="0"/>
+                      </a:endParaRPr>
+                    </a:p>
+                  </a:txBody>
+                  <a:tcPr marT="54864" marB="54864" anchor="ctr">
+                    <a:lnL w="9525" cap="flat" cmpd="sng" algn="ctr">
+                      <a:solidFill>
+                        <a:srgbClr val="D0D7E2"/>
+                      </a:solidFill>
+                      <a:prstDash val="solid"/>
+                      <a:round/>
+                      <a:headEnd type="none" w="med" len="med"/>
+                      <a:tailEnd type="none" w="med" len="med"/>
+                    </a:lnL>
+                    <a:lnR w="9525" cap="flat" cmpd="sng" algn="ctr">
+                      <a:solidFill>
+                        <a:srgbClr val="D0D7E2"/>
+                      </a:solidFill>
+                      <a:prstDash val="solid"/>
+                      <a:round/>
+                      <a:headEnd type="none" w="med" len="med"/>
+                      <a:tailEnd type="none" w="med" len="med"/>
+                    </a:lnR>
+                    <a:lnT w="9525" cap="flat" cmpd="sng" algn="ctr">
+                      <a:solidFill>
+                        <a:srgbClr val="D0D7E2"/>
+                      </a:solidFill>
+                      <a:prstDash val="solid"/>
+                      <a:round/>
+                      <a:headEnd type="none" w="med" len="med"/>
+                      <a:tailEnd type="none" w="med" len="med"/>
+                    </a:lnT>
+                    <a:lnB w="9525" cap="flat" cmpd="sng" algn="ctr">
+                      <a:solidFill>
+                        <a:srgbClr val="D0D7E2"/>
+                      </a:solidFill>
+                      <a:prstDash val="solid"/>
+                      <a:round/>
+                      <a:headEnd type="none" w="med" len="med"/>
+                      <a:tailEnd type="none" w="med" len="med"/>
+                    </a:lnB>
+                    <a:solidFill>
+                      <a:srgbClr val="FFFFFF"/>
+                    </a:solidFill>
+                  </a:tcPr>
+                </a:tc>
+                <a:tc>
+                  <a:txBody>
+                    <a:bodyPr/>
+                    <a:lstStyle/>
+                    <a:p>
+                      <a:pPr marL="0" indent="0">
+                        <a:buNone/>
+                      </a:pPr>
+                      <a:r>
+                        <a:rPr lang="en-US" sz="1200" dirty="0">
+                          <a:solidFill>
+                            <a:srgbClr val="262626"/>
+                          </a:solidFill>
+                          <a:latin typeface="Calibri" pitchFamily="34" charset="0"/>
+                          <a:ea typeface="Calibri" pitchFamily="34" charset="-122"/>
+                          <a:cs typeface="Calibri" pitchFamily="34" charset="-120"/>
+                        </a:rPr>
+                        <a:t>Does it fix trimmed or replayed output</a:t>
+                      </a:r>
+                      <a:endParaRPr lang="en-US" sz="1200" dirty="0">
+                        <a:latin typeface="Calibri" charset="0"/>
+                        <a:ea typeface="Calibri" charset="0"/>
+                        <a:cs typeface="Calibri" charset="0"/>
+                      </a:endParaRPr>
+                    </a:p>
+                  </a:txBody>
+                  <a:tcPr marT="54864" marB="54864" anchor="ctr">
+                    <a:lnL w="9525" cap="flat" cmpd="sng" algn="ctr">
+                      <a:solidFill>
+                        <a:srgbClr val="D0D7E2"/>
+                      </a:solidFill>
+                      <a:prstDash val="solid"/>
+                      <a:round/>
+                      <a:headEnd type="none" w="med" len="med"/>
+                      <a:tailEnd type="none" w="med" len="med"/>
+                    </a:lnL>
+                    <a:lnR w="9525" cap="flat" cmpd="sng" algn="ctr">
+                      <a:solidFill>
+                        <a:srgbClr val="D0D7E2"/>
+                      </a:solidFill>
+                      <a:prstDash val="solid"/>
+                      <a:round/>
+                      <a:headEnd type="none" w="med" len="med"/>
+                      <a:tailEnd type="none" w="med" len="med"/>
+                    </a:lnR>
+                    <a:lnT w="9525" cap="flat" cmpd="sng" algn="ctr">
+                      <a:solidFill>
+                        <a:srgbClr val="D0D7E2"/>
+                      </a:solidFill>
+                      <a:prstDash val="solid"/>
+                      <a:round/>
+                      <a:headEnd type="none" w="med" len="med"/>
+                      <a:tailEnd type="none" w="med" len="med"/>
+                    </a:lnT>
+                    <a:lnB w="9525" cap="flat" cmpd="sng" algn="ctr">
+                      <a:solidFill>
+                        <a:srgbClr val="D0D7E2"/>
+                      </a:solidFill>
+                      <a:prstDash val="solid"/>
+                      <a:round/>
+                      <a:headEnd type="none" w="med" len="med"/>
+                      <a:tailEnd type="none" w="med" len="med"/>
+                    </a:lnB>
+                    <a:solidFill>
+                      <a:srgbClr val="FFFFFF"/>
+                    </a:solidFill>
+                  </a:tcPr>
+                </a:tc>
+                <a:extLst>
+                  <a:ext uri="{0D108BD9-81ED-4DB2-BD59-A6C34878D82A}">
+                    <a16:rowId xmlns:a16="http://schemas.microsoft.com/office/drawing/2014/main" val="10003"/>
+                  </a:ext>
+                </a:extLst>
+              </a:tr>
+              <a:tr h="777240">
+                <a:tc>
+                  <a:txBody>
+                    <a:bodyPr/>
+                    <a:lstStyle/>
+                    <a:p>
+                      <a:pPr marL="0" indent="0">
+                        <a:buNone/>
+                      </a:pPr>
+                      <a:r>
+                        <a:rPr lang="en-US" sz="1800" b="1" dirty="0">
+                          <a:solidFill>
+                            <a:srgbClr val="1F4E79"/>
+                          </a:solidFill>
+                          <a:latin typeface="Calibri" pitchFamily="34" charset="0"/>
+                          <a:ea typeface="Calibri" pitchFamily="34" charset="-122"/>
+                          <a:cs typeface="Calibri" pitchFamily="34" charset="-120"/>
+                        </a:rPr>
+                        <a:t>4  </a:t>
+                      </a:r>
+                      <a:r>
+                        <a:rPr lang="en-US" sz="1200" b="1" dirty="0">
+                          <a:solidFill>
+                            <a:srgbClr val="262626"/>
+                          </a:solidFill>
+                          <a:latin typeface="Calibri" pitchFamily="34" charset="0"/>
+                          <a:ea typeface="Calibri" pitchFamily="34" charset="-122"/>
+                          <a:cs typeface="Calibri" pitchFamily="34" charset="-120"/>
+                        </a:rPr>
+                        <a:t>Built-in monitoring</a:t>
+                      </a:r>
+                      <a:endParaRPr lang="en-US" sz="1200" dirty="0">
+                        <a:latin typeface="Calibri" charset="0"/>
+                        <a:ea typeface="Calibri" charset="0"/>
+                        <a:cs typeface="Calibri" charset="0"/>
+                      </a:endParaRPr>
+                    </a:p>
+                  </a:txBody>
+                  <a:tcPr marT="54864" marB="54864" anchor="ctr">
+                    <a:lnL w="9525" cap="flat" cmpd="sng" algn="ctr">
+                      <a:solidFill>
+                        <a:srgbClr val="D0D7E2"/>
+                      </a:solidFill>
+                      <a:prstDash val="solid"/>
+                      <a:round/>
+                      <a:headEnd type="none" w="med" len="med"/>
+                      <a:tailEnd type="none" w="med" len="med"/>
+                    </a:lnL>
+                    <a:lnR w="9525" cap="flat" cmpd="sng" algn="ctr">
+                      <a:solidFill>
+                        <a:srgbClr val="D0D7E2"/>
+                      </a:solidFill>
+                      <a:prstDash val="solid"/>
+                      <a:round/>
+                      <a:headEnd type="none" w="med" len="med"/>
+                      <a:tailEnd type="none" w="med" len="med"/>
+                    </a:lnR>
+                    <a:lnT w="9525" cap="flat" cmpd="sng" algn="ctr">
+                      <a:solidFill>
+                        <a:srgbClr val="D0D7E2"/>
+                      </a:solidFill>
+                      <a:prstDash val="solid"/>
+                      <a:round/>
+                      <a:headEnd type="none" w="med" len="med"/>
+                      <a:tailEnd type="none" w="med" len="med"/>
+                    </a:lnT>
+                    <a:lnB w="9525" cap="flat" cmpd="sng" algn="ctr">
+                      <a:solidFill>
+                        <a:srgbClr val="D0D7E2"/>
+                      </a:solidFill>
+                      <a:prstDash val="solid"/>
+                      <a:round/>
+                      <a:headEnd type="none" w="med" len="med"/>
+                      <a:tailEnd type="none" w="med" len="med"/>
+                    </a:lnB>
+                    <a:solidFill>
+                      <a:srgbClr val="EAF0F7"/>
+                    </a:solidFill>
+                  </a:tcPr>
+                </a:tc>
+                <a:tc>
+                  <a:txBody>
+                    <a:bodyPr/>
+                    <a:lstStyle/>
+                    <a:p>
+                      <a:pPr marL="0" indent="0">
+                        <a:buNone/>
+                      </a:pPr>
+                      <a:r>
+                        <a:rPr lang="en-US" sz="1200" dirty="0">
+                          <a:solidFill>
+                            <a:srgbClr val="262626"/>
+                          </a:solidFill>
+                          <a:latin typeface="Calibri" pitchFamily="34" charset="0"/>
+                          <a:ea typeface="Calibri" pitchFamily="34" charset="-122"/>
+                          <a:cs typeface="Calibri" pitchFamily="34" charset="-120"/>
+                        </a:rPr>
+                        <a:t>Add Observability, Session Tracing and Testing Center for the agent side</a:t>
+                      </a:r>
+                      <a:endParaRPr lang="en-US" sz="1200" dirty="0">
+                        <a:latin typeface="Calibri" charset="0"/>
+                        <a:ea typeface="Calibri" charset="0"/>
+                        <a:cs typeface="Calibri" charset="0"/>
+                      </a:endParaRPr>
+                    </a:p>
+                  </a:txBody>
+                  <a:tcPr marT="54864" marB="54864" anchor="ctr">
+                    <a:lnL w="9525" cap="flat" cmpd="sng" algn="ctr">
+                      <a:solidFill>
+                        <a:srgbClr val="D0D7E2"/>
+                      </a:solidFill>
+                      <a:prstDash val="solid"/>
+                      <a:round/>
+                      <a:headEnd type="none" w="med" len="med"/>
+                      <a:tailEnd type="none" w="med" len="med"/>
+                    </a:lnL>
+                    <a:lnR w="9525" cap="flat" cmpd="sng" algn="ctr">
+                      <a:solidFill>
+                        <a:srgbClr val="D0D7E2"/>
+                      </a:solidFill>
+                      <a:prstDash val="solid"/>
+                      <a:round/>
+                      <a:headEnd type="none" w="med" len="med"/>
+                      <a:tailEnd type="none" w="med" len="med"/>
+                    </a:lnR>
+                    <a:lnT w="9525" cap="flat" cmpd="sng" algn="ctr">
+                      <a:solidFill>
+                        <a:srgbClr val="D0D7E2"/>
+                      </a:solidFill>
+                      <a:prstDash val="solid"/>
+                      <a:round/>
+                      <a:headEnd type="none" w="med" len="med"/>
+                      <a:tailEnd type="none" w="med" len="med"/>
+                    </a:lnT>
+                    <a:lnB w="9525" cap="flat" cmpd="sng" algn="ctr">
+                      <a:solidFill>
+                        <a:srgbClr val="D0D7E2"/>
+                      </a:solidFill>
+                      <a:prstDash val="solid"/>
+                      <a:round/>
+                      <a:headEnd type="none" w="med" len="med"/>
+                      <a:tailEnd type="none" w="med" len="med"/>
+                    </a:lnB>
+                    <a:solidFill>
+                      <a:srgbClr val="EAF0F7"/>
+                    </a:solidFill>
+                  </a:tcPr>
+                </a:tc>
+                <a:tc>
+                  <a:txBody>
+                    <a:bodyPr/>
+                    <a:lstStyle/>
+                    <a:p>
+                      <a:pPr marL="0" indent="0">
+                        <a:buNone/>
+                      </a:pPr>
+                      <a:r>
+                        <a:rPr lang="en-US" sz="1200" b="1" dirty="0">
+                          <a:solidFill>
+                            <a:srgbClr val="1F4E79"/>
+                          </a:solidFill>
+                          <a:latin typeface="Calibri" pitchFamily="34" charset="0"/>
+                          <a:ea typeface="Calibri" pitchFamily="34" charset="-122"/>
+                          <a:cs typeface="Calibri" pitchFamily="34" charset="-120"/>
+                        </a:rPr>
+                        <a:t>AI_Generation_Log__c still records every AI request</a:t>
+                      </a:r>
+                      <a:endParaRPr lang="en-US" sz="1200" dirty="0">
+                        <a:latin typeface="Calibri" charset="0"/>
+                        <a:ea typeface="Calibri" charset="0"/>
+                        <a:cs typeface="Calibri" charset="0"/>
+                      </a:endParaRPr>
+                    </a:p>
+                  </a:txBody>
+                  <a:tcPr marT="54864" marB="54864" anchor="ctr">
+                    <a:lnL w="9525" cap="flat" cmpd="sng" algn="ctr">
+                      <a:solidFill>
+                        <a:srgbClr val="D0D7E2"/>
+                      </a:solidFill>
+                      <a:prstDash val="solid"/>
+                      <a:round/>
+                      <a:headEnd type="none" w="med" len="med"/>
+                      <a:tailEnd type="none" w="med" len="med"/>
+                    </a:lnL>
+                    <a:lnR w="9525" cap="flat" cmpd="sng" algn="ctr">
+                      <a:solidFill>
+                        <a:srgbClr val="D0D7E2"/>
+                      </a:solidFill>
+                      <a:prstDash val="solid"/>
+                      <a:round/>
+                      <a:headEnd type="none" w="med" len="med"/>
+                      <a:tailEnd type="none" w="med" len="med"/>
+                    </a:lnR>
+                    <a:lnT w="9525" cap="flat" cmpd="sng" algn="ctr">
+                      <a:solidFill>
+                        <a:srgbClr val="D0D7E2"/>
+                      </a:solidFill>
+                      <a:prstDash val="solid"/>
+                      <a:round/>
+                      <a:headEnd type="none" w="med" len="med"/>
+                      <a:tailEnd type="none" w="med" len="med"/>
+                    </a:lnT>
+                    <a:lnB w="9525" cap="flat" cmpd="sng" algn="ctr">
+                      <a:solidFill>
+                        <a:srgbClr val="D0D7E2"/>
+                      </a:solidFill>
+                      <a:prstDash val="solid"/>
+                      <a:round/>
+                      <a:headEnd type="none" w="med" len="med"/>
+                      <a:tailEnd type="none" w="med" len="med"/>
+                    </a:lnB>
+                    <a:solidFill>
+                      <a:srgbClr val="EAF0F7"/>
+                    </a:solidFill>
+                  </a:tcPr>
+                </a:tc>
+                <a:tc>
+                  <a:txBody>
+                    <a:bodyPr/>
+                    <a:lstStyle/>
+                    <a:p>
+                      <a:pPr marL="0" indent="0">
+                        <a:buNone/>
+                      </a:pPr>
+                      <a:r>
+                        <a:rPr lang="en-US" sz="1200" dirty="0">
+                          <a:solidFill>
+                            <a:srgbClr val="262626"/>
+                          </a:solidFill>
+                          <a:latin typeface="Calibri" pitchFamily="34" charset="0"/>
+                          <a:ea typeface="Calibri" pitchFamily="34" charset="-122"/>
+                          <a:cs typeface="Calibri" pitchFamily="34" charset="-120"/>
+                        </a:rPr>
+                        <a:t>Add structured log fields, incl. interface used</a:t>
+                      </a:r>
+                      <a:endParaRPr lang="en-US" sz="1200" dirty="0">
+                        <a:latin typeface="Calibri" charset="0"/>
+                        <a:ea typeface="Calibri" charset="0"/>
+                        <a:cs typeface="Calibri" charset="0"/>
+                      </a:endParaRPr>
+                    </a:p>
+                  </a:txBody>
+                  <a:tcPr marT="54864" marB="54864" anchor="ctr">
+                    <a:lnL w="9525" cap="flat" cmpd="sng" algn="ctr">
+                      <a:solidFill>
+                        <a:srgbClr val="D0D7E2"/>
+                      </a:solidFill>
+                      <a:prstDash val="solid"/>
+                      <a:round/>
+                      <a:headEnd type="none" w="med" len="med"/>
+                      <a:tailEnd type="none" w="med" len="med"/>
+                    </a:lnL>
+                    <a:lnR w="9525" cap="flat" cmpd="sng" algn="ctr">
+                      <a:solidFill>
+                        <a:srgbClr val="D0D7E2"/>
+                      </a:solidFill>
+                      <a:prstDash val="solid"/>
+                      <a:round/>
+                      <a:headEnd type="none" w="med" len="med"/>
+                      <a:tailEnd type="none" w="med" len="med"/>
+                    </a:lnR>
+                    <a:lnT w="9525" cap="flat" cmpd="sng" algn="ctr">
+                      <a:solidFill>
+                        <a:srgbClr val="D0D7E2"/>
+                      </a:solidFill>
+                      <a:prstDash val="solid"/>
+                      <a:round/>
+                      <a:headEnd type="none" w="med" len="med"/>
+                      <a:tailEnd type="none" w="med" len="med"/>
+                    </a:lnT>
+                    <a:lnB w="9525" cap="flat" cmpd="sng" algn="ctr">
+                      <a:solidFill>
+                        <a:srgbClr val="D0D7E2"/>
+                      </a:solidFill>
+                      <a:prstDash val="solid"/>
+                      <a:round/>
+                      <a:headEnd type="none" w="med" len="med"/>
+                      <a:tailEnd type="none" w="med" len="med"/>
+                    </a:lnB>
+                    <a:solidFill>
+                      <a:srgbClr val="EAF0F7"/>
+                    </a:solidFill>
+                  </a:tcPr>
+                </a:tc>
+                <a:extLst>
+                  <a:ext uri="{0D108BD9-81ED-4DB2-BD59-A6C34878D82A}">
+                    <a16:rowId xmlns:a16="http://schemas.microsoft.com/office/drawing/2014/main" val="10004"/>
+                  </a:ext>
+                </a:extLst>
+              </a:tr>
+              <a:tr h="731520">
+                <a:tc>
+                  <a:txBody>
+                    <a:bodyPr/>
+                    <a:lstStyle/>
+                    <a:p>
+                      <a:pPr marL="0" indent="0">
+                        <a:buNone/>
+                      </a:pPr>
+                      <a:r>
+                        <a:rPr lang="en-US" sz="1800" b="1" dirty="0">
+                          <a:solidFill>
+                            <a:srgbClr val="1F4E79"/>
+                          </a:solidFill>
+                          <a:latin typeface="Calibri" pitchFamily="34" charset="0"/>
+                          <a:ea typeface="Calibri" pitchFamily="34" charset="-122"/>
+                          <a:cs typeface="Calibri" pitchFamily="34" charset="-120"/>
+                        </a:rPr>
+                        <a:t>5  </a:t>
+                      </a:r>
+                      <a:r>
+                        <a:rPr lang="en-US" sz="1200" b="1" dirty="0">
+                          <a:solidFill>
+                            <a:srgbClr val="262626"/>
+                          </a:solidFill>
+                          <a:latin typeface="Calibri" pitchFamily="34" charset="0"/>
+                          <a:ea typeface="Calibri" pitchFamily="34" charset="-122"/>
+                          <a:cs typeface="Calibri" pitchFamily="34" charset="-120"/>
+                        </a:rPr>
+                        <a:t>Cost per channel</a:t>
+                      </a:r>
+                      <a:endParaRPr lang="en-US" sz="1200" dirty="0">
+                        <a:latin typeface="Calibri" charset="0"/>
+                        <a:ea typeface="Calibri" charset="0"/>
+                        <a:cs typeface="Calibri" charset="0"/>
+                      </a:endParaRPr>
+                    </a:p>
+                  </a:txBody>
+                  <a:tcPr marT="54864" marB="54864" anchor="ctr">
+                    <a:lnL w="9525" cap="flat" cmpd="sng" algn="ctr">
+                      <a:solidFill>
+                        <a:srgbClr val="D0D7E2"/>
+                      </a:solidFill>
+                      <a:prstDash val="solid"/>
+                      <a:round/>
+                      <a:headEnd type="none" w="med" len="med"/>
+                      <a:tailEnd type="none" w="med" len="med"/>
+                    </a:lnL>
+                    <a:lnR w="9525" cap="flat" cmpd="sng" algn="ctr">
+                      <a:solidFill>
+                        <a:srgbClr val="D0D7E2"/>
+                      </a:solidFill>
+                      <a:prstDash val="solid"/>
+                      <a:round/>
+                      <a:headEnd type="none" w="med" len="med"/>
+                      <a:tailEnd type="none" w="med" len="med"/>
+                    </a:lnR>
+                    <a:lnT w="9525" cap="flat" cmpd="sng" algn="ctr">
+                      <a:solidFill>
+                        <a:srgbClr val="D0D7E2"/>
+                      </a:solidFill>
+                      <a:prstDash val="solid"/>
+                      <a:round/>
+                      <a:headEnd type="none" w="med" len="med"/>
+                      <a:tailEnd type="none" w="med" len="med"/>
+                    </a:lnT>
+                    <a:lnB w="9525" cap="flat" cmpd="sng" algn="ctr">
+                      <a:solidFill>
+                        <a:srgbClr val="D0D7E2"/>
+                      </a:solidFill>
+                      <a:prstDash val="solid"/>
+                      <a:round/>
+                      <a:headEnd type="none" w="med" len="med"/>
+                      <a:tailEnd type="none" w="med" len="med"/>
+                    </a:lnB>
+                    <a:solidFill>
+                      <a:srgbClr val="FFFFFF"/>
+                    </a:solidFill>
+                  </a:tcPr>
+                </a:tc>
+                <a:tc>
+                  <a:txBody>
+                    <a:bodyPr/>
+                    <a:lstStyle/>
+                    <a:p>
+                      <a:pPr marL="0" indent="0">
+                        <a:buNone/>
+                      </a:pPr>
+                      <a:r>
+                        <a:rPr lang="en-US" sz="1200" dirty="0">
+                          <a:solidFill>
+                            <a:srgbClr val="262626"/>
+                          </a:solidFill>
+                          <a:latin typeface="Calibri" pitchFamily="34" charset="0"/>
+                          <a:ea typeface="Calibri" pitchFamily="34" charset="-122"/>
+                          <a:cs typeface="Calibri" pitchFamily="34" charset="-120"/>
+                        </a:rPr>
+                        <a:t>Every interface that calls the agent uses requests</a:t>
+                      </a:r>
+                      <a:endParaRPr lang="en-US" sz="1200" dirty="0">
+                        <a:latin typeface="Calibri" charset="0"/>
+                        <a:ea typeface="Calibri" charset="0"/>
+                        <a:cs typeface="Calibri" charset="0"/>
+                      </a:endParaRPr>
+                    </a:p>
+                  </a:txBody>
+                  <a:tcPr marT="54864" marB="54864" anchor="ctr">
+                    <a:lnL w="9525" cap="flat" cmpd="sng" algn="ctr">
+                      <a:solidFill>
+                        <a:srgbClr val="D0D7E2"/>
+                      </a:solidFill>
+                      <a:prstDash val="solid"/>
+                      <a:round/>
+                      <a:headEnd type="none" w="med" len="med"/>
+                      <a:tailEnd type="none" w="med" len="med"/>
+                    </a:lnL>
+                    <a:lnR w="9525" cap="flat" cmpd="sng" algn="ctr">
+                      <a:solidFill>
+                        <a:srgbClr val="D0D7E2"/>
+                      </a:solidFill>
+                      <a:prstDash val="solid"/>
+                      <a:round/>
+                      <a:headEnd type="none" w="med" len="med"/>
+                      <a:tailEnd type="none" w="med" len="med"/>
+                    </a:lnR>
+                    <a:lnT w="9525" cap="flat" cmpd="sng" algn="ctr">
+                      <a:solidFill>
+                        <a:srgbClr val="D0D7E2"/>
+                      </a:solidFill>
+                      <a:prstDash val="solid"/>
+                      <a:round/>
+                      <a:headEnd type="none" w="med" len="med"/>
+                      <a:tailEnd type="none" w="med" len="med"/>
+                    </a:lnT>
+                    <a:lnB w="9525" cap="flat" cmpd="sng" algn="ctr">
+                      <a:solidFill>
+                        <a:srgbClr val="D0D7E2"/>
+                      </a:solidFill>
+                      <a:prstDash val="solid"/>
+                      <a:round/>
+                      <a:headEnd type="none" w="med" len="med"/>
+                      <a:tailEnd type="none" w="med" len="med"/>
+                    </a:lnB>
+                    <a:solidFill>
+                      <a:srgbClr val="FFFFFF"/>
+                    </a:solidFill>
+                  </a:tcPr>
+                </a:tc>
+                <a:tc>
+                  <a:txBody>
+                    <a:bodyPr/>
+                    <a:lstStyle/>
+                    <a:p>
+                      <a:pPr marL="0" indent="0">
+                        <a:buNone/>
+                      </a:pPr>
+                      <a:r>
+                        <a:rPr lang="en-US" sz="1200" b="1" dirty="0">
+                          <a:solidFill>
+                            <a:srgbClr val="1F4E79"/>
+                          </a:solidFill>
+                          <a:latin typeface="Calibri" pitchFamily="34" charset="0"/>
+                          <a:ea typeface="Calibri" pitchFamily="34" charset="-122"/>
+                          <a:cs typeface="Calibri" pitchFamily="34" charset="-120"/>
+                        </a:rPr>
+                        <a:t>One retry only; failures caught before the AI call</a:t>
+                      </a:r>
+                      <a:endParaRPr lang="en-US" sz="1200" dirty="0">
+                        <a:latin typeface="Calibri" charset="0"/>
+                        <a:ea typeface="Calibri" charset="0"/>
+                        <a:cs typeface="Calibri" charset="0"/>
+                      </a:endParaRPr>
+                    </a:p>
+                  </a:txBody>
+                  <a:tcPr marT="54864" marB="54864" anchor="ctr">
+                    <a:lnL w="9525" cap="flat" cmpd="sng" algn="ctr">
+                      <a:solidFill>
+                        <a:srgbClr val="D0D7E2"/>
+                      </a:solidFill>
+                      <a:prstDash val="solid"/>
+                      <a:round/>
+                      <a:headEnd type="none" w="med" len="med"/>
+                      <a:tailEnd type="none" w="med" len="med"/>
+                    </a:lnL>
+                    <a:lnR w="9525" cap="flat" cmpd="sng" algn="ctr">
+                      <a:solidFill>
+                        <a:srgbClr val="D0D7E2"/>
+                      </a:solidFill>
+                      <a:prstDash val="solid"/>
+                      <a:round/>
+                      <a:headEnd type="none" w="med" len="med"/>
+                      <a:tailEnd type="none" w="med" len="med"/>
+                    </a:lnR>
+                    <a:lnT w="9525" cap="flat" cmpd="sng" algn="ctr">
+                      <a:solidFill>
+                        <a:srgbClr val="D0D7E2"/>
+                      </a:solidFill>
+                      <a:prstDash val="solid"/>
+                      <a:round/>
+                      <a:headEnd type="none" w="med" len="med"/>
+                      <a:tailEnd type="none" w="med" len="med"/>
+                    </a:lnT>
+                    <a:lnB w="9525" cap="flat" cmpd="sng" algn="ctr">
+                      <a:solidFill>
+                        <a:srgbClr val="D0D7E2"/>
+                      </a:solidFill>
+                      <a:prstDash val="solid"/>
+                      <a:round/>
+                      <a:headEnd type="none" w="med" len="med"/>
+                      <a:tailEnd type="none" w="med" len="med"/>
+                    </a:lnB>
+                    <a:solidFill>
+                      <a:srgbClr val="FFFFFF"/>
+                    </a:solidFill>
+                  </a:tcPr>
+                </a:tc>
+                <a:tc>
+                  <a:txBody>
+                    <a:bodyPr/>
+                    <a:lstStyle/>
+                    <a:p>
+                      <a:pPr marL="0" indent="0">
+                        <a:buNone/>
+                      </a:pPr>
+                      <a:r>
+                        <a:rPr lang="en-US" sz="1200" dirty="0">
+                          <a:solidFill>
+                            <a:srgbClr val="262626"/>
+                          </a:solidFill>
+                          <a:latin typeface="Calibri" pitchFamily="34" charset="0"/>
+                          <a:ea typeface="Calibri" pitchFamily="34" charset="-122"/>
+                          <a:cs typeface="Calibri" pitchFamily="34" charset="-120"/>
+                        </a:rPr>
+                        <a:t>Track request use per interface against budget</a:t>
+                      </a:r>
+                      <a:endParaRPr lang="en-US" sz="1200" dirty="0">
+                        <a:latin typeface="Calibri" charset="0"/>
+                        <a:ea typeface="Calibri" charset="0"/>
+                        <a:cs typeface="Calibri" charset="0"/>
+                      </a:endParaRPr>
+                    </a:p>
+                  </a:txBody>
+                  <a:tcPr marT="54864" marB="54864" anchor="ctr">
+                    <a:lnL w="9525" cap="flat" cmpd="sng" algn="ctr">
+                      <a:solidFill>
+                        <a:srgbClr val="D0D7E2"/>
+                      </a:solidFill>
+                      <a:prstDash val="solid"/>
+                      <a:round/>
+                      <a:headEnd type="none" w="med" len="med"/>
+                      <a:tailEnd type="none" w="med" len="med"/>
+                    </a:lnL>
+                    <a:lnR w="9525" cap="flat" cmpd="sng" algn="ctr">
+                      <a:solidFill>
+                        <a:srgbClr val="D0D7E2"/>
+                      </a:solidFill>
+                      <a:prstDash val="solid"/>
+                      <a:round/>
+                      <a:headEnd type="none" w="med" len="med"/>
+                      <a:tailEnd type="none" w="med" len="med"/>
+                    </a:lnR>
+                    <a:lnT w="9525" cap="flat" cmpd="sng" algn="ctr">
+                      <a:solidFill>
+                        <a:srgbClr val="D0D7E2"/>
+                      </a:solidFill>
+                      <a:prstDash val="solid"/>
+                      <a:round/>
+                      <a:headEnd type="none" w="med" len="med"/>
+                      <a:tailEnd type="none" w="med" len="med"/>
+                    </a:lnT>
+                    <a:lnB w="9525" cap="flat" cmpd="sng" algn="ctr">
+                      <a:solidFill>
+                        <a:srgbClr val="D0D7E2"/>
+                      </a:solidFill>
+                      <a:prstDash val="solid"/>
+                      <a:round/>
+                      <a:headEnd type="none" w="med" len="med"/>
+                      <a:tailEnd type="none" w="med" len="med"/>
+                    </a:lnB>
+                    <a:solidFill>
+                      <a:srgbClr val="FFFFFF"/>
+                    </a:solidFill>
+                  </a:tcPr>
+                </a:tc>
+                <a:extLst>
+                  <a:ext uri="{0D108BD9-81ED-4DB2-BD59-A6C34878D82A}">
+                    <a16:rowId xmlns:a16="http://schemas.microsoft.com/office/drawing/2014/main" val="10005"/>
+                  </a:ext>
+                </a:extLst>
+              </a:tr>
+            </a:tbl>
+          </a:graphicData>
+        </a:graphic>
+      </p:graphicFrame>
+      <p:sp>
+        <p:nvSpPr>
+          <p:cNvPr id="6" name="Text 3"/>
+          <p:cNvSpPr txBox="1"/>
+          <p:nvPr/>
+        </p:nvSpPr>
+        <p:spPr>
+          <a:xfrm>
+            <a:off x="502920" y="6199632"/>
+            <a:ext cx="10058400" cy="274320"/>
+          </a:xfrm>
+          <a:prstGeom prst="rect">
+            <a:avLst/>
+          </a:prstGeom>
+          <a:noFill/>
+          <a:ln/>
+        </p:spPr>
+        <p:txBody>
+          <a:bodyPr wrap="square" lIns="0" tIns="0" rIns="0" bIns="0" rtlCol="0" anchor="ctr"/>
+          <a:lstStyle/>
+          <a:p>
+            <a:pPr marL="0" indent="0">
+              <a:buNone/>
+            </a:pPr>
+            <a:r>
+              <a:rPr lang="en-US" sz="1100" i="1" dirty="0">
+                <a:solidFill>
+                  <a:srgbClr val="595959"/>
+                </a:solidFill>
+                <a:latin typeface="Calibri" pitchFamily="34" charset="0"/>
+                <a:ea typeface="Calibri" pitchFamily="34" charset="-122"/>
+                <a:cs typeface="Calibri" pitchFamily="34" charset="-120"/>
+              </a:rPr>
+              <a:t>Why the design is ready: every guarantee lives in Salesforce, not in the chat window. Announced 2026; not yet tested in this build.</a:t>
+            </a:r>
+            <a:endParaRPr lang="en-US" sz="1100" dirty="0"/>
+          </a:p>
+        </p:txBody>
+      </p:sp>
+      <p:sp>
+        <p:nvSpPr>
+          <p:cNvPr id="7" name="Text 4"/>
+          <p:cNvSpPr txBox="1"/>
+          <p:nvPr/>
+        </p:nvSpPr>
+        <p:spPr>
+          <a:xfrm>
+            <a:off x="502920" y="6473952"/>
+            <a:ext cx="7315200" cy="274320"/>
+          </a:xfrm>
+          <a:prstGeom prst="rect">
+            <a:avLst/>
+          </a:prstGeom>
+          <a:noFill/>
+          <a:ln/>
+        </p:spPr>
+        <p:txBody>
+          <a:bodyPr wrap="square" lIns="0" tIns="0" rIns="0" bIns="0" rtlCol="0" anchor="ctr"/>
+          <a:lstStyle/>
+          <a:p>
+            <a:pPr marL="0" indent="0">
+              <a:buNone/>
+            </a:pPr>
+            <a:r>
+              <a:rPr lang="en-US" sz="1000" dirty="0">
+                <a:solidFill>
+                  <a:srgbClr val="595959"/>
+                </a:solidFill>
+                <a:latin typeface="Calibri" pitchFamily="34" charset="0"/>
+                <a:ea typeface="Calibri" pitchFamily="34" charset="-122"/>
+                <a:cs typeface="Calibri" pitchFamily="34" charset="-120"/>
+              </a:rPr>
+              <a:t>Agentforce Banking Reference Implementation</a:t>
+            </a:r>
+            <a:endParaRPr lang="en-US" sz="1000" dirty="0"/>
+          </a:p>
+        </p:txBody>
+      </p:sp>
+      <p:sp>
+        <p:nvSpPr>
+          <p:cNvPr id="8" name="Text 5"/>
+          <p:cNvSpPr txBox="1"/>
+          <p:nvPr/>
+        </p:nvSpPr>
+        <p:spPr>
+          <a:xfrm>
+            <a:off x="10698480" y="6473952"/>
+            <a:ext cx="960120" cy="274320"/>
+          </a:xfrm>
+          <a:prstGeom prst="rect">
+            <a:avLst/>
+          </a:prstGeom>
+          <a:noFill/>
+          <a:ln/>
+        </p:spPr>
+        <p:txBody>
+          <a:bodyPr wrap="square" lIns="0" tIns="0" rIns="0" bIns="0" rtlCol="0" anchor="ctr"/>
+          <a:lstStyle/>
+          <a:p>
+            <a:pPr marL="0" indent="0" algn="r">
+              <a:buNone/>
+            </a:pPr>
+            <a:endParaRPr lang="en-US" sz="1000" dirty="0"/>
+          </a:p>
+        </p:txBody>
+      </p:sp>
+    </p:spTree>
+  </p:cSld>
+  <p:clrMapOvr>
+    <a:masterClrMapping/>
+  </p:clrMapOvr>
+</p:sld>
+</file>
+
+<file path=ppt/slides/slide18.xml><?xml version="1.0" encoding="utf-8"?>
 <p:sld xmlns:a="http://schemas.openxmlformats.org/drawingml/2006/main" xmlns:r="http://schemas.openxmlformats.org/officeDocument/2006/relationships" xmlns:p="http://schemas.openxmlformats.org/presentationml/2006/main">
   <p:cSld>
     <p:spTree>
@@ -27507,7 +29592,13 @@
           <p:cNvGraphicFramePr>
             <a:graphicFrameLocks noGrp="1"/>
           </p:cNvGraphicFramePr>
-          <p:nvPr/>
+          <p:nvPr>
+            <p:extLst>
+              <p:ext uri="{D42A27DB-BD31-4B8C-83A1-F6EECF244321}">
+                <p14:modId xmlns:p14="http://schemas.microsoft.com/office/powerpoint/2010/main" val="3255335798"/>
+              </p:ext>
+            </p:extLst>
+          </p:nvPr>
         </p:nvGraphicFramePr>
         <p:xfrm>
           <a:off x="502920" y="1325880"/>
@@ -27923,7 +30014,7 @@
                           <a:ea typeface="Calibri" pitchFamily="34" charset="-122"/>
                           <a:cs typeface="Calibri" pitchFamily="34" charset="-120"/>
                         </a:rPr>
-                        <a:t>Bankers turn rough notes into summaries by hand, late and rushed</a:t>
+                        <a:t>Users turn rough notes into summaries by hand, late and rushed</a:t>
                       </a:r>
                       <a:endParaRPr lang="en-US" sz="1200" dirty="0">
                         <a:latin typeface="Calibri" charset="0"/>
@@ -28059,7 +30150,7 @@
                           <a:ea typeface="Calibri" pitchFamily="34" charset="-122"/>
                           <a:cs typeface="Calibri" pitchFamily="34" charset="-120"/>
                         </a:rPr>
-                        <a:t>Banker time goes back to clients</a:t>
+                        <a:t>User time goes back to clients or other tasks that are not trivial</a:t>
                       </a:r>
                       <a:endParaRPr lang="en-US" sz="1200" dirty="0">
                         <a:latin typeface="Calibri" charset="0"/>
@@ -28349,7 +30440,7 @@
                           <a:ea typeface="Calibri" pitchFamily="34" charset="-122"/>
                           <a:cs typeface="Calibri" pitchFamily="34" charset="-120"/>
                         </a:rPr>
-                        <a:t>Lower client and reputational risk</a:t>
+                        <a:t>Raises discrepancies to user avoiding lower client and reputational risk</a:t>
                       </a:r>
                       <a:endParaRPr lang="en-US" sz="1200" dirty="0">
                         <a:latin typeface="Calibri" charset="0"/>

</xml_diff>